<commit_message>
Apply independent capstone review: pilot prerequisites, chart evidence and metric sensitivity
</commit_message>
<xml_diff>
--- a/deliverables/Tayseer_Executive_Story_Final.pptx
+++ b/deliverables/Tayseer_Executive_Story_Final.pptx
@@ -2,19 +2,19 @@
 <file path=ppt/presentation.xml><?xml version="1.0" encoding="utf-8"?>
 <p:presentation xmlns:p="http://schemas.openxmlformats.org/presentationml/2006/main">
   <p:sldMasterIdLst>
-    <p:sldMasterId xmlns:r="http://schemas.openxmlformats.org/officeDocument/2006/relationships" id="2147483648" r:id="Rb7a11756a1964b04"/>
+    <p:sldMasterId xmlns:r="http://schemas.openxmlformats.org/officeDocument/2006/relationships" id="2147483648" r:id="R80fb10a058ac4ec3"/>
   </p:sldMasterIdLst>
   <p:notesMasterIdLst>
-    <p:notesMasterId xmlns:r="http://schemas.openxmlformats.org/officeDocument/2006/relationships" r:id="R24b3f5088d824856"/>
+    <p:notesMasterId xmlns:r="http://schemas.openxmlformats.org/officeDocument/2006/relationships" r:id="Reb4f4f135c7e4768"/>
   </p:notesMasterIdLst>
   <p:sldIdLst>
-    <p:sldId xmlns:r="http://schemas.openxmlformats.org/officeDocument/2006/relationships" id="256" r:id="R6ec2c3145e0348e9"/>
-    <p:sldId xmlns:r="http://schemas.openxmlformats.org/officeDocument/2006/relationships" id="257" r:id="Rb2a9643b089743ed"/>
-    <p:sldId xmlns:r="http://schemas.openxmlformats.org/officeDocument/2006/relationships" id="258" r:id="R96530008f74e49be"/>
-    <p:sldId xmlns:r="http://schemas.openxmlformats.org/officeDocument/2006/relationships" id="259" r:id="R7dc205c4e68b401d"/>
-    <p:sldId xmlns:r="http://schemas.openxmlformats.org/officeDocument/2006/relationships" id="260" r:id="R56c501ae39f24f08"/>
-    <p:sldId xmlns:r="http://schemas.openxmlformats.org/officeDocument/2006/relationships" id="261" r:id="R09735c6d81a94d7d"/>
-    <p:sldId xmlns:r="http://schemas.openxmlformats.org/officeDocument/2006/relationships" id="262" r:id="R3045bb6b910b4c18"/>
+    <p:sldId xmlns:r="http://schemas.openxmlformats.org/officeDocument/2006/relationships" id="256" r:id="R8b8e0217f6034f02"/>
+    <p:sldId xmlns:r="http://schemas.openxmlformats.org/officeDocument/2006/relationships" id="257" r:id="Rfcfe55276c8c40d7"/>
+    <p:sldId xmlns:r="http://schemas.openxmlformats.org/officeDocument/2006/relationships" id="258" r:id="Rdf157a29358e4619"/>
+    <p:sldId xmlns:r="http://schemas.openxmlformats.org/officeDocument/2006/relationships" id="259" r:id="R1248759c39b84b4a"/>
+    <p:sldId xmlns:r="http://schemas.openxmlformats.org/officeDocument/2006/relationships" id="260" r:id="R004c43fb0a7148f4"/>
+    <p:sldId xmlns:r="http://schemas.openxmlformats.org/officeDocument/2006/relationships" id="261" r:id="R3207b468a0214f3e"/>
+    <p:sldId xmlns:r="http://schemas.openxmlformats.org/officeDocument/2006/relationships" id="262" r:id="R35c3c4aeaf9f45a3"/>
   </p:sldIdLst>
   <p:sldSz cx="12192000" cy="6858000"/>
   <p:notesSz cx="6858000" cy="9144000"/>
@@ -453,7 +453,7 @@
           </a:p>
           <a:p xmlns:a="http://schemas.openxmlformats.org/drawingml/2006/main">
             <a:r>
-              <a:t>BLUF/Ask. 0:00–0:30. State the complete request before any introduction. Approve a SAR 40M envelope, release SAR 10M now for pilots, hold SAR 30M subject to evidence. Big Idea: target the adoption gap with phased funding and validate the metric before scaling.</a:t>
+              <a:t>BLUF/Ask. 0:00–0:30. State the complete request immediately. Approve SAR40M; release initialSAR10M only after approval of metric, baseline, comparison design, service plans and cost; holdSAR30M for review. Big Idea: target the adoption gap with phased funding, validating the metric and demand before any intervention or release.</a:t>
             </a:r>
           </a:p>
           <a:p xmlns:a="http://schemas.openxmlformats.org/drawingml/2006/main">
@@ -768,7 +768,7 @@
           </a:p>
           <a:p xmlns:a="http://schemas.openxmlformats.org/drawingml/2006/main">
             <a:r>
-              <a:t>Evidence. 2:00–4:00. Index = max(65 - regional arithmetic mean, 0)/100 × latest-month transactions. Scores: Najran 570.1185, Jazan 455.0824, Northern Borders 446.2597. Combined share of nine laggard priority scores: 42.6146%. Alternative weighted metric ranks Najran, Northern Borders, Al-Baha. This sensitivity is material and must be disclosed. The descriptive data do not prove root causes or causal returns.</a:t>
+              <a:t>Evidence. 2:00–4:00. Orient to December 2025, nine region bars, the 0–600 priority index and the target-gap annotations. Index = max(65 - regional arithmetic mean, 0)/100 × latest-month transactions. Scores: Najran 570.1185, Jazan 455.0824, Northern Borders 446.2597, Al-Baha 445.6012. Third and fourth differ by only 0.6585 index units; that is not a robust separation. Combined top-three share of nine laggard priority scores: 42.6146%. Alternative transaction weighting gives national 66.1186% and ranks Najran, Northern Borders, Al-Baha. These are material sensitivities. Fix the metric and validate demand before scaling. Descriptive data do not prove causes or returns. Chart uses source CSV and the workbook field definitions; it is not a Tableau-export screenshot.</a:t>
             </a:r>
           </a:p>
           <a:p xmlns:a="http://schemas.openxmlformats.org/drawingml/2006/main">
@@ -1083,7 +1083,7 @@
           </a:p>
           <a:p xmlns:a="http://schemas.openxmlformats.org/drawingml/2006/main">
             <a:r>
-              <a:t>Ask and next step. 6:15–7:00. Repeat the exact request. Approve 40M; release 10M for pilots; hold 30M. Nominate owner at day 0; agree baseline, definition, service design and cost within 30 days; review at day 90. Suggested continuation threshold: at least +2pp against verified baseline in each pilot, no deterioration in matched CSAT/SLA and a defensible comparison; a management goal, not a forecast. Adjust allocation if the chosen metric changes.</a:t>
+              <a:t>Ask and next step. 6:15–7:00. Approve 40M, authorize initial10M only after approval of metric, baseline, comparison design, service plan and cost; hold30M. Nominate owner on approval Day0. Validate shortlist and approve baseline before any intervention or release; launch within30days if ready. Day90 is counted from envelope approval; report pilot exposure and extend review if insufficient. Suggested +2pp is a management goal, not a causal forecast. Assess matched CSAT/SLA, costs and comparison design. Rerank if metric changes.</a:t>
             </a:r>
           </a:p>
           <a:p xmlns:a="http://schemas.openxmlformats.org/drawingml/2006/main">
@@ -1181,7 +1181,7 @@
   </p:cSld>
   <p:clrMap bg1="lt1" tx1="dk1" bg2="lt2" tx2="dk2" accent1="accent1" accent2="accent2" accent3="accent3" accent4="accent4" accent5="accent5" accent6="accent6" hlink="hlink" folHlink="folHlink"/>
   <p:sldLayoutIdLst>
-    <p:sldLayoutId xmlns:r="http://schemas.openxmlformats.org/officeDocument/2006/relationships" id="2147483649" r:id="Rad7198042cfd4a12"/>
+    <p:sldLayoutId xmlns:r="http://schemas.openxmlformats.org/officeDocument/2006/relationships" id="2147483649" r:id="Rb488b3ae89404148"/>
   </p:sldLayoutIdLst>
   <p:txStyles>
     <p:titleStyle>
@@ -3561,6 +3561,717 @@
 </c:chartSpace>
 </file>
 
+<file path=ppt/slides/charts/chart3.xml><?xml version="1.0" encoding="utf-8"?>
+<c:chartSpace xmlns:c="http://schemas.openxmlformats.org/drawingml/2006/chart" xmlns:r="http://schemas.openxmlformats.org/officeDocument/2006/relationships">
+  <c:lang val="en-US"/>
+  <c:chart>
+    <c:plotArea>
+      <c:barChart>
+        <c:barDir val="bar"/>
+        <c:grouping val="clustered"/>
+        <c:varyColors val="0"/>
+        <c:ser>
+          <c:idx val="0"/>
+          <c:order val="0"/>
+          <c:tx>
+            <c:v>Gap and activity priority index</c:v>
+          </c:tx>
+          <c:spPr>
+            <a:solidFill xmlns:a="http://schemas.openxmlformats.org/drawingml/2006/main">
+              <a:srgbClr val="D7E5E6"/>
+            </a:solidFill>
+          </c:spPr>
+          <c:dPt>
+            <c:idx val="0"/>
+            <c:invertIfNegative val="0"/>
+            <c:spPr>
+              <a:solidFill xmlns:a="http://schemas.openxmlformats.org/drawingml/2006/main">
+                <a:srgbClr val="D7E5E6"/>
+              </a:solidFill>
+            </c:spPr>
+          </c:dPt>
+          <c:dPt>
+            <c:idx val="1"/>
+            <c:invertIfNegative val="0"/>
+            <c:spPr>
+              <a:solidFill xmlns:a="http://schemas.openxmlformats.org/drawingml/2006/main">
+                <a:srgbClr val="D7E5E6"/>
+              </a:solidFill>
+            </c:spPr>
+          </c:dPt>
+          <c:dPt>
+            <c:idx val="2"/>
+            <c:invertIfNegative val="0"/>
+            <c:spPr>
+              <a:solidFill xmlns:a="http://schemas.openxmlformats.org/drawingml/2006/main">
+                <a:srgbClr val="D7E5E6"/>
+              </a:solidFill>
+            </c:spPr>
+          </c:dPt>
+          <c:dPt>
+            <c:idx val="3"/>
+            <c:invertIfNegative val="0"/>
+            <c:spPr>
+              <a:solidFill xmlns:a="http://schemas.openxmlformats.org/drawingml/2006/main">
+                <a:srgbClr val="D7E5E6"/>
+              </a:solidFill>
+            </c:spPr>
+          </c:dPt>
+          <c:dPt>
+            <c:idx val="4"/>
+            <c:invertIfNegative val="0"/>
+            <c:spPr>
+              <a:solidFill xmlns:a="http://schemas.openxmlformats.org/drawingml/2006/main">
+                <a:srgbClr val="D7E5E6"/>
+              </a:solidFill>
+            </c:spPr>
+          </c:dPt>
+          <c:dPt>
+            <c:idx val="5"/>
+            <c:invertIfNegative val="0"/>
+            <c:spPr>
+              <a:solidFill xmlns:a="http://schemas.openxmlformats.org/drawingml/2006/main">
+                <a:srgbClr val="E6B687"/>
+              </a:solidFill>
+            </c:spPr>
+          </c:dPt>
+          <c:dPt>
+            <c:idx val="6"/>
+            <c:invertIfNegative val="0"/>
+            <c:spPr>
+              <a:solidFill xmlns:a="http://schemas.openxmlformats.org/drawingml/2006/main">
+                <a:srgbClr val="087D82"/>
+              </a:solidFill>
+            </c:spPr>
+          </c:dPt>
+          <c:dPt>
+            <c:idx val="7"/>
+            <c:invertIfNegative val="0"/>
+            <c:spPr>
+              <a:solidFill xmlns:a="http://schemas.openxmlformats.org/drawingml/2006/main">
+                <a:srgbClr val="087D82"/>
+              </a:solidFill>
+            </c:spPr>
+          </c:dPt>
+          <c:dPt>
+            <c:idx val="8"/>
+            <c:invertIfNegative val="0"/>
+            <c:spPr>
+              <a:solidFill xmlns:a="http://schemas.openxmlformats.org/drawingml/2006/main">
+                <a:srgbClr val="087D82"/>
+              </a:solidFill>
+            </c:spPr>
+          </c:dPt>
+          <c:dLbls>
+            <c:dLbl>
+              <c:idx val="0"/>
+              <c:tx>
+                <c:rich>
+                  <a:bodyPr xmlns:a="http://schemas.openxmlformats.org/drawingml/2006/main"/>
+                  <a:lstStyle xmlns:a="http://schemas.openxmlformats.org/drawingml/2006/main"/>
+                  <a:p xmlns:a="http://schemas.openxmlformats.org/drawingml/2006/main">
+                    <a:r>
+                      <a:rPr sz="1500">
+                        <a:solidFill>
+                          <a:srgbClr val="15363D"/>
+                        </a:solidFill>
+                        <a:latin typeface="Arial"/>
+                        <a:ea typeface="Arial"/>
+                        <a:cs typeface="Arial"/>
+                      </a:rPr>
+                      <a:t>156.20</a:t>
+                    </a:r>
+                  </a:p>
+                </c:rich>
+              </c:tx>
+              <c:txPr>
+                <a:bodyPr xmlns:a="http://schemas.openxmlformats.org/drawingml/2006/main" anchorCtr="1"/>
+                <a:lstStyle xmlns:a="http://schemas.openxmlformats.org/drawingml/2006/main"/>
+                <a:p xmlns:a="http://schemas.openxmlformats.org/drawingml/2006/main">
+                  <a:pPr>
+                    <a:defRPr sz="1500">
+                      <a:solidFill>
+                        <a:srgbClr val="15363D"/>
+                      </a:solidFill>
+                      <a:latin typeface="Arial"/>
+                      <a:ea typeface="Arial"/>
+                      <a:cs typeface="Arial"/>
+                    </a:defRPr>
+                  </a:pPr>
+                </a:p>
+              </c:txPr>
+              <c:dLblPos val="ctr"/>
+              <c:showLegendKey val="0"/>
+              <c:showVal val="1"/>
+              <c:showCatName val="0"/>
+              <c:showSerName val="0"/>
+              <c:showPercent val="0"/>
+              <c:showBubbleSize val="0"/>
+            </c:dLbl>
+            <c:dLbl>
+              <c:idx val="1"/>
+              <c:tx>
+                <c:rich>
+                  <a:bodyPr xmlns:a="http://schemas.openxmlformats.org/drawingml/2006/main"/>
+                  <a:lstStyle xmlns:a="http://schemas.openxmlformats.org/drawingml/2006/main"/>
+                  <a:p xmlns:a="http://schemas.openxmlformats.org/drawingml/2006/main">
+                    <a:r>
+                      <a:rPr sz="1500">
+                        <a:solidFill>
+                          <a:srgbClr val="15363D"/>
+                        </a:solidFill>
+                        <a:latin typeface="Arial"/>
+                        <a:ea typeface="Arial"/>
+                        <a:cs typeface="Arial"/>
+                      </a:rPr>
+                      <a:t>302.17</a:t>
+                    </a:r>
+                  </a:p>
+                </c:rich>
+              </c:tx>
+              <c:txPr>
+                <a:bodyPr xmlns:a="http://schemas.openxmlformats.org/drawingml/2006/main" anchorCtr="1"/>
+                <a:lstStyle xmlns:a="http://schemas.openxmlformats.org/drawingml/2006/main"/>
+                <a:p xmlns:a="http://schemas.openxmlformats.org/drawingml/2006/main">
+                  <a:pPr>
+                    <a:defRPr sz="1500">
+                      <a:solidFill>
+                        <a:srgbClr val="15363D"/>
+                      </a:solidFill>
+                      <a:latin typeface="Arial"/>
+                      <a:ea typeface="Arial"/>
+                      <a:cs typeface="Arial"/>
+                    </a:defRPr>
+                  </a:pPr>
+                </a:p>
+              </c:txPr>
+              <c:dLblPos val="ctr"/>
+              <c:showLegendKey val="0"/>
+              <c:showVal val="1"/>
+              <c:showCatName val="0"/>
+              <c:showSerName val="0"/>
+              <c:showPercent val="0"/>
+              <c:showBubbleSize val="0"/>
+            </c:dLbl>
+            <c:dLbl>
+              <c:idx val="2"/>
+              <c:tx>
+                <c:rich>
+                  <a:bodyPr xmlns:a="http://schemas.openxmlformats.org/drawingml/2006/main"/>
+                  <a:lstStyle xmlns:a="http://schemas.openxmlformats.org/drawingml/2006/main"/>
+                  <a:p xmlns:a="http://schemas.openxmlformats.org/drawingml/2006/main">
+                    <a:r>
+                      <a:rPr sz="1500">
+                        <a:solidFill>
+                          <a:srgbClr val="15363D"/>
+                        </a:solidFill>
+                        <a:latin typeface="Arial"/>
+                        <a:ea typeface="Arial"/>
+                        <a:cs typeface="Arial"/>
+                      </a:rPr>
+                      <a:t>327.80</a:t>
+                    </a:r>
+                  </a:p>
+                </c:rich>
+              </c:tx>
+              <c:txPr>
+                <a:bodyPr xmlns:a="http://schemas.openxmlformats.org/drawingml/2006/main" anchorCtr="1"/>
+                <a:lstStyle xmlns:a="http://schemas.openxmlformats.org/drawingml/2006/main"/>
+                <a:p xmlns:a="http://schemas.openxmlformats.org/drawingml/2006/main">
+                  <a:pPr>
+                    <a:defRPr sz="1500">
+                      <a:solidFill>
+                        <a:srgbClr val="15363D"/>
+                      </a:solidFill>
+                      <a:latin typeface="Arial"/>
+                      <a:ea typeface="Arial"/>
+                      <a:cs typeface="Arial"/>
+                    </a:defRPr>
+                  </a:pPr>
+                </a:p>
+              </c:txPr>
+              <c:dLblPos val="ctr"/>
+              <c:showLegendKey val="0"/>
+              <c:showVal val="1"/>
+              <c:showCatName val="0"/>
+              <c:showSerName val="0"/>
+              <c:showPercent val="0"/>
+              <c:showBubbleSize val="0"/>
+            </c:dLbl>
+            <c:dLbl>
+              <c:idx val="3"/>
+              <c:tx>
+                <c:rich>
+                  <a:bodyPr xmlns:a="http://schemas.openxmlformats.org/drawingml/2006/main"/>
+                  <a:lstStyle xmlns:a="http://schemas.openxmlformats.org/drawingml/2006/main"/>
+                  <a:p xmlns:a="http://schemas.openxmlformats.org/drawingml/2006/main">
+                    <a:r>
+                      <a:rPr sz="1500">
+                        <a:solidFill>
+                          <a:srgbClr val="15363D"/>
+                        </a:solidFill>
+                        <a:latin typeface="Arial"/>
+                        <a:ea typeface="Arial"/>
+                        <a:cs typeface="Arial"/>
+                      </a:rPr>
+                      <a:t>360.78</a:t>
+                    </a:r>
+                  </a:p>
+                </c:rich>
+              </c:tx>
+              <c:txPr>
+                <a:bodyPr xmlns:a="http://schemas.openxmlformats.org/drawingml/2006/main" anchorCtr="1"/>
+                <a:lstStyle xmlns:a="http://schemas.openxmlformats.org/drawingml/2006/main"/>
+                <a:p xmlns:a="http://schemas.openxmlformats.org/drawingml/2006/main">
+                  <a:pPr>
+                    <a:defRPr sz="1500">
+                      <a:solidFill>
+                        <a:srgbClr val="15363D"/>
+                      </a:solidFill>
+                      <a:latin typeface="Arial"/>
+                      <a:ea typeface="Arial"/>
+                      <a:cs typeface="Arial"/>
+                    </a:defRPr>
+                  </a:pPr>
+                </a:p>
+              </c:txPr>
+              <c:dLblPos val="ctr"/>
+              <c:showLegendKey val="0"/>
+              <c:showVal val="1"/>
+              <c:showCatName val="0"/>
+              <c:showSerName val="0"/>
+              <c:showPercent val="0"/>
+              <c:showBubbleSize val="0"/>
+            </c:dLbl>
+            <c:dLbl>
+              <c:idx val="4"/>
+              <c:tx>
+                <c:rich>
+                  <a:bodyPr xmlns:a="http://schemas.openxmlformats.org/drawingml/2006/main"/>
+                  <a:lstStyle xmlns:a="http://schemas.openxmlformats.org/drawingml/2006/main"/>
+                  <a:p xmlns:a="http://schemas.openxmlformats.org/drawingml/2006/main">
+                    <a:r>
+                      <a:rPr sz="1500">
+                        <a:solidFill>
+                          <a:srgbClr val="15363D"/>
+                        </a:solidFill>
+                        <a:latin typeface="Arial"/>
+                        <a:ea typeface="Arial"/>
+                        <a:cs typeface="Arial"/>
+                      </a:rPr>
+                      <a:t>388.93</a:t>
+                    </a:r>
+                  </a:p>
+                </c:rich>
+              </c:tx>
+              <c:txPr>
+                <a:bodyPr xmlns:a="http://schemas.openxmlformats.org/drawingml/2006/main" anchorCtr="1"/>
+                <a:lstStyle xmlns:a="http://schemas.openxmlformats.org/drawingml/2006/main"/>
+                <a:p xmlns:a="http://schemas.openxmlformats.org/drawingml/2006/main">
+                  <a:pPr>
+                    <a:defRPr sz="1500">
+                      <a:solidFill>
+                        <a:srgbClr val="15363D"/>
+                      </a:solidFill>
+                      <a:latin typeface="Arial"/>
+                      <a:ea typeface="Arial"/>
+                      <a:cs typeface="Arial"/>
+                    </a:defRPr>
+                  </a:pPr>
+                </a:p>
+              </c:txPr>
+              <c:dLblPos val="ctr"/>
+              <c:showLegendKey val="0"/>
+              <c:showVal val="1"/>
+              <c:showCatName val="0"/>
+              <c:showSerName val="0"/>
+              <c:showPercent val="0"/>
+              <c:showBubbleSize val="0"/>
+            </c:dLbl>
+            <c:dLbl>
+              <c:idx val="5"/>
+              <c:tx>
+                <c:rich>
+                  <a:bodyPr xmlns:a="http://schemas.openxmlformats.org/drawingml/2006/main"/>
+                  <a:lstStyle xmlns:a="http://schemas.openxmlformats.org/drawingml/2006/main"/>
+                  <a:p xmlns:a="http://schemas.openxmlformats.org/drawingml/2006/main">
+                    <a:r>
+                      <a:rPr sz="1500">
+                        <a:solidFill>
+                          <a:srgbClr val="15363D"/>
+                        </a:solidFill>
+                        <a:latin typeface="Arial"/>
+                        <a:ea typeface="Arial"/>
+                        <a:cs typeface="Arial"/>
+                      </a:rPr>
+                      <a:t>445.60</a:t>
+                    </a:r>
+                  </a:p>
+                </c:rich>
+              </c:tx>
+              <c:txPr>
+                <a:bodyPr xmlns:a="http://schemas.openxmlformats.org/drawingml/2006/main" anchorCtr="1"/>
+                <a:lstStyle xmlns:a="http://schemas.openxmlformats.org/drawingml/2006/main"/>
+                <a:p xmlns:a="http://schemas.openxmlformats.org/drawingml/2006/main">
+                  <a:pPr>
+                    <a:defRPr sz="1500">
+                      <a:solidFill>
+                        <a:srgbClr val="15363D"/>
+                      </a:solidFill>
+                      <a:latin typeface="Arial"/>
+                      <a:ea typeface="Arial"/>
+                      <a:cs typeface="Arial"/>
+                    </a:defRPr>
+                  </a:pPr>
+                </a:p>
+              </c:txPr>
+              <c:dLblPos val="ctr"/>
+              <c:showLegendKey val="0"/>
+              <c:showVal val="1"/>
+              <c:showCatName val="0"/>
+              <c:showSerName val="0"/>
+              <c:showPercent val="0"/>
+              <c:showBubbleSize val="0"/>
+            </c:dLbl>
+            <c:dLbl>
+              <c:idx val="6"/>
+              <c:tx>
+                <c:rich>
+                  <a:bodyPr xmlns:a="http://schemas.openxmlformats.org/drawingml/2006/main"/>
+                  <a:lstStyle xmlns:a="http://schemas.openxmlformats.org/drawingml/2006/main"/>
+                  <a:p xmlns:a="http://schemas.openxmlformats.org/drawingml/2006/main">
+                    <a:r>
+                      <a:rPr sz="1500">
+                        <a:solidFill>
+                          <a:srgbClr val="FFFFFF"/>
+                        </a:solidFill>
+                        <a:latin typeface="Arial"/>
+                        <a:ea typeface="Arial"/>
+                        <a:cs typeface="Arial"/>
+                      </a:rPr>
+                      <a:t>446.26</a:t>
+                    </a:r>
+                  </a:p>
+                </c:rich>
+              </c:tx>
+              <c:txPr>
+                <a:bodyPr xmlns:a="http://schemas.openxmlformats.org/drawingml/2006/main" anchorCtr="1"/>
+                <a:lstStyle xmlns:a="http://schemas.openxmlformats.org/drawingml/2006/main"/>
+                <a:p xmlns:a="http://schemas.openxmlformats.org/drawingml/2006/main">
+                  <a:pPr>
+                    <a:defRPr sz="1500">
+                      <a:solidFill>
+                        <a:srgbClr val="FFFFFF"/>
+                      </a:solidFill>
+                      <a:latin typeface="Arial"/>
+                      <a:ea typeface="Arial"/>
+                      <a:cs typeface="Arial"/>
+                    </a:defRPr>
+                  </a:pPr>
+                </a:p>
+              </c:txPr>
+              <c:dLblPos val="ctr"/>
+              <c:showLegendKey val="0"/>
+              <c:showVal val="1"/>
+              <c:showCatName val="0"/>
+              <c:showSerName val="0"/>
+              <c:showPercent val="0"/>
+              <c:showBubbleSize val="0"/>
+            </c:dLbl>
+            <c:dLbl>
+              <c:idx val="7"/>
+              <c:tx>
+                <c:rich>
+                  <a:bodyPr xmlns:a="http://schemas.openxmlformats.org/drawingml/2006/main"/>
+                  <a:lstStyle xmlns:a="http://schemas.openxmlformats.org/drawingml/2006/main"/>
+                  <a:p xmlns:a="http://schemas.openxmlformats.org/drawingml/2006/main">
+                    <a:r>
+                      <a:rPr sz="1500">
+                        <a:solidFill>
+                          <a:srgbClr val="FFFFFF"/>
+                        </a:solidFill>
+                        <a:latin typeface="Arial"/>
+                        <a:ea typeface="Arial"/>
+                        <a:cs typeface="Arial"/>
+                      </a:rPr>
+                      <a:t>455.08</a:t>
+                    </a:r>
+                  </a:p>
+                </c:rich>
+              </c:tx>
+              <c:txPr>
+                <a:bodyPr xmlns:a="http://schemas.openxmlformats.org/drawingml/2006/main" anchorCtr="1"/>
+                <a:lstStyle xmlns:a="http://schemas.openxmlformats.org/drawingml/2006/main"/>
+                <a:p xmlns:a="http://schemas.openxmlformats.org/drawingml/2006/main">
+                  <a:pPr>
+                    <a:defRPr sz="1500">
+                      <a:solidFill>
+                        <a:srgbClr val="FFFFFF"/>
+                      </a:solidFill>
+                      <a:latin typeface="Arial"/>
+                      <a:ea typeface="Arial"/>
+                      <a:cs typeface="Arial"/>
+                    </a:defRPr>
+                  </a:pPr>
+                </a:p>
+              </c:txPr>
+              <c:dLblPos val="ctr"/>
+              <c:showLegendKey val="0"/>
+              <c:showVal val="1"/>
+              <c:showCatName val="0"/>
+              <c:showSerName val="0"/>
+              <c:showPercent val="0"/>
+              <c:showBubbleSize val="0"/>
+            </c:dLbl>
+            <c:dLbl>
+              <c:idx val="8"/>
+              <c:tx>
+                <c:rich>
+                  <a:bodyPr xmlns:a="http://schemas.openxmlformats.org/drawingml/2006/main"/>
+                  <a:lstStyle xmlns:a="http://schemas.openxmlformats.org/drawingml/2006/main"/>
+                  <a:p xmlns:a="http://schemas.openxmlformats.org/drawingml/2006/main">
+                    <a:r>
+                      <a:rPr sz="1500">
+                        <a:solidFill>
+                          <a:srgbClr val="FFFFFF"/>
+                        </a:solidFill>
+                        <a:latin typeface="Arial"/>
+                        <a:ea typeface="Arial"/>
+                        <a:cs typeface="Arial"/>
+                      </a:rPr>
+                      <a:t>570.12</a:t>
+                    </a:r>
+                  </a:p>
+                </c:rich>
+              </c:tx>
+              <c:txPr>
+                <a:bodyPr xmlns:a="http://schemas.openxmlformats.org/drawingml/2006/main" anchorCtr="1"/>
+                <a:lstStyle xmlns:a="http://schemas.openxmlformats.org/drawingml/2006/main"/>
+                <a:p xmlns:a="http://schemas.openxmlformats.org/drawingml/2006/main">
+                  <a:pPr>
+                    <a:defRPr sz="1500">
+                      <a:solidFill>
+                        <a:srgbClr val="FFFFFF"/>
+                      </a:solidFill>
+                      <a:latin typeface="Arial"/>
+                      <a:ea typeface="Arial"/>
+                      <a:cs typeface="Arial"/>
+                    </a:defRPr>
+                  </a:pPr>
+                </a:p>
+              </c:txPr>
+              <c:dLblPos val="ctr"/>
+              <c:showLegendKey val="0"/>
+              <c:showVal val="1"/>
+              <c:showCatName val="0"/>
+              <c:showSerName val="0"/>
+              <c:showPercent val="0"/>
+              <c:showBubbleSize val="0"/>
+            </c:dLbl>
+          </c:dLbls>
+          <c:cat>
+            <c:strRef>
+              <c:f>'Chart Data'!$A$2:$A$10</c:f>
+              <c:strCache>
+                <c:ptCount val="9"/>
+                <c:pt idx="0">
+                  <c:v>Qassim</c:v>
+                </c:pt>
+                <c:pt idx="1">
+                  <c:v>Hail</c:v>
+                </c:pt>
+                <c:pt idx="2">
+                  <c:v>Al-Jouf</c:v>
+                </c:pt>
+                <c:pt idx="3">
+                  <c:v>Asir</c:v>
+                </c:pt>
+                <c:pt idx="4">
+                  <c:v>Tabuk</c:v>
+                </c:pt>
+                <c:pt idx="5">
+                  <c:v>Al-Baha</c:v>
+                </c:pt>
+                <c:pt idx="6">
+                  <c:v>Northern Borders</c:v>
+                </c:pt>
+                <c:pt idx="7">
+                  <c:v>Jazan</c:v>
+                </c:pt>
+                <c:pt idx="8">
+                  <c:v>Najran</c:v>
+                </c:pt>
+              </c:strCache>
+            </c:strRef>
+          </c:cat>
+          <c:val>
+            <c:numRef>
+              <c:f>'Chart Data'!$B$2:$B$10</c:f>
+              <c:numCache>
+                <c:formatCode>0</c:formatCode>
+                <c:ptCount val="9"/>
+                <c:pt idx="0">
+                  <c:v>156.2</c:v>
+                </c:pt>
+                <c:pt idx="1">
+                  <c:v>302.17</c:v>
+                </c:pt>
+                <c:pt idx="2">
+                  <c:v>327.8</c:v>
+                </c:pt>
+                <c:pt idx="3">
+                  <c:v>360.78</c:v>
+                </c:pt>
+                <c:pt idx="4">
+                  <c:v>388.93</c:v>
+                </c:pt>
+                <c:pt idx="5">
+                  <c:v>445.6</c:v>
+                </c:pt>
+                <c:pt idx="6">
+                  <c:v>446.26</c:v>
+                </c:pt>
+                <c:pt idx="7">
+                  <c:v>455.08</c:v>
+                </c:pt>
+                <c:pt idx="8">
+                  <c:v>570.12</c:v>
+                </c:pt>
+              </c:numCache>
+            </c:numRef>
+          </c:val>
+        </c:ser>
+        <c:dLbls>
+          <c:txPr>
+            <a:bodyPr xmlns:a="http://schemas.openxmlformats.org/drawingml/2006/main" anchorCtr="1"/>
+            <a:lstStyle xmlns:a="http://schemas.openxmlformats.org/drawingml/2006/main"/>
+            <a:p xmlns:a="http://schemas.openxmlformats.org/drawingml/2006/main">
+              <a:pPr>
+                <a:defRPr sz="1500">
+                  <a:latin typeface="Arial"/>
+                  <a:ea typeface="Arial"/>
+                  <a:cs typeface="Arial"/>
+                </a:defRPr>
+              </a:pPr>
+            </a:p>
+          </c:txPr>
+          <c:dLblPos val="ctr"/>
+          <c:showLegendKey val="0"/>
+          <c:showVal val="1"/>
+          <c:showCatName val="0"/>
+          <c:showSerName val="0"/>
+          <c:showPercent val="0"/>
+          <c:showBubbleSize val="0"/>
+          <c:showLeaderLines val="0"/>
+        </c:dLbls>
+        <c:gapWidth val="40"/>
+        <c:axId val="48650112"/>
+        <c:axId val="48672768"/>
+      </c:barChart>
+      <c:catAx>
+        <c:axId val="48650112"/>
+        <c:scaling>
+          <c:orientation val="minMax"/>
+        </c:scaling>
+        <c:delete val="0"/>
+        <c:axPos val="l"/>
+        <c:numFmt formatCode="General"/>
+        <c:majorTickMark val="none"/>
+        <c:minorTickMark val="none"/>
+        <c:spPr>
+          <a:ln xmlns:a="http://schemas.openxmlformats.org/drawingml/2006/main" w="9525">
+            <a:solidFill>
+              <a:srgbClr val="D4D4D4"/>
+            </a:solidFill>
+            <a:prstDash val="solid"/>
+          </a:ln>
+        </c:spPr>
+        <c:txPr>
+          <a:bodyPr xmlns:a="http://schemas.openxmlformats.org/drawingml/2006/main" anchorCtr="1"/>
+          <a:lstStyle xmlns:a="http://schemas.openxmlformats.org/drawingml/2006/main"/>
+          <a:p xmlns:a="http://schemas.openxmlformats.org/drawingml/2006/main">
+            <a:pPr>
+              <a:defRPr sz="1425">
+                <a:solidFill>
+                  <a:srgbClr val="666666"/>
+                </a:solidFill>
+                <a:latin typeface="Arial"/>
+                <a:ea typeface="Arial"/>
+                <a:cs typeface="Arial"/>
+              </a:defRPr>
+            </a:pPr>
+          </a:p>
+        </c:txPr>
+        <c:crossAx val="48672768"/>
+      </c:catAx>
+      <c:valAx>
+        <c:axId val="48672768"/>
+        <c:scaling>
+          <c:orientation val="minMax"/>
+          <c:max val="600"/>
+          <c:min val="0"/>
+        </c:scaling>
+        <c:delete val="0"/>
+        <c:axPos val="b"/>
+        <c:majorGridlines>
+          <c:spPr>
+            <a:ln xmlns:a="http://schemas.openxmlformats.org/drawingml/2006/main" w="9525">
+              <a:solidFill>
+                <a:srgbClr val="E3E9EA"/>
+              </a:solidFill>
+            </a:ln>
+          </c:spPr>
+        </c:majorGridlines>
+        <c:numFmt formatCode="0"/>
+        <c:majorTickMark val="none"/>
+        <c:minorTickMark val="none"/>
+        <c:spPr>
+          <a:ln xmlns:a="http://schemas.openxmlformats.org/drawingml/2006/main" w="9525">
+            <a:solidFill>
+              <a:srgbClr val="D4D4D4"/>
+            </a:solidFill>
+            <a:prstDash val="solid"/>
+          </a:ln>
+        </c:spPr>
+        <c:txPr>
+          <a:bodyPr xmlns:a="http://schemas.openxmlformats.org/drawingml/2006/main" anchorCtr="1"/>
+          <a:lstStyle xmlns:a="http://schemas.openxmlformats.org/drawingml/2006/main"/>
+          <a:p xmlns:a="http://schemas.openxmlformats.org/drawingml/2006/main">
+            <a:pPr>
+              <a:defRPr sz="1350">
+                <a:solidFill>
+                  <a:srgbClr val="666666"/>
+                </a:solidFill>
+                <a:latin typeface="Arial"/>
+                <a:ea typeface="Arial"/>
+                <a:cs typeface="Arial"/>
+              </a:defRPr>
+            </a:pPr>
+          </a:p>
+        </c:txPr>
+        <c:crossAx val="48650112"/>
+        <c:crossBetween val="between"/>
+        <c:majorUnit val="200"/>
+      </c:valAx>
+      <c:spPr>
+        <a:solidFill xmlns:a="http://schemas.openxmlformats.org/drawingml/2006/main">
+          <a:srgbClr val="FFFFFF"/>
+        </a:solidFill>
+      </c:spPr>
+    </c:plotArea>
+    <c:plotVisOnly val="1"/>
+  </c:chart>
+  <c:spPr>
+    <a:solidFill xmlns:a="http://schemas.openxmlformats.org/drawingml/2006/main">
+      <a:srgbClr val="FFFFFF"/>
+    </a:solidFill>
+  </c:spPr>
+  <c:externalData r:id="rIdChartSnapshot1">
+    <c:autoUpdate val="0"/>
+  </c:externalData>
+</c:chartSpace>
+</file>
+
 <file path=ppt/slides/slide1.xml><?xml version="1.0" encoding="utf-8"?>
 <p:sld xmlns:p="http://schemas.openxmlformats.org/presentationml/2006/main">
   <p:cSld>
@@ -3585,7 +4296,7 @@
           <p:cNvPr id="8" name="">
             <a:extLst xmlns:a="http://schemas.openxmlformats.org/drawingml/2006/main">
               <a:ext uri="{FF2B5EF4-FFF2-40B4-BE49-F238E27FC236}">
-                <a16:creationId xmlns:a16="http://schemas.microsoft.com/office/drawing/2014/main" id="{D3DF2F96-441D-4A99-AE73-A7017EE56CDB}"/>
+                <a16:creationId xmlns:a16="http://schemas.microsoft.com/office/drawing/2014/main" id="{A09588A9-B489-435F-A1CA-24CF9FB26322}"/>
               </a:ext>
             </a:extLst>
           </p:cNvPr>
@@ -3642,7 +4353,7 @@
           <p:cNvPr id="2" name="">
             <a:extLst xmlns:a="http://schemas.openxmlformats.org/drawingml/2006/main">
               <a:ext uri="{FF2B5EF4-FFF2-40B4-BE49-F238E27FC236}">
-                <a16:creationId xmlns:a16="http://schemas.microsoft.com/office/drawing/2014/main" id="{8B3BCF51-358A-4040-89DB-63F303EEEF07}"/>
+                <a16:creationId xmlns:a16="http://schemas.microsoft.com/office/drawing/2014/main" id="{3759B10B-13D7-4716-9ACF-1E6B2CCFE2E3}"/>
               </a:ext>
             </a:extLst>
           </p:cNvPr>
@@ -3699,7 +4410,7 @@
           <p:cNvPr id="3" name="">
             <a:extLst xmlns:a="http://schemas.openxmlformats.org/drawingml/2006/main">
               <a:ext uri="{FF2B5EF4-FFF2-40B4-BE49-F238E27FC236}">
-                <a16:creationId xmlns:a16="http://schemas.microsoft.com/office/drawing/2014/main" id="{495F638B-49DE-4012-A082-DEC4881596C0}"/>
+                <a16:creationId xmlns:a16="http://schemas.microsoft.com/office/drawing/2014/main" id="{516D92E5-2FCC-4A7C-BB04-2263FD23A999}"/>
               </a:ext>
             </a:extLst>
           </p:cNvPr>
@@ -3756,7 +4467,7 @@
           <p:cNvPr id="4" name="">
             <a:extLst xmlns:a="http://schemas.openxmlformats.org/drawingml/2006/main">
               <a:ext uri="{FF2B5EF4-FFF2-40B4-BE49-F238E27FC236}">
-                <a16:creationId xmlns:a16="http://schemas.microsoft.com/office/drawing/2014/main" id="{AD6AE273-37EE-48EF-8129-FA8DBF347418}"/>
+                <a16:creationId xmlns:a16="http://schemas.microsoft.com/office/drawing/2014/main" id="{E101BEE1-0BCD-4ADE-BBB7-1942D8F2703A}"/>
               </a:ext>
             </a:extLst>
           </p:cNvPr>
@@ -3813,7 +4524,7 @@
           <p:cNvPr id="5" name="">
             <a:extLst xmlns:a="http://schemas.openxmlformats.org/drawingml/2006/main">
               <a:ext uri="{FF2B5EF4-FFF2-40B4-BE49-F238E27FC236}">
-                <a16:creationId xmlns:a16="http://schemas.microsoft.com/office/drawing/2014/main" id="{60F495F7-B341-46CA-AB17-5490462E0D86}"/>
+                <a16:creationId xmlns:a16="http://schemas.microsoft.com/office/drawing/2014/main" id="{9F5D88D5-6F1A-41E7-AEE2-5F4B8BCFE7A5}"/>
               </a:ext>
             </a:extLst>
           </p:cNvPr>
@@ -3860,7 +4571,7 @@
                 <a:ea typeface="Arial"/>
                 <a:cs typeface="Arial"/>
               </a:rPr>
-              <a:t>Release SAR 10M for pilots; hold SAR 30M for review</a:t>
+              <a:t>Release SAR 10M after baseline approval; hold SAR 30M</a:t>
             </a:r>
           </a:p>
         </p:txBody>
@@ -3870,7 +4581,7 @@
           <p:cNvPr id="6" name="">
             <a:extLst xmlns:a="http://schemas.openxmlformats.org/drawingml/2006/main">
               <a:ext uri="{FF2B5EF4-FFF2-40B4-BE49-F238E27FC236}">
-                <a16:creationId xmlns:a16="http://schemas.microsoft.com/office/drawing/2014/main" id="{84856ABE-26AC-43AF-BC71-951F01376D0B}"/>
+                <a16:creationId xmlns:a16="http://schemas.microsoft.com/office/drawing/2014/main" id="{8401E799-22CB-4A00-B2D7-EB4B6E03FF2E}"/>
               </a:ext>
             </a:extLst>
           </p:cNvPr>
@@ -3927,7 +4638,7 @@
           <p:cNvPr id="7" name="">
             <a:extLst xmlns:a="http://schemas.openxmlformats.org/drawingml/2006/main">
               <a:ext uri="{FF2B5EF4-FFF2-40B4-BE49-F238E27FC236}">
-                <a16:creationId xmlns:a16="http://schemas.microsoft.com/office/drawing/2014/main" id="{4E261B74-1122-4DF3-87A8-C51497E5C09A}"/>
+                <a16:creationId xmlns:a16="http://schemas.microsoft.com/office/drawing/2014/main" id="{01FB6FAB-51F7-4265-9DA0-C8F4014D030B}"/>
               </a:ext>
             </a:extLst>
           </p:cNvPr>
@@ -3982,7 +4693,7 @@
     </p:spTree>
     <p:extLst>
       <p:ext uri="{BB962C8B-B14F-4D97-AF65-F5344CB8AC3E}">
-        <p14:creationId xmlns:p14="http://schemas.microsoft.com/office/powerpoint/2010/main" val="843843124"/>
+        <p14:creationId xmlns:p14="http://schemas.microsoft.com/office/powerpoint/2010/main" val="583923919"/>
       </p:ext>
     </p:extLst>
   </p:cSld>
@@ -4010,10 +4721,10 @@
       </p:grpSpPr>
       <p:sp>
         <p:nvSpPr>
-          <p:cNvPr id="10" name="">
+          <p:cNvPr id="11" name="">
             <a:extLst xmlns:a="http://schemas.openxmlformats.org/drawingml/2006/main">
               <a:ext uri="{FF2B5EF4-FFF2-40B4-BE49-F238E27FC236}">
-                <a16:creationId xmlns:a16="http://schemas.microsoft.com/office/drawing/2014/main" id="{D08E4788-D356-4B1F-85CE-587C38FE0604}"/>
+                <a16:creationId xmlns:a16="http://schemas.microsoft.com/office/drawing/2014/main" id="{A5B8BE2B-ADAC-49EC-BF81-F64F11B785C5}"/>
               </a:ext>
             </a:extLst>
           </p:cNvPr>
@@ -4060,7 +4771,7 @@
                 <a:ea typeface="Arial"/>
                 <a:cs typeface="Arial"/>
               </a:rPr>
-              <a:t>National adoption improved, but remains below 65%</a:t>
+              <a:t>National course adoption remains below 65%</a:t>
             </a:r>
           </a:p>
         </p:txBody>
@@ -4070,7 +4781,7 @@
           <p:cNvPr id="2" name="">
             <a:extLst xmlns:a="http://schemas.openxmlformats.org/drawingml/2006/main">
               <a:ext uri="{FF2B5EF4-FFF2-40B4-BE49-F238E27FC236}">
-                <a16:creationId xmlns:a16="http://schemas.microsoft.com/office/drawing/2014/main" id="{EB7555C0-71F3-406C-9817-4468C1F74FB7}"/>
+                <a16:creationId xmlns:a16="http://schemas.microsoft.com/office/drawing/2014/main" id="{3718ED2D-F54E-462F-B718-6C8293BBD9C9}"/>
               </a:ext>
             </a:extLst>
           </p:cNvPr>
@@ -4127,7 +4838,7 @@
           <p:cNvPr id="3" name="">
             <a:extLst xmlns:a="http://schemas.openxmlformats.org/drawingml/2006/main">
               <a:ext uri="{FF2B5EF4-FFF2-40B4-BE49-F238E27FC236}">
-                <a16:creationId xmlns:a16="http://schemas.microsoft.com/office/drawing/2014/main" id="{D2A9AC32-94F8-46B8-8D24-2767B24B1980}"/>
+                <a16:creationId xmlns:a16="http://schemas.microsoft.com/office/drawing/2014/main" id="{73FB3E33-88A7-4F6D-A619-1F1A8C987721}"/>
               </a:ext>
             </a:extLst>
           </p:cNvPr>
@@ -4184,7 +4895,7 @@
           <p:cNvPr id="4" name="">
             <a:extLst xmlns:a="http://schemas.openxmlformats.org/drawingml/2006/main">
               <a:ext uri="{FF2B5EF4-FFF2-40B4-BE49-F238E27FC236}">
-                <a16:creationId xmlns:a16="http://schemas.microsoft.com/office/drawing/2014/main" id="{4DAF1570-0695-4163-A256-C9983A243E7F}"/>
+                <a16:creationId xmlns:a16="http://schemas.microsoft.com/office/drawing/2014/main" id="{65917437-C7FD-4B1B-A71C-217AF92B437A}"/>
               </a:ext>
             </a:extLst>
           </p:cNvPr>
@@ -4238,7 +4949,7 @@
       </p:sp>
       <p:graphicFrame>
         <p:nvGraphicFramePr>
-          <p:cNvPr id="14" name="Chart"/>
+          <p:cNvPr id="15" name="Chart"/>
           <p:cNvGraphicFramePr/>
           <p:nvPr/>
         </p:nvGraphicFramePr>
@@ -4248,7 +4959,7 @@
         </p:xfrm>
         <a:graphic xmlns:a="http://schemas.openxmlformats.org/drawingml/2006/main">
           <a:graphicData uri="http://schemas.openxmlformats.org/drawingml/2006/chart">
-            <c:chart xmlns:r="http://schemas.openxmlformats.org/officeDocument/2006/relationships" xmlns:c="http://schemas.openxmlformats.org/drawingml/2006/chart" r:id="R58066c90f351463d"/>
+            <c:chart xmlns:r="http://schemas.openxmlformats.org/officeDocument/2006/relationships" xmlns:c="http://schemas.openxmlformats.org/drawingml/2006/chart" r:id="R029df7db226a4ff6"/>
           </a:graphicData>
         </a:graphic>
       </p:graphicFrame>
@@ -4257,7 +4968,7 @@
           <p:cNvPr id="6" name="">
             <a:extLst xmlns:a="http://schemas.openxmlformats.org/drawingml/2006/main">
               <a:ext uri="{FF2B5EF4-FFF2-40B4-BE49-F238E27FC236}">
-                <a16:creationId xmlns:a16="http://schemas.microsoft.com/office/drawing/2014/main" id="{636A895F-55C0-43B3-B52C-7B2A55036336}"/>
+                <a16:creationId xmlns:a16="http://schemas.microsoft.com/office/drawing/2014/main" id="{28C5E99E-122B-4A2E-AAE6-392EE19B9B18}"/>
               </a:ext>
             </a:extLst>
           </p:cNvPr>
@@ -4314,7 +5025,7 @@
           <p:cNvPr id="7" name="">
             <a:extLst xmlns:a="http://schemas.openxmlformats.org/drawingml/2006/main">
               <a:ext uri="{FF2B5EF4-FFF2-40B4-BE49-F238E27FC236}">
-                <a16:creationId xmlns:a16="http://schemas.microsoft.com/office/drawing/2014/main" id="{26A58ACC-E660-42BA-9DDA-80C887C1EAD6}"/>
+                <a16:creationId xmlns:a16="http://schemas.microsoft.com/office/drawing/2014/main" id="{35622404-39A7-4B23-BD53-9A0607A91AE9}"/>
               </a:ext>
             </a:extLst>
           </p:cNvPr>
@@ -4371,7 +5082,7 @@
           <p:cNvPr id="8" name="">
             <a:extLst xmlns:a="http://schemas.openxmlformats.org/drawingml/2006/main">
               <a:ext uri="{FF2B5EF4-FFF2-40B4-BE49-F238E27FC236}">
-                <a16:creationId xmlns:a16="http://schemas.microsoft.com/office/drawing/2014/main" id="{686946EB-EA2C-4075-93CB-80C82F9E95A2}"/>
+                <a16:creationId xmlns:a16="http://schemas.microsoft.com/office/drawing/2014/main" id="{9084C919-3B86-420B-8D50-D3903F21E471}"/>
               </a:ext>
             </a:extLst>
           </p:cNvPr>
@@ -4428,7 +5139,64 @@
           <p:cNvPr id="9" name="">
             <a:extLst xmlns:a="http://schemas.openxmlformats.org/drawingml/2006/main">
               <a:ext uri="{FF2B5EF4-FFF2-40B4-BE49-F238E27FC236}">
-                <a16:creationId xmlns:a16="http://schemas.microsoft.com/office/drawing/2014/main" id="{60FBA472-5212-43C8-BFAC-5AFB2737E4C6}"/>
+                <a16:creationId xmlns:a16="http://schemas.microsoft.com/office/drawing/2014/main" id="{0B70139B-7825-43D7-82AE-267A3E617D1F}"/>
+              </a:ext>
+            </a:extLst>
+          </p:cNvPr>
+          <p:cNvSpPr>
+            <a:spLocks xmlns:a="http://schemas.openxmlformats.org/drawingml/2006/main" noGrp="1"/>
+          </p:cNvSpPr>
+          <p:nvPr/>
+        </p:nvSpPr>
+        <p:spPr>
+          <a:xfrm xmlns:a="http://schemas.openxmlformats.org/drawingml/2006/main">
+            <a:off x="1952625" y="6000750"/>
+            <a:ext cx="9620250" cy="228600"/>
+          </a:xfrm>
+          <a:prstGeom xmlns:a="http://schemas.openxmlformats.org/drawingml/2006/main" prst="rect">
+            <a:avLst/>
+          </a:prstGeom>
+          <a:noFill xmlns:a="http://schemas.openxmlformats.org/drawingml/2006/main"/>
+          <a:ln xmlns:a="http://schemas.openxmlformats.org/drawingml/2006/main" w="0">
+            <a:noFill/>
+          </a:ln>
+        </p:spPr>
+        <p:txBody>
+          <a:bodyPr xmlns:a="http://schemas.openxmlformats.org/drawingml/2006/main">
+            <a:noAutofit/>
+          </a:bodyPr>
+          <a:lstStyle xmlns:a="http://schemas.openxmlformats.org/drawingml/2006/main"/>
+          <a:p xmlns:a="http://schemas.openxmlformats.org/drawingml/2006/main">
+            <a:pPr algn="l">
+              <a:defRPr sz="1275" b="0">
+                <a:solidFill>
+                  <a:srgbClr val="B45C16"/>
+                </a:solidFill>
+                <a:latin typeface="Arial"/>
+                <a:ea typeface="Arial"/>
+                <a:cs typeface="Arial"/>
+              </a:defRPr>
+            </a:pPr>
+            <a:r>
+              <a:rPr sz="1275" b="0">
+                <a:solidFill>
+                  <a:srgbClr val="B45C16"/>
+                </a:solidFill>
+                <a:latin typeface="Arial"/>
+                <a:ea typeface="Arial"/>
+                <a:cs typeface="Arial"/>
+              </a:rPr>
+              <a:t>Transaction-weighted alternative: 66.12% (&gt;65%). Target status depends on the definition.</a:t>
+            </a:r>
+          </a:p>
+        </p:txBody>
+      </p:sp>
+      <p:sp>
+        <p:nvSpPr>
+          <p:cNvPr id="10" name="">
+            <a:extLst xmlns:a="http://schemas.openxmlformats.org/drawingml/2006/main">
+              <a:ext uri="{FF2B5EF4-FFF2-40B4-BE49-F238E27FC236}">
+                <a16:creationId xmlns:a16="http://schemas.microsoft.com/office/drawing/2014/main" id="{739D3EF4-89A9-412C-BDA6-8F6F55CF2CB3}"/>
               </a:ext>
             </a:extLst>
           </p:cNvPr>
@@ -4483,7 +5251,7 @@
     </p:spTree>
     <p:extLst>
       <p:ext uri="{BB962C8B-B14F-4D97-AF65-F5344CB8AC3E}">
-        <p14:creationId xmlns:p14="http://schemas.microsoft.com/office/powerpoint/2010/main" val="1888119549"/>
+        <p14:creationId xmlns:p14="http://schemas.microsoft.com/office/powerpoint/2010/main" val="2073866700"/>
       </p:ext>
     </p:extLst>
   </p:cSld>
@@ -4514,7 +5282,7 @@
           <p:cNvPr id="7" name="">
             <a:extLst xmlns:a="http://schemas.openxmlformats.org/drawingml/2006/main">
               <a:ext uri="{FF2B5EF4-FFF2-40B4-BE49-F238E27FC236}">
-                <a16:creationId xmlns:a16="http://schemas.microsoft.com/office/drawing/2014/main" id="{1C2B0AB0-A41B-4073-B40D-C8B377DED602}"/>
+                <a16:creationId xmlns:a16="http://schemas.microsoft.com/office/drawing/2014/main" id="{80404330-1AE7-4753-A954-D2F0004DB371}"/>
               </a:ext>
             </a:extLst>
           </p:cNvPr>
@@ -4571,7 +5339,7 @@
           <p:cNvPr id="2" name="">
             <a:extLst xmlns:a="http://schemas.openxmlformats.org/drawingml/2006/main">
               <a:ext uri="{FF2B5EF4-FFF2-40B4-BE49-F238E27FC236}">
-                <a16:creationId xmlns:a16="http://schemas.microsoft.com/office/drawing/2014/main" id="{A089D4DF-A28D-4128-BD1D-1BE36E29FF37}"/>
+                <a16:creationId xmlns:a16="http://schemas.microsoft.com/office/drawing/2014/main" id="{E535A41F-2F6D-4743-97D7-EA75EEE27679}"/>
               </a:ext>
             </a:extLst>
           </p:cNvPr>
@@ -4635,7 +5403,7 @@
         </p:xfrm>
         <a:graphic xmlns:a="http://schemas.openxmlformats.org/drawingml/2006/main">
           <a:graphicData uri="http://schemas.openxmlformats.org/drawingml/2006/chart">
-            <c:chart xmlns:r="http://schemas.openxmlformats.org/officeDocument/2006/relationships" xmlns:c="http://schemas.openxmlformats.org/drawingml/2006/chart" r:id="R49c81be1279b4494"/>
+            <c:chart xmlns:r="http://schemas.openxmlformats.org/officeDocument/2006/relationships" xmlns:c="http://schemas.openxmlformats.org/drawingml/2006/chart" r:id="Rb4228c31970e46b8"/>
           </a:graphicData>
         </a:graphic>
       </p:graphicFrame>
@@ -4644,7 +5412,7 @@
           <p:cNvPr id="4" name="">
             <a:extLst xmlns:a="http://schemas.openxmlformats.org/drawingml/2006/main">
               <a:ext uri="{FF2B5EF4-FFF2-40B4-BE49-F238E27FC236}">
-                <a16:creationId xmlns:a16="http://schemas.microsoft.com/office/drawing/2014/main" id="{12FAD838-DC1A-45B2-8396-A77644B34E79}"/>
+                <a16:creationId xmlns:a16="http://schemas.microsoft.com/office/drawing/2014/main" id="{5A88C3F5-B88A-4518-9A78-89F824EE293E}"/>
               </a:ext>
             </a:extLst>
           </p:cNvPr>
@@ -4674,7 +5442,7 @@
           <p:cNvPr id="5" name="">
             <a:extLst xmlns:a="http://schemas.openxmlformats.org/drawingml/2006/main">
               <a:ext uri="{FF2B5EF4-FFF2-40B4-BE49-F238E27FC236}">
-                <a16:creationId xmlns:a16="http://schemas.microsoft.com/office/drawing/2014/main" id="{316C5D20-38A0-4B36-B5B1-3A963636EA29}"/>
+                <a16:creationId xmlns:a16="http://schemas.microsoft.com/office/drawing/2014/main" id="{47AE13AC-ED33-485A-9E33-7C35C4A74A2D}"/>
               </a:ext>
             </a:extLst>
           </p:cNvPr>
@@ -4731,7 +5499,7 @@
           <p:cNvPr id="6" name="">
             <a:extLst xmlns:a="http://schemas.openxmlformats.org/drawingml/2006/main">
               <a:ext uri="{FF2B5EF4-FFF2-40B4-BE49-F238E27FC236}">
-                <a16:creationId xmlns:a16="http://schemas.microsoft.com/office/drawing/2014/main" id="{06C5604A-5C9C-4556-8B73-F861E2F9F481}"/>
+                <a16:creationId xmlns:a16="http://schemas.microsoft.com/office/drawing/2014/main" id="{10DE4A0A-3110-40E5-8086-DF1BF05382B1}"/>
               </a:ext>
             </a:extLst>
           </p:cNvPr>
@@ -4786,7 +5554,7 @@
     </p:spTree>
     <p:extLst>
       <p:ext uri="{BB962C8B-B14F-4D97-AF65-F5344CB8AC3E}">
-        <p14:creationId xmlns:p14="http://schemas.microsoft.com/office/powerpoint/2010/main" val="759000543"/>
+        <p14:creationId xmlns:p14="http://schemas.microsoft.com/office/powerpoint/2010/main" val="1524833030"/>
       </p:ext>
     </p:extLst>
   </p:cSld>
@@ -4814,10 +5582,10 @@
       </p:grpSpPr>
       <p:sp>
         <p:nvSpPr>
-          <p:cNvPr id="8" name="">
+          <p:cNvPr id="12" name="">
             <a:extLst xmlns:a="http://schemas.openxmlformats.org/drawingml/2006/main">
               <a:ext uri="{FF2B5EF4-FFF2-40B4-BE49-F238E27FC236}">
-                <a16:creationId xmlns:a16="http://schemas.microsoft.com/office/drawing/2014/main" id="{415B00FA-B03F-4FD4-AC5C-D4A295F34F45}"/>
+                <a16:creationId xmlns:a16="http://schemas.microsoft.com/office/drawing/2014/main" id="{DD246550-EBFD-4815-B1BE-51041C84E42D}"/>
               </a:ext>
             </a:extLst>
           </p:cNvPr>
@@ -4864,7 +5632,7 @@
                 <a:ea typeface="Arial"/>
                 <a:cs typeface="Arial"/>
               </a:rPr>
-              <a:t>The adoption gap and activity identify funding priorities</a:t>
+              <a:t>Najran leads; third place needs validation</a:t>
             </a:r>
           </a:p>
         </p:txBody>
@@ -4874,7 +5642,7 @@
           <p:cNvPr id="2" name="">
             <a:extLst xmlns:a="http://schemas.openxmlformats.org/drawingml/2006/main">
               <a:ext uri="{FF2B5EF4-FFF2-40B4-BE49-F238E27FC236}">
-                <a16:creationId xmlns:a16="http://schemas.microsoft.com/office/drawing/2014/main" id="{56097644-739C-4518-AD0B-1F250CCE8782}"/>
+                <a16:creationId xmlns:a16="http://schemas.microsoft.com/office/drawing/2014/main" id="{E85B1DCA-230F-4394-A2FD-17D9355AB287}"/>
               </a:ext>
             </a:extLst>
           </p:cNvPr>
@@ -4926,440 +5694,12 @@
           </a:p>
         </p:txBody>
       </p:sp>
-      <p:graphicFrame>
-        <p:nvGraphicFramePr>
-          <p:cNvPr id="10" name=""/>
-          <p:cNvGraphicFramePr/>
-          <p:nvPr/>
-        </p:nvGraphicFramePr>
-        <p:xfrm>
-          <a:off xmlns:a="http://schemas.openxmlformats.org/drawingml/2006/main" x="619125" y="1647825"/>
-          <a:ext xmlns:a="http://schemas.openxmlformats.org/drawingml/2006/main" cx="10953750" cy="2495550"/>
-        </p:xfrm>
-        <a:graphic xmlns:a="http://schemas.openxmlformats.org/drawingml/2006/main">
-          <a:graphicData uri="http://schemas.openxmlformats.org/drawingml/2006/table">
-            <a:tbl>
-              <a:tblPr/>
-              <a:tblGrid>
-                <a:gridCol w="3381375"/>
-                <a:gridCol w="2095500"/>
-                <a:gridCol w="2333625"/>
-                <a:gridCol w="3143250"/>
-              </a:tblGrid>
-              <a:tr h="623888">
-                <a:tc>
-                  <a:txBody>
-                    <a:bodyPr/>
-                    <a:lstStyle/>
-                    <a:p>
-                      <a:r>
-                        <a:rPr sz="1800" b="1">
-                          <a:solidFill>
-                            <a:srgbClr val="FFFFFF"/>
-                          </a:solidFill>
-                          <a:latin typeface="Arial"/>
-                          <a:ea typeface="Arial"/>
-                          <a:cs typeface="Arial"/>
-                        </a:rPr>
-                        <a:t>Region</a:t>
-                      </a:r>
-                    </a:p>
-                  </a:txBody>
-                  <a:tcPr marL="133350" marR="133350" marT="95250" marB="95250" anchor="ctr">
-                    <a:solidFill>
-                      <a:srgbClr val="087D82"/>
-                    </a:solidFill>
-                  </a:tcPr>
-                </a:tc>
-                <a:tc>
-                  <a:txBody>
-                    <a:bodyPr/>
-                    <a:lstStyle/>
-                    <a:p>
-                      <a:r>
-                        <a:rPr sz="1800" b="1">
-                          <a:solidFill>
-                            <a:srgbClr val="FFFFFF"/>
-                          </a:solidFill>
-                          <a:latin typeface="Arial"/>
-                          <a:ea typeface="Arial"/>
-                          <a:cs typeface="Arial"/>
-                        </a:rPr>
-                        <a:t>Adoption</a:t>
-                      </a:r>
-                    </a:p>
-                  </a:txBody>
-                  <a:tcPr marL="133350" marR="133350" marT="95250" marB="95250" anchor="ctr">
-                    <a:solidFill>
-                      <a:srgbClr val="087D82"/>
-                    </a:solidFill>
-                  </a:tcPr>
-                </a:tc>
-                <a:tc>
-                  <a:txBody>
-                    <a:bodyPr/>
-                    <a:lstStyle/>
-                    <a:p>
-                      <a:r>
-                        <a:rPr sz="1800" b="1">
-                          <a:solidFill>
-                            <a:srgbClr val="FFFFFF"/>
-                          </a:solidFill>
-                          <a:latin typeface="Arial"/>
-                          <a:ea typeface="Arial"/>
-                          <a:cs typeface="Arial"/>
-                        </a:rPr>
-                        <a:t>Gap (pp)</a:t>
-                      </a:r>
-                    </a:p>
-                  </a:txBody>
-                  <a:tcPr marL="133350" marR="133350" marT="95250" marB="95250" anchor="ctr">
-                    <a:solidFill>
-                      <a:srgbClr val="087D82"/>
-                    </a:solidFill>
-                  </a:tcPr>
-                </a:tc>
-                <a:tc>
-                  <a:txBody>
-                    <a:bodyPr/>
-                    <a:lstStyle/>
-                    <a:p>
-                      <a:r>
-                        <a:rPr sz="1800" b="1">
-                          <a:solidFill>
-                            <a:srgbClr val="FFFFFF"/>
-                          </a:solidFill>
-                          <a:latin typeface="Arial"/>
-                          <a:ea typeface="Arial"/>
-                          <a:cs typeface="Arial"/>
-                        </a:rPr>
-                        <a:t>Dec. transactions</a:t>
-                      </a:r>
-                    </a:p>
-                  </a:txBody>
-                  <a:tcPr marL="133350" marR="133350" marT="95250" marB="95250" anchor="ctr">
-                    <a:solidFill>
-                      <a:srgbClr val="087D82"/>
-                    </a:solidFill>
-                  </a:tcPr>
-                </a:tc>
-              </a:tr>
-              <a:tr h="623888">
-                <a:tc>
-                  <a:txBody>
-                    <a:bodyPr/>
-                    <a:lstStyle/>
-                    <a:p>
-                      <a:pPr algn="l"/>
-                      <a:r>
-                        <a:rPr sz="1800">
-                          <a:solidFill>
-                            <a:srgbClr val="15363D"/>
-                          </a:solidFill>
-                          <a:latin typeface="Arial"/>
-                          <a:ea typeface="Arial"/>
-                          <a:cs typeface="Arial"/>
-                        </a:rPr>
-                        <a:t>Najran</a:t>
-                      </a:r>
-                    </a:p>
-                  </a:txBody>
-                  <a:tcPr marL="133350" marR="133350" marT="95250" marB="95250" anchor="ctr">
-                    <a:solidFill>
-                      <a:srgbClr val="FFFFFF"/>
-                    </a:solidFill>
-                  </a:tcPr>
-                </a:tc>
-                <a:tc>
-                  <a:txBody>
-                    <a:bodyPr/>
-                    <a:lstStyle/>
-                    <a:p>
-                      <a:pPr algn="l"/>
-                      <a:r>
-                        <a:rPr sz="1800">
-                          <a:solidFill>
-                            <a:srgbClr val="15363D"/>
-                          </a:solidFill>
-                          <a:latin typeface="Arial"/>
-                          <a:ea typeface="Arial"/>
-                          <a:cs typeface="Arial"/>
-                        </a:rPr>
-                        <a:t>58.89%</a:t>
-                      </a:r>
-                    </a:p>
-                  </a:txBody>
-                  <a:tcPr marL="133350" marR="133350" marT="95250" marB="95250" anchor="ctr">
-                    <a:solidFill>
-                      <a:srgbClr val="FFFFFF"/>
-                    </a:solidFill>
-                  </a:tcPr>
-                </a:tc>
-                <a:tc>
-                  <a:txBody>
-                    <a:bodyPr/>
-                    <a:lstStyle/>
-                    <a:p>
-                      <a:pPr algn="l"/>
-                      <a:r>
-                        <a:rPr sz="1800">
-                          <a:solidFill>
-                            <a:srgbClr val="15363D"/>
-                          </a:solidFill>
-                          <a:latin typeface="Arial"/>
-                          <a:ea typeface="Arial"/>
-                          <a:cs typeface="Arial"/>
-                        </a:rPr>
-                        <a:t>6.11</a:t>
-                      </a:r>
-                    </a:p>
-                  </a:txBody>
-                  <a:tcPr marL="133350" marR="133350" marT="95250" marB="95250" anchor="ctr">
-                    <a:solidFill>
-                      <a:srgbClr val="FFFFFF"/>
-                    </a:solidFill>
-                  </a:tcPr>
-                </a:tc>
-                <a:tc>
-                  <a:txBody>
-                    <a:bodyPr/>
-                    <a:lstStyle/>
-                    <a:p>
-                      <a:pPr algn="l"/>
-                      <a:r>
-                        <a:rPr sz="1800">
-                          <a:solidFill>
-                            <a:srgbClr val="15363D"/>
-                          </a:solidFill>
-                          <a:latin typeface="Arial"/>
-                          <a:ea typeface="Arial"/>
-                          <a:cs typeface="Arial"/>
-                        </a:rPr>
-                        <a:t>9,329</a:t>
-                      </a:r>
-                    </a:p>
-                  </a:txBody>
-                  <a:tcPr marL="133350" marR="133350" marT="95250" marB="95250" anchor="ctr">
-                    <a:solidFill>
-                      <a:srgbClr val="FFFFFF"/>
-                    </a:solidFill>
-                  </a:tcPr>
-                </a:tc>
-              </a:tr>
-              <a:tr h="623888">
-                <a:tc>
-                  <a:txBody>
-                    <a:bodyPr/>
-                    <a:lstStyle/>
-                    <a:p>
-                      <a:pPr algn="l"/>
-                      <a:r>
-                        <a:rPr sz="1800">
-                          <a:solidFill>
-                            <a:srgbClr val="15363D"/>
-                          </a:solidFill>
-                          <a:latin typeface="Arial"/>
-                          <a:ea typeface="Arial"/>
-                          <a:cs typeface="Arial"/>
-                        </a:rPr>
-                        <a:t>Jazan</a:t>
-                      </a:r>
-                    </a:p>
-                  </a:txBody>
-                  <a:tcPr marL="133350" marR="133350" marT="95250" marB="95250" anchor="ctr">
-                    <a:solidFill>
-                      <a:srgbClr val="FFFFFF"/>
-                    </a:solidFill>
-                  </a:tcPr>
-                </a:tc>
-                <a:tc>
-                  <a:txBody>
-                    <a:bodyPr/>
-                    <a:lstStyle/>
-                    <a:p>
-                      <a:pPr algn="l"/>
-                      <a:r>
-                        <a:rPr sz="1800">
-                          <a:solidFill>
-                            <a:srgbClr val="15363D"/>
-                          </a:solidFill>
-                          <a:latin typeface="Arial"/>
-                          <a:ea typeface="Arial"/>
-                          <a:cs typeface="Arial"/>
-                        </a:rPr>
-                        <a:t>60.66%</a:t>
-                      </a:r>
-                    </a:p>
-                  </a:txBody>
-                  <a:tcPr marL="133350" marR="133350" marT="95250" marB="95250" anchor="ctr">
-                    <a:solidFill>
-                      <a:srgbClr val="FFFFFF"/>
-                    </a:solidFill>
-                  </a:tcPr>
-                </a:tc>
-                <a:tc>
-                  <a:txBody>
-                    <a:bodyPr/>
-                    <a:lstStyle/>
-                    <a:p>
-                      <a:pPr algn="l"/>
-                      <a:r>
-                        <a:rPr sz="1800">
-                          <a:solidFill>
-                            <a:srgbClr val="15363D"/>
-                          </a:solidFill>
-                          <a:latin typeface="Arial"/>
-                          <a:ea typeface="Arial"/>
-                          <a:cs typeface="Arial"/>
-                        </a:rPr>
-                        <a:t>4.34</a:t>
-                      </a:r>
-                    </a:p>
-                  </a:txBody>
-                  <a:tcPr marL="133350" marR="133350" marT="95250" marB="95250" anchor="ctr">
-                    <a:solidFill>
-                      <a:srgbClr val="FFFFFF"/>
-                    </a:solidFill>
-                  </a:tcPr>
-                </a:tc>
-                <a:tc>
-                  <a:txBody>
-                    <a:bodyPr/>
-                    <a:lstStyle/>
-                    <a:p>
-                      <a:pPr algn="l"/>
-                      <a:r>
-                        <a:rPr sz="1800">
-                          <a:solidFill>
-                            <a:srgbClr val="15363D"/>
-                          </a:solidFill>
-                          <a:latin typeface="Arial"/>
-                          <a:ea typeface="Arial"/>
-                          <a:cs typeface="Arial"/>
-                        </a:rPr>
-                        <a:t>10,490</a:t>
-                      </a:r>
-                    </a:p>
-                  </a:txBody>
-                  <a:tcPr marL="133350" marR="133350" marT="95250" marB="95250" anchor="ctr">
-                    <a:solidFill>
-                      <a:srgbClr val="FFFFFF"/>
-                    </a:solidFill>
-                  </a:tcPr>
-                </a:tc>
-              </a:tr>
-              <a:tr h="623888">
-                <a:tc>
-                  <a:txBody>
-                    <a:bodyPr/>
-                    <a:lstStyle/>
-                    <a:p>
-                      <a:pPr algn="l"/>
-                      <a:r>
-                        <a:rPr sz="1800">
-                          <a:solidFill>
-                            <a:srgbClr val="15363D"/>
-                          </a:solidFill>
-                          <a:latin typeface="Arial"/>
-                          <a:ea typeface="Arial"/>
-                          <a:cs typeface="Arial"/>
-                        </a:rPr>
-                        <a:t>Northern Borders</a:t>
-                      </a:r>
-                    </a:p>
-                  </a:txBody>
-                  <a:tcPr marL="133350" marR="133350" marT="95250" marB="95250" anchor="ctr">
-                    <a:solidFill>
-                      <a:srgbClr val="FFFFFF"/>
-                    </a:solidFill>
-                  </a:tcPr>
-                </a:tc>
-                <a:tc>
-                  <a:txBody>
-                    <a:bodyPr/>
-                    <a:lstStyle/>
-                    <a:p>
-                      <a:pPr algn="l"/>
-                      <a:r>
-                        <a:rPr sz="1800">
-                          <a:solidFill>
-                            <a:srgbClr val="15363D"/>
-                          </a:solidFill>
-                          <a:latin typeface="Arial"/>
-                          <a:ea typeface="Arial"/>
-                          <a:cs typeface="Arial"/>
-                        </a:rPr>
-                        <a:t>60.91%</a:t>
-                      </a:r>
-                    </a:p>
-                  </a:txBody>
-                  <a:tcPr marL="133350" marR="133350" marT="95250" marB="95250" anchor="ctr">
-                    <a:solidFill>
-                      <a:srgbClr val="FFFFFF"/>
-                    </a:solidFill>
-                  </a:tcPr>
-                </a:tc>
-                <a:tc>
-                  <a:txBody>
-                    <a:bodyPr/>
-                    <a:lstStyle/>
-                    <a:p>
-                      <a:pPr algn="l"/>
-                      <a:r>
-                        <a:rPr sz="1800">
-                          <a:solidFill>
-                            <a:srgbClr val="15363D"/>
-                          </a:solidFill>
-                          <a:latin typeface="Arial"/>
-                          <a:ea typeface="Arial"/>
-                          <a:cs typeface="Arial"/>
-                        </a:rPr>
-                        <a:t>4.09</a:t>
-                      </a:r>
-                    </a:p>
-                  </a:txBody>
-                  <a:tcPr marL="133350" marR="133350" marT="95250" marB="95250" anchor="ctr">
-                    <a:solidFill>
-                      <a:srgbClr val="FFFFFF"/>
-                    </a:solidFill>
-                  </a:tcPr>
-                </a:tc>
-                <a:tc>
-                  <a:txBody>
-                    <a:bodyPr/>
-                    <a:lstStyle/>
-                    <a:p>
-                      <a:pPr algn="l"/>
-                      <a:r>
-                        <a:rPr sz="1800">
-                          <a:solidFill>
-                            <a:srgbClr val="15363D"/>
-                          </a:solidFill>
-                          <a:latin typeface="Arial"/>
-                          <a:ea typeface="Arial"/>
-                          <a:cs typeface="Arial"/>
-                        </a:rPr>
-                        <a:t>10,917</a:t>
-                      </a:r>
-                    </a:p>
-                  </a:txBody>
-                  <a:tcPr marL="133350" marR="133350" marT="95250" marB="95250" anchor="ctr">
-                    <a:solidFill>
-                      <a:srgbClr val="FFFFFF"/>
-                    </a:solidFill>
-                  </a:tcPr>
-                </a:tc>
-              </a:tr>
-            </a:tbl>
-          </a:graphicData>
-        </a:graphic>
-      </p:graphicFrame>
       <p:sp>
         <p:nvSpPr>
-          <p:cNvPr id="4" name="">
+          <p:cNvPr id="3" name="">
             <a:extLst xmlns:a="http://schemas.openxmlformats.org/drawingml/2006/main">
               <a:ext uri="{FF2B5EF4-FFF2-40B4-BE49-F238E27FC236}">
-                <a16:creationId xmlns:a16="http://schemas.microsoft.com/office/drawing/2014/main" id="{80FBBD96-6388-44F8-8CB6-27E3DECFA0C5}"/>
+                <a16:creationId xmlns:a16="http://schemas.microsoft.com/office/drawing/2014/main" id="{AEFDD8C9-6572-42A5-9A17-8C21152F2391}"/>
               </a:ext>
             </a:extLst>
           </p:cNvPr>
@@ -5370,8 +5710,8 @@
         </p:nvSpPr>
         <p:spPr>
           <a:xfrm xmlns:a="http://schemas.openxmlformats.org/drawingml/2006/main">
-            <a:off x="8058150" y="4305300"/>
-            <a:ext cx="3381375" cy="695325"/>
+            <a:off x="666750" y="1314450"/>
+            <a:ext cx="10858500" cy="304800"/>
           </a:xfrm>
           <a:prstGeom xmlns:a="http://schemas.openxmlformats.org/drawingml/2006/main" prst="rect">
             <a:avLst/>
@@ -5388,9 +5728,9 @@
           <a:lstStyle xmlns:a="http://schemas.openxmlformats.org/drawingml/2006/main"/>
           <a:p xmlns:a="http://schemas.openxmlformats.org/drawingml/2006/main">
             <a:pPr algn="l">
-              <a:defRPr sz="4350" b="1">
-                <a:solidFill>
-                  <a:srgbClr val="087D82"/>
+              <a:defRPr sz="1500" b="0">
+                <a:solidFill>
+                  <a:srgbClr val="56666B"/>
                 </a:solidFill>
                 <a:latin typeface="Arial"/>
                 <a:ea typeface="Arial"/>
@@ -5398,25 +5738,41 @@
               </a:defRPr>
             </a:pPr>
             <a:r>
-              <a:rPr sz="4350" b="1">
-                <a:solidFill>
-                  <a:srgbClr val="087D82"/>
+              <a:rPr sz="1500" b="0">
+                <a:solidFill>
+                  <a:srgbClr val="56666B"/>
                 </a:solidFill>
                 <a:latin typeface="Arial"/>
                 <a:ea typeface="Arial"/>
                 <a:cs typeface="Arial"/>
               </a:rPr>
-              <a:t>42.61%</a:t>
+              <a:t>December 2025 · Synthetic data · Teal: proposed pilots; orange: Al-Baha alternative</a:t>
             </a:r>
           </a:p>
         </p:txBody>
       </p:sp>
+      <p:graphicFrame>
+        <p:nvGraphicFramePr>
+          <p:cNvPr id="15" name="Chart"/>
+          <p:cNvGraphicFramePr/>
+          <p:nvPr/>
+        </p:nvGraphicFramePr>
+        <p:xfrm>
+          <a:off xmlns:a="http://schemas.openxmlformats.org/drawingml/2006/main" x="609600" y="1695450"/>
+          <a:ext xmlns:a="http://schemas.openxmlformats.org/drawingml/2006/main" cx="7286625" cy="3429000"/>
+        </p:xfrm>
+        <a:graphic xmlns:a="http://schemas.openxmlformats.org/drawingml/2006/main">
+          <a:graphicData uri="http://schemas.openxmlformats.org/drawingml/2006/chart">
+            <c:chart xmlns:r="http://schemas.openxmlformats.org/officeDocument/2006/relationships" xmlns:c="http://schemas.openxmlformats.org/drawingml/2006/chart" r:id="R0ee2318b741444a1"/>
+          </a:graphicData>
+        </a:graphic>
+      </p:graphicFrame>
       <p:sp>
         <p:nvSpPr>
           <p:cNvPr id="5" name="">
             <a:extLst xmlns:a="http://schemas.openxmlformats.org/drawingml/2006/main">
               <a:ext uri="{FF2B5EF4-FFF2-40B4-BE49-F238E27FC236}">
-                <a16:creationId xmlns:a16="http://schemas.microsoft.com/office/drawing/2014/main" id="{1FEC9349-7761-4DEB-B58B-9B945D216238}"/>
+                <a16:creationId xmlns:a16="http://schemas.microsoft.com/office/drawing/2014/main" id="{E5D22CB3-4B2B-48EE-BEA7-6602C2698A46}"/>
               </a:ext>
             </a:extLst>
           </p:cNvPr>
@@ -5427,8 +5783,8 @@
         </p:nvSpPr>
         <p:spPr>
           <a:xfrm xmlns:a="http://schemas.openxmlformats.org/drawingml/2006/main">
-            <a:off x="647700" y="4391025"/>
-            <a:ext cx="7058025" cy="866775"/>
+            <a:off x="8258175" y="1781175"/>
+            <a:ext cx="3238500" cy="790575"/>
           </a:xfrm>
           <a:prstGeom xmlns:a="http://schemas.openxmlformats.org/drawingml/2006/main" prst="rect">
             <a:avLst/>
@@ -5445,9 +5801,9 @@
           <a:lstStyle xmlns:a="http://schemas.openxmlformats.org/drawingml/2006/main"/>
           <a:p xmlns:a="http://schemas.openxmlformats.org/drawingml/2006/main">
             <a:pPr algn="l">
-              <a:defRPr sz="2100" b="1">
-                <a:solidFill>
-                  <a:srgbClr val="15363D"/>
+              <a:defRPr sz="4500" b="1">
+                <a:solidFill>
+                  <a:srgbClr val="087D82"/>
                 </a:solidFill>
                 <a:latin typeface="Arial"/>
                 <a:ea typeface="Arial"/>
@@ -5455,15 +5811,15 @@
               </a:defRPr>
             </a:pPr>
             <a:r>
-              <a:rPr sz="2100" b="1">
-                <a:solidFill>
-                  <a:srgbClr val="15363D"/>
+              <a:rPr sz="4500" b="1">
+                <a:solidFill>
+                  <a:srgbClr val="087D82"/>
                 </a:solidFill>
                 <a:latin typeface="Arial"/>
                 <a:ea typeface="Arial"/>
                 <a:cs typeface="Arial"/>
               </a:rPr>
-              <a:t>Share of the laggards’ gap × volume priority index</a:t>
+              <a:t>42.61%</a:t>
             </a:r>
           </a:p>
         </p:txBody>
@@ -5473,7 +5829,7 @@
           <p:cNvPr id="6" name="">
             <a:extLst xmlns:a="http://schemas.openxmlformats.org/drawingml/2006/main">
               <a:ext uri="{FF2B5EF4-FFF2-40B4-BE49-F238E27FC236}">
-                <a16:creationId xmlns:a16="http://schemas.microsoft.com/office/drawing/2014/main" id="{AEAB7BB8-9EAB-47EE-B628-C050A650D921}"/>
+                <a16:creationId xmlns:a16="http://schemas.microsoft.com/office/drawing/2014/main" id="{81A5C3CD-F65A-43F5-816B-973A1A28FEFC}"/>
               </a:ext>
             </a:extLst>
           </p:cNvPr>
@@ -5484,8 +5840,8 @@
         </p:nvSpPr>
         <p:spPr>
           <a:xfrm xmlns:a="http://schemas.openxmlformats.org/drawingml/2006/main">
-            <a:off x="666750" y="5391150"/>
-            <a:ext cx="10858500" cy="571500"/>
+            <a:off x="8258175" y="2714625"/>
+            <a:ext cx="3267075" cy="1000125"/>
           </a:xfrm>
           <a:prstGeom xmlns:a="http://schemas.openxmlformats.org/drawingml/2006/main" prst="rect">
             <a:avLst/>
@@ -5502,9 +5858,9 @@
           <a:lstStyle xmlns:a="http://schemas.openxmlformats.org/drawingml/2006/main"/>
           <a:p xmlns:a="http://schemas.openxmlformats.org/drawingml/2006/main">
             <a:pPr algn="l">
-              <a:defRPr sz="1950" b="0">
-                <a:solidFill>
-                  <a:srgbClr val="B45C16"/>
+              <a:defRPr sz="1950" b="1">
+                <a:solidFill>
+                  <a:srgbClr val="15363D"/>
                 </a:solidFill>
                 <a:latin typeface="Arial"/>
                 <a:ea typeface="Arial"/>
@@ -5512,15 +5868,15 @@
               </a:defRPr>
             </a:pPr>
             <a:r>
-              <a:rPr sz="1950" b="0">
-                <a:solidFill>
-                  <a:srgbClr val="B45C16"/>
+              <a:rPr sz="1950" b="1">
+                <a:solidFill>
+                  <a:srgbClr val="15363D"/>
                 </a:solidFill>
                 <a:latin typeface="Arial"/>
                 <a:ea typeface="Arial"/>
                 <a:cs typeface="Arial"/>
               </a:rPr>
-              <a:t>Metric sensitivity: transaction weighting selects Al-Baha instead of Jazan</a:t>
+              <a:t>Selected regions’ share of the laggards’ priority index</a:t>
             </a:r>
           </a:p>
         </p:txBody>
@@ -5530,7 +5886,281 @@
           <p:cNvPr id="7" name="">
             <a:extLst xmlns:a="http://schemas.openxmlformats.org/drawingml/2006/main">
               <a:ext uri="{FF2B5EF4-FFF2-40B4-BE49-F238E27FC236}">
-                <a16:creationId xmlns:a16="http://schemas.microsoft.com/office/drawing/2014/main" id="{CBEBB45D-F4C4-42BB-934E-D175BECF1F38}"/>
+                <a16:creationId xmlns:a16="http://schemas.microsoft.com/office/drawing/2014/main" id="{9191B9A5-7015-4D59-AFB8-63331D97CA2B}"/>
+              </a:ext>
+            </a:extLst>
+          </p:cNvPr>
+          <p:cNvSpPr>
+            <a:spLocks xmlns:a="http://schemas.openxmlformats.org/drawingml/2006/main" noGrp="1"/>
+          </p:cNvSpPr>
+          <p:nvPr/>
+        </p:nvSpPr>
+        <p:spPr>
+          <a:xfrm xmlns:a="http://schemas.openxmlformats.org/drawingml/2006/main">
+            <a:off x="8258175" y="3743325"/>
+            <a:ext cx="3267075" cy="323850"/>
+          </a:xfrm>
+          <a:prstGeom xmlns:a="http://schemas.openxmlformats.org/drawingml/2006/main" prst="rect">
+            <a:avLst/>
+          </a:prstGeom>
+          <a:noFill xmlns:a="http://schemas.openxmlformats.org/drawingml/2006/main"/>
+          <a:ln xmlns:a="http://schemas.openxmlformats.org/drawingml/2006/main" w="0">
+            <a:noFill/>
+          </a:ln>
+        </p:spPr>
+        <p:txBody>
+          <a:bodyPr xmlns:a="http://schemas.openxmlformats.org/drawingml/2006/main">
+            <a:noAutofit/>
+          </a:bodyPr>
+          <a:lstStyle xmlns:a="http://schemas.openxmlformats.org/drawingml/2006/main"/>
+          <a:p xmlns:a="http://schemas.openxmlformats.org/drawingml/2006/main">
+            <a:pPr algn="l">
+              <a:defRPr sz="1725" b="1">
+                <a:solidFill>
+                  <a:srgbClr val="15363D"/>
+                </a:solidFill>
+                <a:latin typeface="Arial"/>
+                <a:ea typeface="Arial"/>
+                <a:cs typeface="Arial"/>
+              </a:defRPr>
+            </a:pPr>
+            <a:r>
+              <a:rPr sz="1725" b="1">
+                <a:solidFill>
+                  <a:srgbClr val="15363D"/>
+                </a:solidFill>
+                <a:latin typeface="Arial"/>
+                <a:ea typeface="Arial"/>
+                <a:cs typeface="Arial"/>
+              </a:rPr>
+              <a:t>Target gaps (pp)</a:t>
+            </a:r>
+          </a:p>
+        </p:txBody>
+      </p:sp>
+      <p:sp>
+        <p:nvSpPr>
+          <p:cNvPr id="8" name="">
+            <a:extLst xmlns:a="http://schemas.openxmlformats.org/drawingml/2006/main">
+              <a:ext uri="{FF2B5EF4-FFF2-40B4-BE49-F238E27FC236}">
+                <a16:creationId xmlns:a16="http://schemas.microsoft.com/office/drawing/2014/main" id="{C7EC6B86-2921-4E9D-A2B9-BDC0A6EF86DC}"/>
+              </a:ext>
+            </a:extLst>
+          </p:cNvPr>
+          <p:cNvSpPr>
+            <a:spLocks xmlns:a="http://schemas.openxmlformats.org/drawingml/2006/main" noGrp="1"/>
+          </p:cNvSpPr>
+          <p:nvPr/>
+        </p:nvSpPr>
+        <p:spPr>
+          <a:xfrm xmlns:a="http://schemas.openxmlformats.org/drawingml/2006/main">
+            <a:off x="8258175" y="4162425"/>
+            <a:ext cx="3267075" cy="904875"/>
+          </a:xfrm>
+          <a:prstGeom xmlns:a="http://schemas.openxmlformats.org/drawingml/2006/main" prst="rect">
+            <a:avLst/>
+          </a:prstGeom>
+          <a:noFill xmlns:a="http://schemas.openxmlformats.org/drawingml/2006/main"/>
+          <a:ln xmlns:a="http://schemas.openxmlformats.org/drawingml/2006/main" w="0">
+            <a:noFill/>
+          </a:ln>
+        </p:spPr>
+        <p:txBody>
+          <a:bodyPr xmlns:a="http://schemas.openxmlformats.org/drawingml/2006/main">
+            <a:noAutofit/>
+          </a:bodyPr>
+          <a:lstStyle xmlns:a="http://schemas.openxmlformats.org/drawingml/2006/main"/>
+          <a:p xmlns:a="http://schemas.openxmlformats.org/drawingml/2006/main">
+            <a:pPr algn="l">
+              <a:defRPr sz="1725" b="0">
+                <a:solidFill>
+                  <a:srgbClr val="15363D"/>
+                </a:solidFill>
+                <a:latin typeface="Arial"/>
+                <a:ea typeface="Arial"/>
+                <a:cs typeface="Arial"/>
+              </a:defRPr>
+            </a:pPr>
+            <a:r>
+              <a:rPr sz="1725" b="0">
+                <a:solidFill>
+                  <a:srgbClr val="15363D"/>
+                </a:solidFill>
+                <a:latin typeface="Arial"/>
+                <a:ea typeface="Arial"/>
+                <a:cs typeface="Arial"/>
+              </a:rPr>
+              <a:t>Najran 6.11</a:t>
+            </a:r>
+          </a:p>
+          <a:p xmlns:a="http://schemas.openxmlformats.org/drawingml/2006/main">
+            <a:pPr algn="l">
+              <a:defRPr sz="1725" b="0">
+                <a:solidFill>
+                  <a:srgbClr val="15363D"/>
+                </a:solidFill>
+                <a:latin typeface="Arial"/>
+                <a:ea typeface="Arial"/>
+                <a:cs typeface="Arial"/>
+              </a:defRPr>
+            </a:pPr>
+            <a:r>
+              <a:rPr sz="1725" b="0">
+                <a:solidFill>
+                  <a:srgbClr val="15363D"/>
+                </a:solidFill>
+                <a:latin typeface="Arial"/>
+                <a:ea typeface="Arial"/>
+                <a:cs typeface="Arial"/>
+              </a:rPr>
+              <a:t>Jazan 4.34</a:t>
+            </a:r>
+          </a:p>
+          <a:p xmlns:a="http://schemas.openxmlformats.org/drawingml/2006/main">
+            <a:pPr algn="l">
+              <a:defRPr sz="1725" b="0">
+                <a:solidFill>
+                  <a:srgbClr val="15363D"/>
+                </a:solidFill>
+                <a:latin typeface="Arial"/>
+                <a:ea typeface="Arial"/>
+                <a:cs typeface="Arial"/>
+              </a:defRPr>
+            </a:pPr>
+            <a:r>
+              <a:rPr sz="1725" b="0">
+                <a:solidFill>
+                  <a:srgbClr val="15363D"/>
+                </a:solidFill>
+                <a:latin typeface="Arial"/>
+                <a:ea typeface="Arial"/>
+                <a:cs typeface="Arial"/>
+              </a:rPr>
+              <a:t>Northern Borders 4.09</a:t>
+            </a:r>
+          </a:p>
+        </p:txBody>
+      </p:sp>
+      <p:sp>
+        <p:nvSpPr>
+          <p:cNvPr id="9" name="">
+            <a:extLst xmlns:a="http://schemas.openxmlformats.org/drawingml/2006/main">
+              <a:ext uri="{FF2B5EF4-FFF2-40B4-BE49-F238E27FC236}">
+                <a16:creationId xmlns:a16="http://schemas.microsoft.com/office/drawing/2014/main" id="{A79C8FAF-3B1D-4153-BCDB-3BD29FF76901}"/>
+              </a:ext>
+            </a:extLst>
+          </p:cNvPr>
+          <p:cNvSpPr>
+            <a:spLocks xmlns:a="http://schemas.openxmlformats.org/drawingml/2006/main" noGrp="1"/>
+          </p:cNvSpPr>
+          <p:nvPr/>
+        </p:nvSpPr>
+        <p:spPr>
+          <a:xfrm xmlns:a="http://schemas.openxmlformats.org/drawingml/2006/main">
+            <a:off x="666750" y="5219700"/>
+            <a:ext cx="10858500" cy="381000"/>
+          </a:xfrm>
+          <a:prstGeom xmlns:a="http://schemas.openxmlformats.org/drawingml/2006/main" prst="rect">
+            <a:avLst/>
+          </a:prstGeom>
+          <a:noFill xmlns:a="http://schemas.openxmlformats.org/drawingml/2006/main"/>
+          <a:ln xmlns:a="http://schemas.openxmlformats.org/drawingml/2006/main" w="0">
+            <a:noFill/>
+          </a:ln>
+        </p:spPr>
+        <p:txBody>
+          <a:bodyPr xmlns:a="http://schemas.openxmlformats.org/drawingml/2006/main">
+            <a:noAutofit/>
+          </a:bodyPr>
+          <a:lstStyle xmlns:a="http://schemas.openxmlformats.org/drawingml/2006/main"/>
+          <a:p xmlns:a="http://schemas.openxmlformats.org/drawingml/2006/main">
+            <a:pPr algn="l">
+              <a:defRPr sz="1725" b="0">
+                <a:solidFill>
+                  <a:srgbClr val="56666B"/>
+                </a:solidFill>
+                <a:latin typeface="Arial"/>
+                <a:ea typeface="Arial"/>
+                <a:cs typeface="Arial"/>
+              </a:defRPr>
+            </a:pPr>
+            <a:r>
+              <a:rPr sz="1725" b="0">
+                <a:solidFill>
+                  <a:srgbClr val="56666B"/>
+                </a:solidFill>
+                <a:latin typeface="Arial"/>
+                <a:ea typeface="Arial"/>
+                <a:cs typeface="Arial"/>
+              </a:rPr>
+              <a:t>Priority proxy = positive gap / 100 × December transactions; not a conversion count</a:t>
+            </a:r>
+          </a:p>
+        </p:txBody>
+      </p:sp>
+      <p:sp>
+        <p:nvSpPr>
+          <p:cNvPr id="10" name="">
+            <a:extLst xmlns:a="http://schemas.openxmlformats.org/drawingml/2006/main">
+              <a:ext uri="{FF2B5EF4-FFF2-40B4-BE49-F238E27FC236}">
+                <a16:creationId xmlns:a16="http://schemas.microsoft.com/office/drawing/2014/main" id="{85CDD235-10CE-40E7-8BC0-CBD2BD36B5D0}"/>
+              </a:ext>
+            </a:extLst>
+          </p:cNvPr>
+          <p:cNvSpPr>
+            <a:spLocks xmlns:a="http://schemas.openxmlformats.org/drawingml/2006/main" noGrp="1"/>
+          </p:cNvSpPr>
+          <p:nvPr/>
+        </p:nvSpPr>
+        <p:spPr>
+          <a:xfrm xmlns:a="http://schemas.openxmlformats.org/drawingml/2006/main">
+            <a:off x="666750" y="5638800"/>
+            <a:ext cx="10858500" cy="381000"/>
+          </a:xfrm>
+          <a:prstGeom xmlns:a="http://schemas.openxmlformats.org/drawingml/2006/main" prst="rect">
+            <a:avLst/>
+          </a:prstGeom>
+          <a:noFill xmlns:a="http://schemas.openxmlformats.org/drawingml/2006/main"/>
+          <a:ln xmlns:a="http://schemas.openxmlformats.org/drawingml/2006/main" w="0">
+            <a:noFill/>
+          </a:ln>
+        </p:spPr>
+        <p:txBody>
+          <a:bodyPr xmlns:a="http://schemas.openxmlformats.org/drawingml/2006/main">
+            <a:noAutofit/>
+          </a:bodyPr>
+          <a:lstStyle xmlns:a="http://schemas.openxmlformats.org/drawingml/2006/main"/>
+          <a:p xmlns:a="http://schemas.openxmlformats.org/drawingml/2006/main">
+            <a:pPr algn="l">
+              <a:defRPr sz="2025" b="1">
+                <a:solidFill>
+                  <a:srgbClr val="B45C16"/>
+                </a:solidFill>
+                <a:latin typeface="Arial"/>
+                <a:ea typeface="Arial"/>
+                <a:cs typeface="Arial"/>
+              </a:defRPr>
+            </a:pPr>
+            <a:r>
+              <a:rPr sz="2025" b="1">
+                <a:solidFill>
+                  <a:srgbClr val="B45C16"/>
+                </a:solidFill>
+                <a:latin typeface="Arial"/>
+                <a:ea typeface="Arial"/>
+                <a:cs typeface="Arial"/>
+              </a:rPr>
+              <a:t>Near tie: Northern Borders 446.26 vs Al-Baha 445.60</a:t>
+            </a:r>
+          </a:p>
+        </p:txBody>
+      </p:sp>
+      <p:sp>
+        <p:nvSpPr>
+          <p:cNvPr id="11" name="">
+            <a:extLst xmlns:a="http://schemas.openxmlformats.org/drawingml/2006/main">
+              <a:ext uri="{FF2B5EF4-FFF2-40B4-BE49-F238E27FC236}">
+                <a16:creationId xmlns:a16="http://schemas.microsoft.com/office/drawing/2014/main" id="{53CDFA12-F057-43BD-AA46-B78FA7E8639A}"/>
               </a:ext>
             </a:extLst>
           </p:cNvPr>
@@ -5577,7 +6207,7 @@
                 <a:ea typeface="Arial"/>
                 <a:cs typeface="Arial"/>
               </a:rPr>
-              <a:t>The priority index is a proxy, not a conversion count. Agree the metric before scaling.</a:t>
+              <a:t>Metric sensitivity: transaction weighting selects Al-Baha instead of Jazan. Agree the definition before release.</a:t>
             </a:r>
           </a:p>
         </p:txBody>
@@ -5585,7 +6215,7 @@
     </p:spTree>
     <p:extLst>
       <p:ext uri="{BB962C8B-B14F-4D97-AF65-F5344CB8AC3E}">
-        <p14:creationId xmlns:p14="http://schemas.microsoft.com/office/powerpoint/2010/main" val="404555915"/>
+        <p14:creationId xmlns:p14="http://schemas.microsoft.com/office/powerpoint/2010/main" val="1288161498"/>
       </p:ext>
     </p:extLst>
   </p:cSld>
@@ -5616,7 +6246,7 @@
           <p:cNvPr id="6" name="">
             <a:extLst xmlns:a="http://schemas.openxmlformats.org/drawingml/2006/main">
               <a:ext uri="{FF2B5EF4-FFF2-40B4-BE49-F238E27FC236}">
-                <a16:creationId xmlns:a16="http://schemas.microsoft.com/office/drawing/2014/main" id="{6C939096-F75D-4895-B1DD-F55DA26723E4}"/>
+                <a16:creationId xmlns:a16="http://schemas.microsoft.com/office/drawing/2014/main" id="{E86C3462-5FFA-4B48-95D6-D2C9AD24382D}"/>
               </a:ext>
             </a:extLst>
           </p:cNvPr>
@@ -5673,7 +6303,7 @@
           <p:cNvPr id="2" name="">
             <a:extLst xmlns:a="http://schemas.openxmlformats.org/drawingml/2006/main">
               <a:ext uri="{FF2B5EF4-FFF2-40B4-BE49-F238E27FC236}">
-                <a16:creationId xmlns:a16="http://schemas.microsoft.com/office/drawing/2014/main" id="{608551EF-EEDD-4A08-88E2-34DCCC4D712F}"/>
+                <a16:creationId xmlns:a16="http://schemas.microsoft.com/office/drawing/2014/main" id="{4F8DBCE7-C509-49D3-8CF0-E71CDF58A6B4}"/>
               </a:ext>
             </a:extLst>
           </p:cNvPr>
@@ -5884,7 +6514,7 @@
                           <a:ea typeface="Arial"/>
                           <a:cs typeface="Arial"/>
                         </a:rPr>
-                        <a:t>SAR 4.44M per lagging region</a:t>
+                        <a:t>SAR 40M ÷ 9 (about 4.44M each)</a:t>
                       </a:r>
                     </a:p>
                   </a:txBody>
@@ -6158,7 +6788,7 @@
           <p:cNvPr id="4" name="">
             <a:extLst xmlns:a="http://schemas.openxmlformats.org/drawingml/2006/main">
               <a:ext uri="{FF2B5EF4-FFF2-40B4-BE49-F238E27FC236}">
-                <a16:creationId xmlns:a16="http://schemas.microsoft.com/office/drawing/2014/main" id="{F207ACC0-73B9-4126-B76F-86521F1D3A27}"/>
+                <a16:creationId xmlns:a16="http://schemas.microsoft.com/office/drawing/2014/main" id="{5751C20D-A16E-4AF2-A718-BD2C39BD04B1}"/>
               </a:ext>
             </a:extLst>
           </p:cNvPr>
@@ -6205,7 +6835,7 @@
                 <a:ea typeface="Arial"/>
                 <a:cs typeface="Arial"/>
               </a:rPr>
-              <a:t>Selected: release SAR 10M initially; hold SAR 30M subject to evidence</a:t>
+              <a:t>Selected: SAR 10M after baseline approval; hold SAR 30M for review</a:t>
             </a:r>
           </a:p>
         </p:txBody>
@@ -6215,7 +6845,7 @@
           <p:cNvPr id="5" name="">
             <a:extLst xmlns:a="http://schemas.openxmlformats.org/drawingml/2006/main">
               <a:ext uri="{FF2B5EF4-FFF2-40B4-BE49-F238E27FC236}">
-                <a16:creationId xmlns:a16="http://schemas.microsoft.com/office/drawing/2014/main" id="{E0C6D61B-DE57-4C8B-8BF2-940049E2E1CF}"/>
+                <a16:creationId xmlns:a16="http://schemas.microsoft.com/office/drawing/2014/main" id="{F518F815-63C2-4945-9E6A-E51F7009A6BF}"/>
               </a:ext>
             </a:extLst>
           </p:cNvPr>
@@ -6270,7 +6900,7 @@
     </p:spTree>
     <p:extLst>
       <p:ext uri="{BB962C8B-B14F-4D97-AF65-F5344CB8AC3E}">
-        <p14:creationId xmlns:p14="http://schemas.microsoft.com/office/powerpoint/2010/main" val="127954788"/>
+        <p14:creationId xmlns:p14="http://schemas.microsoft.com/office/powerpoint/2010/main" val="1445886591"/>
       </p:ext>
     </p:extLst>
   </p:cSld>
@@ -6301,7 +6931,7 @@
           <p:cNvPr id="8" name="">
             <a:extLst xmlns:a="http://schemas.openxmlformats.org/drawingml/2006/main">
               <a:ext uri="{FF2B5EF4-FFF2-40B4-BE49-F238E27FC236}">
-                <a16:creationId xmlns:a16="http://schemas.microsoft.com/office/drawing/2014/main" id="{18081F9C-8375-43D3-BA79-464901814C13}"/>
+                <a16:creationId xmlns:a16="http://schemas.microsoft.com/office/drawing/2014/main" id="{3C5E4A73-A308-4C43-B5E9-AEEBA1EE5093}"/>
               </a:ext>
             </a:extLst>
           </p:cNvPr>
@@ -6358,7 +6988,7 @@
           <p:cNvPr id="2" name="">
             <a:extLst xmlns:a="http://schemas.openxmlformats.org/drawingml/2006/main">
               <a:ext uri="{FF2B5EF4-FFF2-40B4-BE49-F238E27FC236}">
-                <a16:creationId xmlns:a16="http://schemas.microsoft.com/office/drawing/2014/main" id="{3F3B6BB1-3ED2-4738-AEF7-F8013004D916}"/>
+                <a16:creationId xmlns:a16="http://schemas.microsoft.com/office/drawing/2014/main" id="{028D8642-0DF6-43F7-AE2B-D2A7AA0DCCA1}"/>
               </a:ext>
             </a:extLst>
           </p:cNvPr>
@@ -6747,7 +7377,7 @@
           <p:cNvPr id="4" name="">
             <a:extLst xmlns:a="http://schemas.openxmlformats.org/drawingml/2006/main">
               <a:ext uri="{FF2B5EF4-FFF2-40B4-BE49-F238E27FC236}">
-                <a16:creationId xmlns:a16="http://schemas.microsoft.com/office/drawing/2014/main" id="{E5751693-111B-4E56-A834-AD93472537ED}"/>
+                <a16:creationId xmlns:a16="http://schemas.microsoft.com/office/drawing/2014/main" id="{ECD8D605-77A6-4C3F-AD6E-CF4F03D20FE4}"/>
               </a:ext>
             </a:extLst>
           </p:cNvPr>
@@ -6804,7 +7434,7 @@
           <p:cNvPr id="5" name="">
             <a:extLst xmlns:a="http://schemas.openxmlformats.org/drawingml/2006/main">
               <a:ext uri="{FF2B5EF4-FFF2-40B4-BE49-F238E27FC236}">
-                <a16:creationId xmlns:a16="http://schemas.microsoft.com/office/drawing/2014/main" id="{20081B41-95E9-4A46-AA26-E1D0F1A74A76}"/>
+                <a16:creationId xmlns:a16="http://schemas.microsoft.com/office/drawing/2014/main" id="{07DCED5D-1D46-4AAA-B821-8D7FE0F53FA8}"/>
               </a:ext>
             </a:extLst>
           </p:cNvPr>
@@ -6861,7 +7491,7 @@
           <p:cNvPr id="6" name="">
             <a:extLst xmlns:a="http://schemas.openxmlformats.org/drawingml/2006/main">
               <a:ext uri="{FF2B5EF4-FFF2-40B4-BE49-F238E27FC236}">
-                <a16:creationId xmlns:a16="http://schemas.microsoft.com/office/drawing/2014/main" id="{1035B21B-294F-468D-ACC4-430D0E7F0376}"/>
+                <a16:creationId xmlns:a16="http://schemas.microsoft.com/office/drawing/2014/main" id="{77348F27-E7B6-4C2F-A7DF-C3E8F33FC73D}"/>
               </a:ext>
             </a:extLst>
           </p:cNvPr>
@@ -6918,7 +7548,7 @@
           <p:cNvPr id="7" name="">
             <a:extLst xmlns:a="http://schemas.openxmlformats.org/drawingml/2006/main">
               <a:ext uri="{FF2B5EF4-FFF2-40B4-BE49-F238E27FC236}">
-                <a16:creationId xmlns:a16="http://schemas.microsoft.com/office/drawing/2014/main" id="{FB53F53F-4E04-4392-BD23-EA427E009D30}"/>
+                <a16:creationId xmlns:a16="http://schemas.microsoft.com/office/drawing/2014/main" id="{9249E49A-3C97-4618-9AB3-D7B0A07379C2}"/>
               </a:ext>
             </a:extLst>
           </p:cNvPr>
@@ -6973,7 +7603,7 @@
     </p:spTree>
     <p:extLst>
       <p:ext uri="{BB962C8B-B14F-4D97-AF65-F5344CB8AC3E}">
-        <p14:creationId xmlns:p14="http://schemas.microsoft.com/office/powerpoint/2010/main" val="1048893505"/>
+        <p14:creationId xmlns:p14="http://schemas.microsoft.com/office/powerpoint/2010/main" val="453127683"/>
       </p:ext>
     </p:extLst>
   </p:cSld>
@@ -7004,7 +7634,7 @@
           <p:cNvPr id="7" name="">
             <a:extLst xmlns:a="http://schemas.openxmlformats.org/drawingml/2006/main">
               <a:ext uri="{FF2B5EF4-FFF2-40B4-BE49-F238E27FC236}">
-                <a16:creationId xmlns:a16="http://schemas.microsoft.com/office/drawing/2014/main" id="{C2A30759-37B4-41AF-9F63-B58CBCEF02DC}"/>
+                <a16:creationId xmlns:a16="http://schemas.microsoft.com/office/drawing/2014/main" id="{E32D67B9-CBB8-4559-9F60-F07681910B4B}"/>
               </a:ext>
             </a:extLst>
           </p:cNvPr>
@@ -7061,7 +7691,7 @@
           <p:cNvPr id="2" name="">
             <a:extLst xmlns:a="http://schemas.openxmlformats.org/drawingml/2006/main">
               <a:ext uri="{FF2B5EF4-FFF2-40B4-BE49-F238E27FC236}">
-                <a16:creationId xmlns:a16="http://schemas.microsoft.com/office/drawing/2014/main" id="{3D724C94-E024-4D78-A852-C47B7EF3B39C}"/>
+                <a16:creationId xmlns:a16="http://schemas.microsoft.com/office/drawing/2014/main" id="{4E45553F-5A90-4136-BD0D-5E403FEB0DB0}"/>
               </a:ext>
             </a:extLst>
           </p:cNvPr>
@@ -7118,7 +7748,7 @@
           <p:cNvPr id="3" name="">
             <a:extLst xmlns:a="http://schemas.openxmlformats.org/drawingml/2006/main">
               <a:ext uri="{FF2B5EF4-FFF2-40B4-BE49-F238E27FC236}">
-                <a16:creationId xmlns:a16="http://schemas.microsoft.com/office/drawing/2014/main" id="{B2CD6D9A-3C94-4653-B6C9-FAE1D9F54060}"/>
+                <a16:creationId xmlns:a16="http://schemas.microsoft.com/office/drawing/2014/main" id="{8E639767-9BF4-43F2-B0DC-04EAA00949C7}"/>
               </a:ext>
             </a:extLst>
           </p:cNvPr>
@@ -7165,7 +7795,7 @@
                 <a:ea typeface="Arial"/>
                 <a:cs typeface="Arial"/>
               </a:rPr>
-              <a:t>Approve SAR 40M; release SAR 10M for pilots</a:t>
+              <a:t>Approve SAR 40M; pilot SAR 10M after baseline approval</a:t>
             </a:r>
           </a:p>
         </p:txBody>
@@ -7279,7 +7909,7 @@
                           <a:ea typeface="Arial"/>
                           <a:cs typeface="Arial"/>
                         </a:rPr>
-                        <a:t>Name an owner and launch pilots in the three regions</a:t>
+                        <a:t>Approve the envelope and name an accountable owner</a:t>
                       </a:r>
                     </a:p>
                   </a:txBody>
@@ -7331,7 +7961,7 @@
                           <a:ea typeface="Arial"/>
                           <a:cs typeface="Arial"/>
                         </a:rPr>
-                        <a:t>Agree the metric, baseline, service plans and cost</a:t>
+                        <a:t>Approve metric, baseline, comparison and cost; then launch pilots</a:t>
                       </a:r>
                     </a:p>
                   </a:txBody>
@@ -7403,7 +8033,7 @@
           <p:cNvPr id="5" name="">
             <a:extLst xmlns:a="http://schemas.openxmlformats.org/drawingml/2006/main">
               <a:ext uri="{FF2B5EF4-FFF2-40B4-BE49-F238E27FC236}">
-                <a16:creationId xmlns:a16="http://schemas.microsoft.com/office/drawing/2014/main" id="{6661812C-1130-402C-B25C-F65FA97770F3}"/>
+                <a16:creationId xmlns:a16="http://schemas.microsoft.com/office/drawing/2014/main" id="{E2884387-F6CC-40D7-85AF-25631369838C}"/>
               </a:ext>
             </a:extLst>
           </p:cNvPr>
@@ -7460,7 +8090,7 @@
           <p:cNvPr id="6" name="">
             <a:extLst xmlns:a="http://schemas.openxmlformats.org/drawingml/2006/main">
               <a:ext uri="{FF2B5EF4-FFF2-40B4-BE49-F238E27FC236}">
-                <a16:creationId xmlns:a16="http://schemas.microsoft.com/office/drawing/2014/main" id="{A4952A5B-CBC8-43E0-9A21-ADFE8924D2CF}"/>
+                <a16:creationId xmlns:a16="http://schemas.microsoft.com/office/drawing/2014/main" id="{3B1DEB09-3ED7-4C6C-9DD9-6F076883B95C}"/>
               </a:ext>
             </a:extLst>
           </p:cNvPr>
@@ -7515,7 +8145,7 @@
     </p:spTree>
     <p:extLst>
       <p:ext uri="{BB962C8B-B14F-4D97-AF65-F5344CB8AC3E}">
-        <p14:creationId xmlns:p14="http://schemas.microsoft.com/office/powerpoint/2010/main" val="1522917063"/>
+        <p14:creationId xmlns:p14="http://schemas.microsoft.com/office/powerpoint/2010/main" val="1907179640"/>
       </p:ext>
     </p:extLst>
   </p:cSld>

</xml_diff>

<commit_message>
Remove team divisions and make project documentation English
</commit_message>
<xml_diff>
--- a/deliverables/Tayseer_Executive_Story_Final.pptx
+++ b/deliverables/Tayseer_Executive_Story_Final.pptx
@@ -2,19 +2,19 @@
 <file path=ppt/presentation.xml><?xml version="1.0" encoding="utf-8"?>
 <p:presentation xmlns:p="http://schemas.openxmlformats.org/presentationml/2006/main">
   <p:sldMasterIdLst>
-    <p:sldMasterId xmlns:r="http://schemas.openxmlformats.org/officeDocument/2006/relationships" id="2147483648" r:id="R80fb10a058ac4ec3"/>
+    <p:sldMasterId xmlns:r="http://schemas.openxmlformats.org/officeDocument/2006/relationships" id="2147483648" r:id="R7864572e29e04b7e"/>
   </p:sldMasterIdLst>
   <p:notesMasterIdLst>
-    <p:notesMasterId xmlns:r="http://schemas.openxmlformats.org/officeDocument/2006/relationships" r:id="Reb4f4f135c7e4768"/>
+    <p:notesMasterId xmlns:r="http://schemas.openxmlformats.org/officeDocument/2006/relationships" r:id="R078d44b5b6d443a8"/>
   </p:notesMasterIdLst>
   <p:sldIdLst>
-    <p:sldId xmlns:r="http://schemas.openxmlformats.org/officeDocument/2006/relationships" id="256" r:id="R8b8e0217f6034f02"/>
-    <p:sldId xmlns:r="http://schemas.openxmlformats.org/officeDocument/2006/relationships" id="257" r:id="Rfcfe55276c8c40d7"/>
-    <p:sldId xmlns:r="http://schemas.openxmlformats.org/officeDocument/2006/relationships" id="258" r:id="Rdf157a29358e4619"/>
-    <p:sldId xmlns:r="http://schemas.openxmlformats.org/officeDocument/2006/relationships" id="259" r:id="R1248759c39b84b4a"/>
-    <p:sldId xmlns:r="http://schemas.openxmlformats.org/officeDocument/2006/relationships" id="260" r:id="R004c43fb0a7148f4"/>
-    <p:sldId xmlns:r="http://schemas.openxmlformats.org/officeDocument/2006/relationships" id="261" r:id="R3207b468a0214f3e"/>
-    <p:sldId xmlns:r="http://schemas.openxmlformats.org/officeDocument/2006/relationships" id="262" r:id="R35c3c4aeaf9f45a3"/>
+    <p:sldId xmlns:r="http://schemas.openxmlformats.org/officeDocument/2006/relationships" id="256" r:id="R0c3858244f0946db"/>
+    <p:sldId xmlns:r="http://schemas.openxmlformats.org/officeDocument/2006/relationships" id="257" r:id="Rc4cb11010df54fbf"/>
+    <p:sldId xmlns:r="http://schemas.openxmlformats.org/officeDocument/2006/relationships" id="258" r:id="Rdf2b1bc1ab08442d"/>
+    <p:sldId xmlns:r="http://schemas.openxmlformats.org/officeDocument/2006/relationships" id="259" r:id="R8d7e3e4d251e4dfa"/>
+    <p:sldId xmlns:r="http://schemas.openxmlformats.org/officeDocument/2006/relationships" id="260" r:id="Rf5d872fb3e17471e"/>
+    <p:sldId xmlns:r="http://schemas.openxmlformats.org/officeDocument/2006/relationships" id="261" r:id="R6c5e60b06c234b12"/>
+    <p:sldId xmlns:r="http://schemas.openxmlformats.org/officeDocument/2006/relationships" id="262" r:id="R2fc8cffacfc24624"/>
   </p:sldIdLst>
   <p:sldSz cx="12192000" cy="6858000"/>
   <p:notesSz cx="6858000" cy="9144000"/>
@@ -448,12 +448,7 @@
           <a:lstStyle xmlns:a="http://schemas.openxmlformats.org/drawingml/2006/main"/>
           <a:p xmlns:a="http://schemas.openxmlformats.org/drawingml/2006/main">
             <a:r>
-              <a:t>Abdulelah @c3bod</a:t>
-            </a:r>
-          </a:p>
-          <a:p xmlns:a="http://schemas.openxmlformats.org/drawingml/2006/main">
-            <a:r>
-              <a:t>BLUF/Ask. 0:00–0:30. State the complete request immediately. Approve SAR40M; release initialSAR10M only after approval of metric, baseline, comparison design, service plans and cost; holdSAR30M for review. Big Idea: target the adoption gap with phased funding, validating the metric and demand before any intervention or release.</a:t>
+              <a:t>BLUF/Ask. State the complete request immediately. Approve SAR 40M; release initial SAR 10M only after approval of metric, baseline, comparison design, service plans and cost; hold SAR 30M for review. Big Idea: target the adoption gap with phased funding, validating the metric and demand before any intervention or release.</a:t>
             </a:r>
           </a:p>
           <a:p xmlns:a="http://schemas.openxmlformats.org/drawingml/2006/main">
@@ -553,12 +548,7 @@
           <a:lstStyle xmlns:a="http://schemas.openxmlformats.org/drawingml/2006/main"/>
           <a:p xmlns:a="http://schemas.openxmlformats.org/drawingml/2006/main">
             <a:r>
-              <a:t>Abdulelah @c3bod</a:t>
-            </a:r>
-          </a:p>
-          <a:p xmlns:a="http://schemas.openxmlformats.org/drawingml/2006/main">
-            <a:r>
-              <a:t>Situation. 0:30–1:15. Orient the audience to monthly dates, a 0–100% axis and the 65% target. January 2022: 51.40%; December 2025: 63.33%; increase: 11.93 percentage points. No unsupported date for future target attainment.</a:t>
+              <a:t>Situation. Orient the audience to monthly dates, a 0–100% axis and the 65% target. January 2022: 51.40%; December 2025: 63.33%; increase: 11.93 percentage points. No unsupported date for future target attainment.</a:t>
             </a:r>
           </a:p>
           <a:p xmlns:a="http://schemas.openxmlformats.org/drawingml/2006/main">
@@ -658,12 +648,7 @@
           <a:lstStyle xmlns:a="http://schemas.openxmlformats.org/drawingml/2006/main"/>
           <a:p xmlns:a="http://schemas.openxmlformats.org/drawingml/2006/main">
             <a:r>
-              <a:t>Sanad @SanadAlkhamali</a:t>
-            </a:r>
-          </a:p>
-          <a:p xmlns:a="http://schemas.openxmlformats.org/drawingml/2006/main">
-            <a:r>
-              <a:t>Complication. 1:15–2:00. Orient to horizontal region bars, 0–100% scale, December 2025 and 65% reference. Nine below and four at/above target. Najran is lowest at 58.89%. Funding requires both gap and activity, not the lowest rate alone. Orange reference is 65%.</a:t>
+              <a:t>Complication. Orient to horizontal region bars, 0–100% scale, December 2025 and 65% reference. Nine below and four at/above target. Najran is lowest at 58.89%. Funding requires both gap and activity, not the lowest rate alone. Orange reference is 65%.</a:t>
             </a:r>
           </a:p>
           <a:p xmlns:a="http://schemas.openxmlformats.org/drawingml/2006/main">
@@ -763,12 +748,7 @@
           <a:lstStyle xmlns:a="http://schemas.openxmlformats.org/drawingml/2006/main"/>
           <a:p xmlns:a="http://schemas.openxmlformats.org/drawingml/2006/main">
             <a:r>
-              <a:t>Sanad @SanadAlkhamali</a:t>
-            </a:r>
-          </a:p>
-          <a:p xmlns:a="http://schemas.openxmlformats.org/drawingml/2006/main">
-            <a:r>
-              <a:t>Evidence. 2:00–4:00. Orient to December 2025, nine region bars, the 0–600 priority index and the target-gap annotations. Index = max(65 - regional arithmetic mean, 0)/100 × latest-month transactions. Scores: Najran 570.1185, Jazan 455.0824, Northern Borders 446.2597, Al-Baha 445.6012. Third and fourth differ by only 0.6585 index units; that is not a robust separation. Combined top-three share of nine laggard priority scores: 42.6146%. Alternative transaction weighting gives national 66.1186% and ranks Najran, Northern Borders, Al-Baha. These are material sensitivities. Fix the metric and validate demand before scaling. Descriptive data do not prove causes or returns. Chart uses source CSV and the workbook field definitions; it is not a Tableau-export screenshot.</a:t>
+              <a:t>Evidence. Orient to December 2025, nine region bars, the 0–600 priority index and the target-gap annotations. Index = max(65 - regional arithmetic mean, 0)/100 × latest-month transactions. Scores: Najran 570.1185, Jazan 455.0824, Northern Borders 446.2597, Al-Baha 445.6012. Third and fourth differ by only 0.6585 index units; that is not a robust separation. Combined top-three share of nine laggard priority scores: 42.6146%. Alternative transaction weighting gives national 66.1186% and ranks Najran, Northern Borders, Al-Baha. These are material sensitivities. Fix the metric and validate demand before scaling. Descriptive data do not prove causes or returns. Chart uses source CSV and the workbook field definitions; it is not a Tableau-export screenshot.</a:t>
             </a:r>
           </a:p>
           <a:p xmlns:a="http://schemas.openxmlformats.org/drawingml/2006/main">
@@ -868,12 +848,7 @@
           <a:lstStyle xmlns:a="http://schemas.openxmlformats.org/drawingml/2006/main"/>
           <a:p xmlns:a="http://schemas.openxmlformats.org/drawingml/2006/main">
             <a:r>
-              <a:t>Hathal @1Hathall</a:t>
-            </a:r>
-          </a:p>
-          <a:p xmlns:a="http://schemas.openxmlformats.org/drawingml/2006/main">
-            <a:r>
-              <a:t>Options. 4:00–5:00. Compare equal nine-region coverage, full concentration and staged investment. Select staged because metric sensitivity and the lack of a causal response model warrant learning before the full release. Equal allocation 40/9 = 4.444M, rounded for display only.</a:t>
+              <a:t>Options. Compare equal nine-region coverage, full concentration and staged investment. Select staged because metric sensitivity and the lack of a causal response model warrant learning before the full release. Equal allocation 40/9 = 4.444M, rounded for display only.</a:t>
             </a:r>
           </a:p>
           <a:p xmlns:a="http://schemas.openxmlformats.org/drawingml/2006/main">
@@ -973,12 +948,7 @@
           <a:lstStyle xmlns:a="http://schemas.openxmlformats.org/drawingml/2006/main"/>
           <a:p xmlns:a="http://schemas.openxmlformats.org/drawingml/2006/main">
             <a:r>
-              <a:t>Hathal @1Hathall</a:t>
-            </a:r>
-          </a:p>
-          <a:p xmlns:a="http://schemas.openxmlformats.org/drawingml/2006/main">
-            <a:r>
-              <a:t>Recommendation. 5:00–6:15. SAR 35M proportional to the current top-three score, rounded using largest remainders, plus SAR 5M reserve. Intended effect: raise selected-region adoption without degrading service. Illustrative national scenario: 63.328346 + (6.11125+4.33825+4.08775)/13 = 64.44660%. This is conditional arithmetic, not a forecast or causal return. A next wave would still be needed. No observed investment-response coefficients are available.</a:t>
+              <a:t>Recommendation. SAR 35M proportional to the current top-three score, rounded using largest remainders, plus SAR 5M reserve. Intended effect: raise selected-region adoption without degrading service. Illustrative national scenario: 63.328346 + (6.11125+4.33825+4.08775)/13 = 64.44660%. This is conditional arithmetic, not a forecast or causal return. A next wave would still be needed. No observed investment-response coefficients are available.</a:t>
             </a:r>
           </a:p>
           <a:p xmlns:a="http://schemas.openxmlformats.org/drawingml/2006/main">
@@ -1078,12 +1048,7 @@
           <a:lstStyle xmlns:a="http://schemas.openxmlformats.org/drawingml/2006/main"/>
           <a:p xmlns:a="http://schemas.openxmlformats.org/drawingml/2006/main">
             <a:r>
-              <a:t>Hathal @1Hathall</a:t>
-            </a:r>
-          </a:p>
-          <a:p xmlns:a="http://schemas.openxmlformats.org/drawingml/2006/main">
-            <a:r>
-              <a:t>Ask and next step. 6:15–7:00. Approve 40M, authorize initial10M only after approval of metric, baseline, comparison design, service plan and cost; hold30M. Nominate owner on approval Day0. Validate shortlist and approve baseline before any intervention or release; launch within30days if ready. Day90 is counted from envelope approval; report pilot exposure and extend review if insufficient. Suggested +2pp is a management goal, not a causal forecast. Assess matched CSAT/SLA, costs and comparison design. Rerank if metric changes.</a:t>
+              <a:t>Ask and next step. Approve 40M, authorize initial 10M only after approval of metric, baseline, comparison design, service plan and cost; hold 30M. Nominate owner on approval Day 0. Validate shortlist and approve baseline before any intervention or release; launch within 30 days if ready. Day 90 is counted from envelope approval; report pilot exposure and extend review if insufficient. Suggested +2pp is a management goal, not a causal forecast. Assess matched CSAT/SLA, costs and comparison design. Rerank if metric changes.</a:t>
             </a:r>
           </a:p>
           <a:p xmlns:a="http://schemas.openxmlformats.org/drawingml/2006/main">
@@ -1181,7 +1146,7 @@
   </p:cSld>
   <p:clrMap bg1="lt1" tx1="dk1" bg2="lt2" tx2="dk2" accent1="accent1" accent2="accent2" accent3="accent3" accent4="accent4" accent5="accent5" accent6="accent6" hlink="hlink" folHlink="folHlink"/>
   <p:sldLayoutIdLst>
-    <p:sldLayoutId xmlns:r="http://schemas.openxmlformats.org/officeDocument/2006/relationships" id="2147483649" r:id="Rb488b3ae89404148"/>
+    <p:sldLayoutId xmlns:r="http://schemas.openxmlformats.org/officeDocument/2006/relationships" id="2147483649" r:id="R52908d3b4f6d4b17"/>
   </p:sldLayoutIdLst>
   <p:txStyles>
     <p:titleStyle>
@@ -4296,7 +4261,7 @@
           <p:cNvPr id="8" name="">
             <a:extLst xmlns:a="http://schemas.openxmlformats.org/drawingml/2006/main">
               <a:ext uri="{FF2B5EF4-FFF2-40B4-BE49-F238E27FC236}">
-                <a16:creationId xmlns:a16="http://schemas.microsoft.com/office/drawing/2014/main" id="{A09588A9-B489-435F-A1CA-24CF9FB26322}"/>
+                <a16:creationId xmlns:a16="http://schemas.microsoft.com/office/drawing/2014/main" id="{793435A2-C523-43FC-843E-F16F04A7EF45}"/>
               </a:ext>
             </a:extLst>
           </p:cNvPr>
@@ -4353,7 +4318,7 @@
           <p:cNvPr id="2" name="">
             <a:extLst xmlns:a="http://schemas.openxmlformats.org/drawingml/2006/main">
               <a:ext uri="{FF2B5EF4-FFF2-40B4-BE49-F238E27FC236}">
-                <a16:creationId xmlns:a16="http://schemas.microsoft.com/office/drawing/2014/main" id="{3759B10B-13D7-4716-9ACF-1E6B2CCFE2E3}"/>
+                <a16:creationId xmlns:a16="http://schemas.microsoft.com/office/drawing/2014/main" id="{D25B4271-B454-42D5-91B1-98B01D357B55}"/>
               </a:ext>
             </a:extLst>
           </p:cNvPr>
@@ -4410,7 +4375,7 @@
           <p:cNvPr id="3" name="">
             <a:extLst xmlns:a="http://schemas.openxmlformats.org/drawingml/2006/main">
               <a:ext uri="{FF2B5EF4-FFF2-40B4-BE49-F238E27FC236}">
-                <a16:creationId xmlns:a16="http://schemas.microsoft.com/office/drawing/2014/main" id="{516D92E5-2FCC-4A7C-BB04-2263FD23A999}"/>
+                <a16:creationId xmlns:a16="http://schemas.microsoft.com/office/drawing/2014/main" id="{66ADBBAE-672D-4FD9-854A-E5EF448F5505}"/>
               </a:ext>
             </a:extLst>
           </p:cNvPr>
@@ -4467,7 +4432,7 @@
           <p:cNvPr id="4" name="">
             <a:extLst xmlns:a="http://schemas.openxmlformats.org/drawingml/2006/main">
               <a:ext uri="{FF2B5EF4-FFF2-40B4-BE49-F238E27FC236}">
-                <a16:creationId xmlns:a16="http://schemas.microsoft.com/office/drawing/2014/main" id="{E101BEE1-0BCD-4ADE-BBB7-1942D8F2703A}"/>
+                <a16:creationId xmlns:a16="http://schemas.microsoft.com/office/drawing/2014/main" id="{40C18432-6342-4596-A63B-D38ED0937173}"/>
               </a:ext>
             </a:extLst>
           </p:cNvPr>
@@ -4524,7 +4489,7 @@
           <p:cNvPr id="5" name="">
             <a:extLst xmlns:a="http://schemas.openxmlformats.org/drawingml/2006/main">
               <a:ext uri="{FF2B5EF4-FFF2-40B4-BE49-F238E27FC236}">
-                <a16:creationId xmlns:a16="http://schemas.microsoft.com/office/drawing/2014/main" id="{9F5D88D5-6F1A-41E7-AEE2-5F4B8BCFE7A5}"/>
+                <a16:creationId xmlns:a16="http://schemas.microsoft.com/office/drawing/2014/main" id="{571C0AFC-D72E-414E-A6D2-B9CAC86237F5}"/>
               </a:ext>
             </a:extLst>
           </p:cNvPr>
@@ -4581,7 +4546,7 @@
           <p:cNvPr id="6" name="">
             <a:extLst xmlns:a="http://schemas.openxmlformats.org/drawingml/2006/main">
               <a:ext uri="{FF2B5EF4-FFF2-40B4-BE49-F238E27FC236}">
-                <a16:creationId xmlns:a16="http://schemas.microsoft.com/office/drawing/2014/main" id="{8401E799-22CB-4A00-B2D7-EB4B6E03FF2E}"/>
+                <a16:creationId xmlns:a16="http://schemas.microsoft.com/office/drawing/2014/main" id="{91D7EA40-7CFE-4F8E-9CFA-0185C9096D33}"/>
               </a:ext>
             </a:extLst>
           </p:cNvPr>
@@ -4638,7 +4603,7 @@
           <p:cNvPr id="7" name="">
             <a:extLst xmlns:a="http://schemas.openxmlformats.org/drawingml/2006/main">
               <a:ext uri="{FF2B5EF4-FFF2-40B4-BE49-F238E27FC236}">
-                <a16:creationId xmlns:a16="http://schemas.microsoft.com/office/drawing/2014/main" id="{01FB6FAB-51F7-4265-9DA0-C8F4014D030B}"/>
+                <a16:creationId xmlns:a16="http://schemas.microsoft.com/office/drawing/2014/main" id="{1377F319-9EB0-45B7-A49D-1EAC2F625F2E}"/>
               </a:ext>
             </a:extLst>
           </p:cNvPr>
@@ -4685,7 +4650,7 @@
                 <a:ea typeface="Arial"/>
                 <a:cs typeface="Arial"/>
               </a:rPr>
-              <a:t>SDAIA Academy SDA-DSC-112     Abdulelah · Sanad · Hathal     Synthetic training data</a:t>
+              <a:t>SDAIA Academy SDA-DSC-112 · Synthetic training data</a:t>
             </a:r>
           </a:p>
         </p:txBody>
@@ -4693,7 +4658,7 @@
     </p:spTree>
     <p:extLst>
       <p:ext uri="{BB962C8B-B14F-4D97-AF65-F5344CB8AC3E}">
-        <p14:creationId xmlns:p14="http://schemas.microsoft.com/office/powerpoint/2010/main" val="583923919"/>
+        <p14:creationId xmlns:p14="http://schemas.microsoft.com/office/powerpoint/2010/main" val="1711756939"/>
       </p:ext>
     </p:extLst>
   </p:cSld>
@@ -4724,7 +4689,7 @@
           <p:cNvPr id="11" name="">
             <a:extLst xmlns:a="http://schemas.openxmlformats.org/drawingml/2006/main">
               <a:ext uri="{FF2B5EF4-FFF2-40B4-BE49-F238E27FC236}">
-                <a16:creationId xmlns:a16="http://schemas.microsoft.com/office/drawing/2014/main" id="{A5B8BE2B-ADAC-49EC-BF81-F64F11B785C5}"/>
+                <a16:creationId xmlns:a16="http://schemas.microsoft.com/office/drawing/2014/main" id="{DBB0D458-4220-43CD-996E-5DD473C5CB51}"/>
               </a:ext>
             </a:extLst>
           </p:cNvPr>
@@ -4781,7 +4746,7 @@
           <p:cNvPr id="2" name="">
             <a:extLst xmlns:a="http://schemas.openxmlformats.org/drawingml/2006/main">
               <a:ext uri="{FF2B5EF4-FFF2-40B4-BE49-F238E27FC236}">
-                <a16:creationId xmlns:a16="http://schemas.microsoft.com/office/drawing/2014/main" id="{3718ED2D-F54E-462F-B718-6C8293BBD9C9}"/>
+                <a16:creationId xmlns:a16="http://schemas.microsoft.com/office/drawing/2014/main" id="{5078F6C4-3A09-4EA2-AE6B-4B8252B1CA9A}"/>
               </a:ext>
             </a:extLst>
           </p:cNvPr>
@@ -4838,7 +4803,7 @@
           <p:cNvPr id="3" name="">
             <a:extLst xmlns:a="http://schemas.openxmlformats.org/drawingml/2006/main">
               <a:ext uri="{FF2B5EF4-FFF2-40B4-BE49-F238E27FC236}">
-                <a16:creationId xmlns:a16="http://schemas.microsoft.com/office/drawing/2014/main" id="{73FB3E33-88A7-4F6D-A619-1F1A8C987721}"/>
+                <a16:creationId xmlns:a16="http://schemas.microsoft.com/office/drawing/2014/main" id="{960F33D8-684A-4BE9-8524-89E9E8AA1EB7}"/>
               </a:ext>
             </a:extLst>
           </p:cNvPr>
@@ -4895,7 +4860,7 @@
           <p:cNvPr id="4" name="">
             <a:extLst xmlns:a="http://schemas.openxmlformats.org/drawingml/2006/main">
               <a:ext uri="{FF2B5EF4-FFF2-40B4-BE49-F238E27FC236}">
-                <a16:creationId xmlns:a16="http://schemas.microsoft.com/office/drawing/2014/main" id="{65917437-C7FD-4B1B-A71C-217AF92B437A}"/>
+                <a16:creationId xmlns:a16="http://schemas.microsoft.com/office/drawing/2014/main" id="{F15E59C1-CDA0-438D-AF24-5DD38AB43172}"/>
               </a:ext>
             </a:extLst>
           </p:cNvPr>
@@ -4959,7 +4924,7 @@
         </p:xfrm>
         <a:graphic xmlns:a="http://schemas.openxmlformats.org/drawingml/2006/main">
           <a:graphicData uri="http://schemas.openxmlformats.org/drawingml/2006/chart">
-            <c:chart xmlns:r="http://schemas.openxmlformats.org/officeDocument/2006/relationships" xmlns:c="http://schemas.openxmlformats.org/drawingml/2006/chart" r:id="R029df7db226a4ff6"/>
+            <c:chart xmlns:r="http://schemas.openxmlformats.org/officeDocument/2006/relationships" xmlns:c="http://schemas.openxmlformats.org/drawingml/2006/chart" r:id="R8d7eaa1160c64cdb"/>
           </a:graphicData>
         </a:graphic>
       </p:graphicFrame>
@@ -4968,7 +4933,7 @@
           <p:cNvPr id="6" name="">
             <a:extLst xmlns:a="http://schemas.openxmlformats.org/drawingml/2006/main">
               <a:ext uri="{FF2B5EF4-FFF2-40B4-BE49-F238E27FC236}">
-                <a16:creationId xmlns:a16="http://schemas.microsoft.com/office/drawing/2014/main" id="{28C5E99E-122B-4A2E-AAE6-392EE19B9B18}"/>
+                <a16:creationId xmlns:a16="http://schemas.microsoft.com/office/drawing/2014/main" id="{2DA525BC-39E1-49D8-9AB6-FD32E5B773C9}"/>
               </a:ext>
             </a:extLst>
           </p:cNvPr>
@@ -5025,7 +4990,7 @@
           <p:cNvPr id="7" name="">
             <a:extLst xmlns:a="http://schemas.openxmlformats.org/drawingml/2006/main">
               <a:ext uri="{FF2B5EF4-FFF2-40B4-BE49-F238E27FC236}">
-                <a16:creationId xmlns:a16="http://schemas.microsoft.com/office/drawing/2014/main" id="{35622404-39A7-4B23-BD53-9A0607A91AE9}"/>
+                <a16:creationId xmlns:a16="http://schemas.microsoft.com/office/drawing/2014/main" id="{64B37636-1D28-4B31-9A78-6BA237C3B74C}"/>
               </a:ext>
             </a:extLst>
           </p:cNvPr>
@@ -5082,7 +5047,7 @@
           <p:cNvPr id="8" name="">
             <a:extLst xmlns:a="http://schemas.openxmlformats.org/drawingml/2006/main">
               <a:ext uri="{FF2B5EF4-FFF2-40B4-BE49-F238E27FC236}">
-                <a16:creationId xmlns:a16="http://schemas.microsoft.com/office/drawing/2014/main" id="{9084C919-3B86-420B-8D50-D3903F21E471}"/>
+                <a16:creationId xmlns:a16="http://schemas.microsoft.com/office/drawing/2014/main" id="{519DA8E5-0DDE-480B-9395-CD500A766BF8}"/>
               </a:ext>
             </a:extLst>
           </p:cNvPr>
@@ -5139,7 +5104,7 @@
           <p:cNvPr id="9" name="">
             <a:extLst xmlns:a="http://schemas.openxmlformats.org/drawingml/2006/main">
               <a:ext uri="{FF2B5EF4-FFF2-40B4-BE49-F238E27FC236}">
-                <a16:creationId xmlns:a16="http://schemas.microsoft.com/office/drawing/2014/main" id="{0B70139B-7825-43D7-82AE-267A3E617D1F}"/>
+                <a16:creationId xmlns:a16="http://schemas.microsoft.com/office/drawing/2014/main" id="{A15AE02C-27D6-4DEA-81E4-7D8DB3BE2BF0}"/>
               </a:ext>
             </a:extLst>
           </p:cNvPr>
@@ -5196,7 +5161,7 @@
           <p:cNvPr id="10" name="">
             <a:extLst xmlns:a="http://schemas.openxmlformats.org/drawingml/2006/main">
               <a:ext uri="{FF2B5EF4-FFF2-40B4-BE49-F238E27FC236}">
-                <a16:creationId xmlns:a16="http://schemas.microsoft.com/office/drawing/2014/main" id="{739D3EF4-89A9-412C-BDA6-8F6F55CF2CB3}"/>
+                <a16:creationId xmlns:a16="http://schemas.microsoft.com/office/drawing/2014/main" id="{CD6D9C59-2A69-4648-9F72-824C48C5A028}"/>
               </a:ext>
             </a:extLst>
           </p:cNvPr>
@@ -5251,7 +5216,7 @@
     </p:spTree>
     <p:extLst>
       <p:ext uri="{BB962C8B-B14F-4D97-AF65-F5344CB8AC3E}">
-        <p14:creationId xmlns:p14="http://schemas.microsoft.com/office/powerpoint/2010/main" val="2073866700"/>
+        <p14:creationId xmlns:p14="http://schemas.microsoft.com/office/powerpoint/2010/main" val="2084569482"/>
       </p:ext>
     </p:extLst>
   </p:cSld>
@@ -5282,7 +5247,7 @@
           <p:cNvPr id="7" name="">
             <a:extLst xmlns:a="http://schemas.openxmlformats.org/drawingml/2006/main">
               <a:ext uri="{FF2B5EF4-FFF2-40B4-BE49-F238E27FC236}">
-                <a16:creationId xmlns:a16="http://schemas.microsoft.com/office/drawing/2014/main" id="{80404330-1AE7-4753-A954-D2F0004DB371}"/>
+                <a16:creationId xmlns:a16="http://schemas.microsoft.com/office/drawing/2014/main" id="{6A4F2EFD-E967-4B22-A9BE-B554DC299FDE}"/>
               </a:ext>
             </a:extLst>
           </p:cNvPr>
@@ -5339,7 +5304,7 @@
           <p:cNvPr id="2" name="">
             <a:extLst xmlns:a="http://schemas.openxmlformats.org/drawingml/2006/main">
               <a:ext uri="{FF2B5EF4-FFF2-40B4-BE49-F238E27FC236}">
-                <a16:creationId xmlns:a16="http://schemas.microsoft.com/office/drawing/2014/main" id="{E535A41F-2F6D-4743-97D7-EA75EEE27679}"/>
+                <a16:creationId xmlns:a16="http://schemas.microsoft.com/office/drawing/2014/main" id="{044AC3F7-BDA9-4CC0-A3B1-BD7118C3DE83}"/>
               </a:ext>
             </a:extLst>
           </p:cNvPr>
@@ -5403,7 +5368,7 @@
         </p:xfrm>
         <a:graphic xmlns:a="http://schemas.openxmlformats.org/drawingml/2006/main">
           <a:graphicData uri="http://schemas.openxmlformats.org/drawingml/2006/chart">
-            <c:chart xmlns:r="http://schemas.openxmlformats.org/officeDocument/2006/relationships" xmlns:c="http://schemas.openxmlformats.org/drawingml/2006/chart" r:id="Rb4228c31970e46b8"/>
+            <c:chart xmlns:r="http://schemas.openxmlformats.org/officeDocument/2006/relationships" xmlns:c="http://schemas.openxmlformats.org/drawingml/2006/chart" r:id="R1d3c14d626b04ada"/>
           </a:graphicData>
         </a:graphic>
       </p:graphicFrame>
@@ -5412,7 +5377,7 @@
           <p:cNvPr id="4" name="">
             <a:extLst xmlns:a="http://schemas.openxmlformats.org/drawingml/2006/main">
               <a:ext uri="{FF2B5EF4-FFF2-40B4-BE49-F238E27FC236}">
-                <a16:creationId xmlns:a16="http://schemas.microsoft.com/office/drawing/2014/main" id="{5A88C3F5-B88A-4518-9A78-89F824EE293E}"/>
+                <a16:creationId xmlns:a16="http://schemas.microsoft.com/office/drawing/2014/main" id="{A4E13E96-3B7D-4D12-9ED0-B0F661EAE42A}"/>
               </a:ext>
             </a:extLst>
           </p:cNvPr>
@@ -5442,7 +5407,7 @@
           <p:cNvPr id="5" name="">
             <a:extLst xmlns:a="http://schemas.openxmlformats.org/drawingml/2006/main">
               <a:ext uri="{FF2B5EF4-FFF2-40B4-BE49-F238E27FC236}">
-                <a16:creationId xmlns:a16="http://schemas.microsoft.com/office/drawing/2014/main" id="{47AE13AC-ED33-485A-9E33-7C35C4A74A2D}"/>
+                <a16:creationId xmlns:a16="http://schemas.microsoft.com/office/drawing/2014/main" id="{56C22908-0C65-4E08-AB46-441B2C93322E}"/>
               </a:ext>
             </a:extLst>
           </p:cNvPr>
@@ -5499,7 +5464,7 @@
           <p:cNvPr id="6" name="">
             <a:extLst xmlns:a="http://schemas.openxmlformats.org/drawingml/2006/main">
               <a:ext uri="{FF2B5EF4-FFF2-40B4-BE49-F238E27FC236}">
-                <a16:creationId xmlns:a16="http://schemas.microsoft.com/office/drawing/2014/main" id="{10DE4A0A-3110-40E5-8086-DF1BF05382B1}"/>
+                <a16:creationId xmlns:a16="http://schemas.microsoft.com/office/drawing/2014/main" id="{37D76AD0-B40A-4847-953B-6257CBBE100B}"/>
               </a:ext>
             </a:extLst>
           </p:cNvPr>
@@ -5554,7 +5519,7 @@
     </p:spTree>
     <p:extLst>
       <p:ext uri="{BB962C8B-B14F-4D97-AF65-F5344CB8AC3E}">
-        <p14:creationId xmlns:p14="http://schemas.microsoft.com/office/powerpoint/2010/main" val="1524833030"/>
+        <p14:creationId xmlns:p14="http://schemas.microsoft.com/office/powerpoint/2010/main" val="682313061"/>
       </p:ext>
     </p:extLst>
   </p:cSld>
@@ -5585,7 +5550,7 @@
           <p:cNvPr id="12" name="">
             <a:extLst xmlns:a="http://schemas.openxmlformats.org/drawingml/2006/main">
               <a:ext uri="{FF2B5EF4-FFF2-40B4-BE49-F238E27FC236}">
-                <a16:creationId xmlns:a16="http://schemas.microsoft.com/office/drawing/2014/main" id="{DD246550-EBFD-4815-B1BE-51041C84E42D}"/>
+                <a16:creationId xmlns:a16="http://schemas.microsoft.com/office/drawing/2014/main" id="{B6A38DB9-44B6-4A59-B4EA-3AEB3B821F8F}"/>
               </a:ext>
             </a:extLst>
           </p:cNvPr>
@@ -5642,7 +5607,7 @@
           <p:cNvPr id="2" name="">
             <a:extLst xmlns:a="http://schemas.openxmlformats.org/drawingml/2006/main">
               <a:ext uri="{FF2B5EF4-FFF2-40B4-BE49-F238E27FC236}">
-                <a16:creationId xmlns:a16="http://schemas.microsoft.com/office/drawing/2014/main" id="{E85B1DCA-230F-4394-A2FD-17D9355AB287}"/>
+                <a16:creationId xmlns:a16="http://schemas.microsoft.com/office/drawing/2014/main" id="{0EE4637F-FE4E-410D-8C69-E3E9781A1A3E}"/>
               </a:ext>
             </a:extLst>
           </p:cNvPr>
@@ -5699,7 +5664,7 @@
           <p:cNvPr id="3" name="">
             <a:extLst xmlns:a="http://schemas.openxmlformats.org/drawingml/2006/main">
               <a:ext uri="{FF2B5EF4-FFF2-40B4-BE49-F238E27FC236}">
-                <a16:creationId xmlns:a16="http://schemas.microsoft.com/office/drawing/2014/main" id="{AEFDD8C9-6572-42A5-9A17-8C21152F2391}"/>
+                <a16:creationId xmlns:a16="http://schemas.microsoft.com/office/drawing/2014/main" id="{7779D0CE-AD6C-4126-A15A-EE4F03592062}"/>
               </a:ext>
             </a:extLst>
           </p:cNvPr>
@@ -5763,7 +5728,7 @@
         </p:xfrm>
         <a:graphic xmlns:a="http://schemas.openxmlformats.org/drawingml/2006/main">
           <a:graphicData uri="http://schemas.openxmlformats.org/drawingml/2006/chart">
-            <c:chart xmlns:r="http://schemas.openxmlformats.org/officeDocument/2006/relationships" xmlns:c="http://schemas.openxmlformats.org/drawingml/2006/chart" r:id="R0ee2318b741444a1"/>
+            <c:chart xmlns:r="http://schemas.openxmlformats.org/officeDocument/2006/relationships" xmlns:c="http://schemas.openxmlformats.org/drawingml/2006/chart" r:id="R7a85ec0721d84117"/>
           </a:graphicData>
         </a:graphic>
       </p:graphicFrame>
@@ -5772,7 +5737,7 @@
           <p:cNvPr id="5" name="">
             <a:extLst xmlns:a="http://schemas.openxmlformats.org/drawingml/2006/main">
               <a:ext uri="{FF2B5EF4-FFF2-40B4-BE49-F238E27FC236}">
-                <a16:creationId xmlns:a16="http://schemas.microsoft.com/office/drawing/2014/main" id="{E5D22CB3-4B2B-48EE-BEA7-6602C2698A46}"/>
+                <a16:creationId xmlns:a16="http://schemas.microsoft.com/office/drawing/2014/main" id="{D71339BB-BE3E-48DF-A9EF-7DD881E533AA}"/>
               </a:ext>
             </a:extLst>
           </p:cNvPr>
@@ -5829,7 +5794,7 @@
           <p:cNvPr id="6" name="">
             <a:extLst xmlns:a="http://schemas.openxmlformats.org/drawingml/2006/main">
               <a:ext uri="{FF2B5EF4-FFF2-40B4-BE49-F238E27FC236}">
-                <a16:creationId xmlns:a16="http://schemas.microsoft.com/office/drawing/2014/main" id="{81A5C3CD-F65A-43F5-816B-973A1A28FEFC}"/>
+                <a16:creationId xmlns:a16="http://schemas.microsoft.com/office/drawing/2014/main" id="{0D40724E-0987-494B-8C67-4DF6E240454B}"/>
               </a:ext>
             </a:extLst>
           </p:cNvPr>
@@ -5886,7 +5851,7 @@
           <p:cNvPr id="7" name="">
             <a:extLst xmlns:a="http://schemas.openxmlformats.org/drawingml/2006/main">
               <a:ext uri="{FF2B5EF4-FFF2-40B4-BE49-F238E27FC236}">
-                <a16:creationId xmlns:a16="http://schemas.microsoft.com/office/drawing/2014/main" id="{9191B9A5-7015-4D59-AFB8-63331D97CA2B}"/>
+                <a16:creationId xmlns:a16="http://schemas.microsoft.com/office/drawing/2014/main" id="{FD679BC7-3275-4C69-94C5-B2ABFB2C84C8}"/>
               </a:ext>
             </a:extLst>
           </p:cNvPr>
@@ -5943,7 +5908,7 @@
           <p:cNvPr id="8" name="">
             <a:extLst xmlns:a="http://schemas.openxmlformats.org/drawingml/2006/main">
               <a:ext uri="{FF2B5EF4-FFF2-40B4-BE49-F238E27FC236}">
-                <a16:creationId xmlns:a16="http://schemas.microsoft.com/office/drawing/2014/main" id="{C7EC6B86-2921-4E9D-A2B9-BDC0A6EF86DC}"/>
+                <a16:creationId xmlns:a16="http://schemas.microsoft.com/office/drawing/2014/main" id="{3A8CD12D-9290-43E2-A7F8-218551CF3FDC}"/>
               </a:ext>
             </a:extLst>
           </p:cNvPr>
@@ -6046,7 +6011,7 @@
           <p:cNvPr id="9" name="">
             <a:extLst xmlns:a="http://schemas.openxmlformats.org/drawingml/2006/main">
               <a:ext uri="{FF2B5EF4-FFF2-40B4-BE49-F238E27FC236}">
-                <a16:creationId xmlns:a16="http://schemas.microsoft.com/office/drawing/2014/main" id="{A79C8FAF-3B1D-4153-BCDB-3BD29FF76901}"/>
+                <a16:creationId xmlns:a16="http://schemas.microsoft.com/office/drawing/2014/main" id="{1C777C88-543C-4615-AF81-D3A1C6AC9691}"/>
               </a:ext>
             </a:extLst>
           </p:cNvPr>
@@ -6103,7 +6068,7 @@
           <p:cNvPr id="10" name="">
             <a:extLst xmlns:a="http://schemas.openxmlformats.org/drawingml/2006/main">
               <a:ext uri="{FF2B5EF4-FFF2-40B4-BE49-F238E27FC236}">
-                <a16:creationId xmlns:a16="http://schemas.microsoft.com/office/drawing/2014/main" id="{85CDD235-10CE-40E7-8BC0-CBD2BD36B5D0}"/>
+                <a16:creationId xmlns:a16="http://schemas.microsoft.com/office/drawing/2014/main" id="{6AE5554B-CCFB-46DE-B38E-EF7E217EFA39}"/>
               </a:ext>
             </a:extLst>
           </p:cNvPr>
@@ -6160,7 +6125,7 @@
           <p:cNvPr id="11" name="">
             <a:extLst xmlns:a="http://schemas.openxmlformats.org/drawingml/2006/main">
               <a:ext uri="{FF2B5EF4-FFF2-40B4-BE49-F238E27FC236}">
-                <a16:creationId xmlns:a16="http://schemas.microsoft.com/office/drawing/2014/main" id="{53CDFA12-F057-43BD-AA46-B78FA7E8639A}"/>
+                <a16:creationId xmlns:a16="http://schemas.microsoft.com/office/drawing/2014/main" id="{92DABFDC-024C-4140-90B3-FFC280F6C18F}"/>
               </a:ext>
             </a:extLst>
           </p:cNvPr>
@@ -6215,7 +6180,7 @@
     </p:spTree>
     <p:extLst>
       <p:ext uri="{BB962C8B-B14F-4D97-AF65-F5344CB8AC3E}">
-        <p14:creationId xmlns:p14="http://schemas.microsoft.com/office/powerpoint/2010/main" val="1288161498"/>
+        <p14:creationId xmlns:p14="http://schemas.microsoft.com/office/powerpoint/2010/main" val="441588381"/>
       </p:ext>
     </p:extLst>
   </p:cSld>
@@ -6246,7 +6211,7 @@
           <p:cNvPr id="6" name="">
             <a:extLst xmlns:a="http://schemas.openxmlformats.org/drawingml/2006/main">
               <a:ext uri="{FF2B5EF4-FFF2-40B4-BE49-F238E27FC236}">
-                <a16:creationId xmlns:a16="http://schemas.microsoft.com/office/drawing/2014/main" id="{E86C3462-5FFA-4B48-95D6-D2C9AD24382D}"/>
+                <a16:creationId xmlns:a16="http://schemas.microsoft.com/office/drawing/2014/main" id="{9EFBAB83-6399-4062-9B06-59152EE483EE}"/>
               </a:ext>
             </a:extLst>
           </p:cNvPr>
@@ -6303,7 +6268,7 @@
           <p:cNvPr id="2" name="">
             <a:extLst xmlns:a="http://schemas.openxmlformats.org/drawingml/2006/main">
               <a:ext uri="{FF2B5EF4-FFF2-40B4-BE49-F238E27FC236}">
-                <a16:creationId xmlns:a16="http://schemas.microsoft.com/office/drawing/2014/main" id="{4F8DBCE7-C509-49D3-8CF0-E71CDF58A6B4}"/>
+                <a16:creationId xmlns:a16="http://schemas.microsoft.com/office/drawing/2014/main" id="{969B43E0-9036-4E42-85A2-0241260476A1}"/>
               </a:ext>
             </a:extLst>
           </p:cNvPr>
@@ -6788,7 +6753,7 @@
           <p:cNvPr id="4" name="">
             <a:extLst xmlns:a="http://schemas.openxmlformats.org/drawingml/2006/main">
               <a:ext uri="{FF2B5EF4-FFF2-40B4-BE49-F238E27FC236}">
-                <a16:creationId xmlns:a16="http://schemas.microsoft.com/office/drawing/2014/main" id="{5751C20D-A16E-4AF2-A718-BD2C39BD04B1}"/>
+                <a16:creationId xmlns:a16="http://schemas.microsoft.com/office/drawing/2014/main" id="{639BFC4E-81E9-4C87-9A64-13F177E9A276}"/>
               </a:ext>
             </a:extLst>
           </p:cNvPr>
@@ -6845,7 +6810,7 @@
           <p:cNvPr id="5" name="">
             <a:extLst xmlns:a="http://schemas.openxmlformats.org/drawingml/2006/main">
               <a:ext uri="{FF2B5EF4-FFF2-40B4-BE49-F238E27FC236}">
-                <a16:creationId xmlns:a16="http://schemas.microsoft.com/office/drawing/2014/main" id="{F518F815-63C2-4945-9E6A-E51F7009A6BF}"/>
+                <a16:creationId xmlns:a16="http://schemas.microsoft.com/office/drawing/2014/main" id="{DDBA465C-A62D-4B1F-B164-B9646FFC7A84}"/>
               </a:ext>
             </a:extLst>
           </p:cNvPr>
@@ -6900,7 +6865,7 @@
     </p:spTree>
     <p:extLst>
       <p:ext uri="{BB962C8B-B14F-4D97-AF65-F5344CB8AC3E}">
-        <p14:creationId xmlns:p14="http://schemas.microsoft.com/office/powerpoint/2010/main" val="1445886591"/>
+        <p14:creationId xmlns:p14="http://schemas.microsoft.com/office/powerpoint/2010/main" val="587222563"/>
       </p:ext>
     </p:extLst>
   </p:cSld>
@@ -6931,7 +6896,7 @@
           <p:cNvPr id="8" name="">
             <a:extLst xmlns:a="http://schemas.openxmlformats.org/drawingml/2006/main">
               <a:ext uri="{FF2B5EF4-FFF2-40B4-BE49-F238E27FC236}">
-                <a16:creationId xmlns:a16="http://schemas.microsoft.com/office/drawing/2014/main" id="{3C5E4A73-A308-4C43-B5E9-AEEBA1EE5093}"/>
+                <a16:creationId xmlns:a16="http://schemas.microsoft.com/office/drawing/2014/main" id="{71E4D43F-7CFF-4FF3-A55B-EB9401A01F9D}"/>
               </a:ext>
             </a:extLst>
           </p:cNvPr>
@@ -6988,7 +6953,7 @@
           <p:cNvPr id="2" name="">
             <a:extLst xmlns:a="http://schemas.openxmlformats.org/drawingml/2006/main">
               <a:ext uri="{FF2B5EF4-FFF2-40B4-BE49-F238E27FC236}">
-                <a16:creationId xmlns:a16="http://schemas.microsoft.com/office/drawing/2014/main" id="{028D8642-0DF6-43F7-AE2B-D2A7AA0DCCA1}"/>
+                <a16:creationId xmlns:a16="http://schemas.microsoft.com/office/drawing/2014/main" id="{00E62E52-0AE8-4945-ABFB-75D311683033}"/>
               </a:ext>
             </a:extLst>
           </p:cNvPr>
@@ -7377,7 +7342,7 @@
           <p:cNvPr id="4" name="">
             <a:extLst xmlns:a="http://schemas.openxmlformats.org/drawingml/2006/main">
               <a:ext uri="{FF2B5EF4-FFF2-40B4-BE49-F238E27FC236}">
-                <a16:creationId xmlns:a16="http://schemas.microsoft.com/office/drawing/2014/main" id="{ECD8D605-77A6-4C3F-AD6E-CF4F03D20FE4}"/>
+                <a16:creationId xmlns:a16="http://schemas.microsoft.com/office/drawing/2014/main" id="{B810B9BB-9033-489F-A4B3-5A7CE67F438B}"/>
               </a:ext>
             </a:extLst>
           </p:cNvPr>
@@ -7434,7 +7399,7 @@
           <p:cNvPr id="5" name="">
             <a:extLst xmlns:a="http://schemas.openxmlformats.org/drawingml/2006/main">
               <a:ext uri="{FF2B5EF4-FFF2-40B4-BE49-F238E27FC236}">
-                <a16:creationId xmlns:a16="http://schemas.microsoft.com/office/drawing/2014/main" id="{07DCED5D-1D46-4AAA-B821-8D7FE0F53FA8}"/>
+                <a16:creationId xmlns:a16="http://schemas.microsoft.com/office/drawing/2014/main" id="{298C6A25-2022-40E8-BA52-95E8A781087B}"/>
               </a:ext>
             </a:extLst>
           </p:cNvPr>
@@ -7491,7 +7456,7 @@
           <p:cNvPr id="6" name="">
             <a:extLst xmlns:a="http://schemas.openxmlformats.org/drawingml/2006/main">
               <a:ext uri="{FF2B5EF4-FFF2-40B4-BE49-F238E27FC236}">
-                <a16:creationId xmlns:a16="http://schemas.microsoft.com/office/drawing/2014/main" id="{77348F27-E7B6-4C2F-A7DF-C3E8F33FC73D}"/>
+                <a16:creationId xmlns:a16="http://schemas.microsoft.com/office/drawing/2014/main" id="{D7C7CD7E-154D-4436-8944-E19DD1E9C17D}"/>
               </a:ext>
             </a:extLst>
           </p:cNvPr>
@@ -7548,7 +7513,7 @@
           <p:cNvPr id="7" name="">
             <a:extLst xmlns:a="http://schemas.openxmlformats.org/drawingml/2006/main">
               <a:ext uri="{FF2B5EF4-FFF2-40B4-BE49-F238E27FC236}">
-                <a16:creationId xmlns:a16="http://schemas.microsoft.com/office/drawing/2014/main" id="{9249E49A-3C97-4618-9AB3-D7B0A07379C2}"/>
+                <a16:creationId xmlns:a16="http://schemas.microsoft.com/office/drawing/2014/main" id="{2A82CE85-D72F-4010-9E81-0459ED728EC0}"/>
               </a:ext>
             </a:extLst>
           </p:cNvPr>
@@ -7603,7 +7568,7 @@
     </p:spTree>
     <p:extLst>
       <p:ext uri="{BB962C8B-B14F-4D97-AF65-F5344CB8AC3E}">
-        <p14:creationId xmlns:p14="http://schemas.microsoft.com/office/powerpoint/2010/main" val="453127683"/>
+        <p14:creationId xmlns:p14="http://schemas.microsoft.com/office/powerpoint/2010/main" val="1846590125"/>
       </p:ext>
     </p:extLst>
   </p:cSld>
@@ -7634,7 +7599,7 @@
           <p:cNvPr id="7" name="">
             <a:extLst xmlns:a="http://schemas.openxmlformats.org/drawingml/2006/main">
               <a:ext uri="{FF2B5EF4-FFF2-40B4-BE49-F238E27FC236}">
-                <a16:creationId xmlns:a16="http://schemas.microsoft.com/office/drawing/2014/main" id="{E32D67B9-CBB8-4559-9F60-F07681910B4B}"/>
+                <a16:creationId xmlns:a16="http://schemas.microsoft.com/office/drawing/2014/main" id="{378DB6E4-874F-47B7-BC44-E23AE4B3D05D}"/>
               </a:ext>
             </a:extLst>
           </p:cNvPr>
@@ -7681,7 +7646,7 @@
                 <a:ea typeface="Arial"/>
                 <a:cs typeface="Arial"/>
               </a:rPr>
-              <a:t>Approve the envelope now; scale after the day-90 review</a:t>
+              <a:t>Approve SAR 40M; review pilots at day 90</a:t>
             </a:r>
           </a:p>
         </p:txBody>
@@ -7691,7 +7656,7 @@
           <p:cNvPr id="2" name="">
             <a:extLst xmlns:a="http://schemas.openxmlformats.org/drawingml/2006/main">
               <a:ext uri="{FF2B5EF4-FFF2-40B4-BE49-F238E27FC236}">
-                <a16:creationId xmlns:a16="http://schemas.microsoft.com/office/drawing/2014/main" id="{4E45553F-5A90-4136-BD0D-5E403FEB0DB0}"/>
+                <a16:creationId xmlns:a16="http://schemas.microsoft.com/office/drawing/2014/main" id="{5A41CB70-F7E2-455E-9714-0B663AF240E6}"/>
               </a:ext>
             </a:extLst>
           </p:cNvPr>
@@ -7748,7 +7713,7 @@
           <p:cNvPr id="3" name="">
             <a:extLst xmlns:a="http://schemas.openxmlformats.org/drawingml/2006/main">
               <a:ext uri="{FF2B5EF4-FFF2-40B4-BE49-F238E27FC236}">
-                <a16:creationId xmlns:a16="http://schemas.microsoft.com/office/drawing/2014/main" id="{8E639767-9BF4-43F2-B0DC-04EAA00949C7}"/>
+                <a16:creationId xmlns:a16="http://schemas.microsoft.com/office/drawing/2014/main" id="{F27311E6-2032-4CD2-A46C-4EDADE243500}"/>
               </a:ext>
             </a:extLst>
           </p:cNvPr>
@@ -8033,7 +7998,7 @@
           <p:cNvPr id="5" name="">
             <a:extLst xmlns:a="http://schemas.openxmlformats.org/drawingml/2006/main">
               <a:ext uri="{FF2B5EF4-FFF2-40B4-BE49-F238E27FC236}">
-                <a16:creationId xmlns:a16="http://schemas.microsoft.com/office/drawing/2014/main" id="{E2884387-F6CC-40D7-85AF-25631369838C}"/>
+                <a16:creationId xmlns:a16="http://schemas.microsoft.com/office/drawing/2014/main" id="{365C1333-A65B-43DC-BB8F-63A43C636636}"/>
               </a:ext>
             </a:extLst>
           </p:cNvPr>
@@ -8090,7 +8055,7 @@
           <p:cNvPr id="6" name="">
             <a:extLst xmlns:a="http://schemas.openxmlformats.org/drawingml/2006/main">
               <a:ext uri="{FF2B5EF4-FFF2-40B4-BE49-F238E27FC236}">
-                <a16:creationId xmlns:a16="http://schemas.microsoft.com/office/drawing/2014/main" id="{3B1DEB09-3ED7-4C6C-9DD9-6F076883B95C}"/>
+                <a16:creationId xmlns:a16="http://schemas.microsoft.com/office/drawing/2014/main" id="{DA7B78AD-6CA7-4D98-9690-1E2E8C99AE5F}"/>
               </a:ext>
             </a:extLst>
           </p:cNvPr>
@@ -8145,7 +8110,7 @@
     </p:spTree>
     <p:extLst>
       <p:ext uri="{BB962C8B-B14F-4D97-AF65-F5344CB8AC3E}">
-        <p14:creationId xmlns:p14="http://schemas.microsoft.com/office/powerpoint/2010/main" val="1907179640"/>
+        <p14:creationId xmlns:p14="http://schemas.microsoft.com/office/powerpoint/2010/main" val="866670845"/>
       </p:ext>
     </p:extLst>
   </p:cSld>

</xml_diff>

<commit_message>
Use simple English and add presenter notes to every slide
</commit_message>
<xml_diff>
--- a/deliverables/Tayseer_Executive_Story_Final.pptx
+++ b/deliverables/Tayseer_Executive_Story_Final.pptx
@@ -2,19 +2,19 @@
 <file path=ppt/presentation.xml><?xml version="1.0" encoding="utf-8"?>
 <p:presentation xmlns:p="http://schemas.openxmlformats.org/presentationml/2006/main">
   <p:sldMasterIdLst>
-    <p:sldMasterId xmlns:r="http://schemas.openxmlformats.org/officeDocument/2006/relationships" id="2147483648" r:id="R7864572e29e04b7e"/>
+    <p:sldMasterId xmlns:r="http://schemas.openxmlformats.org/officeDocument/2006/relationships" id="2147483648" r:id="Rcfcfe6300f8645fa"/>
   </p:sldMasterIdLst>
   <p:notesMasterIdLst>
-    <p:notesMasterId xmlns:r="http://schemas.openxmlformats.org/officeDocument/2006/relationships" r:id="R078d44b5b6d443a8"/>
+    <p:notesMasterId xmlns:r="http://schemas.openxmlformats.org/officeDocument/2006/relationships" r:id="Rddbd0501d71d4b72"/>
   </p:notesMasterIdLst>
   <p:sldIdLst>
-    <p:sldId xmlns:r="http://schemas.openxmlformats.org/officeDocument/2006/relationships" id="256" r:id="R0c3858244f0946db"/>
-    <p:sldId xmlns:r="http://schemas.openxmlformats.org/officeDocument/2006/relationships" id="257" r:id="Rc4cb11010df54fbf"/>
-    <p:sldId xmlns:r="http://schemas.openxmlformats.org/officeDocument/2006/relationships" id="258" r:id="Rdf2b1bc1ab08442d"/>
-    <p:sldId xmlns:r="http://schemas.openxmlformats.org/officeDocument/2006/relationships" id="259" r:id="R8d7e3e4d251e4dfa"/>
-    <p:sldId xmlns:r="http://schemas.openxmlformats.org/officeDocument/2006/relationships" id="260" r:id="Rf5d872fb3e17471e"/>
-    <p:sldId xmlns:r="http://schemas.openxmlformats.org/officeDocument/2006/relationships" id="261" r:id="R6c5e60b06c234b12"/>
-    <p:sldId xmlns:r="http://schemas.openxmlformats.org/officeDocument/2006/relationships" id="262" r:id="R2fc8cffacfc24624"/>
+    <p:sldId xmlns:r="http://schemas.openxmlformats.org/officeDocument/2006/relationships" id="256" r:id="Rad8f7e020653436e"/>
+    <p:sldId xmlns:r="http://schemas.openxmlformats.org/officeDocument/2006/relationships" id="257" r:id="R7be30f1de9f34d0b"/>
+    <p:sldId xmlns:r="http://schemas.openxmlformats.org/officeDocument/2006/relationships" id="258" r:id="R9413290337294d12"/>
+    <p:sldId xmlns:r="http://schemas.openxmlformats.org/officeDocument/2006/relationships" id="259" r:id="Rc43debd6ce5e45e8"/>
+    <p:sldId xmlns:r="http://schemas.openxmlformats.org/officeDocument/2006/relationships" id="260" r:id="Rdce23e26ca6d4c56"/>
+    <p:sldId xmlns:r="http://schemas.openxmlformats.org/officeDocument/2006/relationships" id="261" r:id="Re2d64cec87794f65"/>
+    <p:sldId xmlns:r="http://schemas.openxmlformats.org/officeDocument/2006/relationships" id="262" r:id="Rb817c53ee05b48d7"/>
   </p:sldIdLst>
   <p:sldSz cx="12192000" cy="6858000"/>
   <p:notesSz cx="6858000" cy="9144000"/>
@@ -448,37 +448,57 @@
           <a:lstStyle xmlns:a="http://schemas.openxmlformats.org/drawingml/2006/main"/>
           <a:p xmlns:a="http://schemas.openxmlformats.org/drawingml/2006/main">
             <a:r>
-              <a:t>BLUF/Ask. State the complete request immediately. Approve SAR 40M; release initial SAR 10M only after approval of metric, baseline, comparison design, service plans and cost; hold SAR 30M for review. Big Idea: target the adoption gap with phased funding, validating the metric and demand before any intervention or release.</a:t>
-            </a:r>
-          </a:p>
-          <a:p xmlns:a="http://schemas.openxmlformats.org/drawingml/2006/main">
-            <a:r>
-              <a:t>Source: https://drive.google.com/file/d/1T6pweFV4EjBxZ75gge775OOYMYx2aKX0/view</a:t>
-            </a:r>
-          </a:p>
-          <a:p xmlns:a="http://schemas.openxmlformats.org/drawingml/2006/main">
-            <a:r>
-              <a:t>Method: Arithmetic mean of digital_adoption_pct, matching supplied labs. This is a course index, not digital transactions / total transactions.</a:t>
-            </a:r>
-          </a:p>
-          <a:p xmlns:a="http://schemas.openxmlformats.org/drawingml/2006/main">
-            <a:r>
-              <a:t>Period: December 2025 unless the chart is a monthly trend.</a:t>
+              <a:t>REQUIRED QUESTION: Which regions should get priority, and what decision do we ask for?</a:t>
+            </a:r>
+          </a:p>
+          <a:p xmlns:a="http://schemas.openxmlformats.org/drawingml/2006/main">
+            <a:r>
+              <a:t/>
+            </a:r>
+          </a:p>
+          <a:p xmlns:a="http://schemas.openxmlformats.org/drawingml/2006/main">
+            <a:r>
+              <a:t>SAY: Please approve SAR 40 million for a plan focused on Najran, Jazan and Northern Borders. Release the first SAR 10 million only after we approve the trial plan. Hold SAR 30 million for review. We want to improve adoption where the gap and transaction activity are large, test the results, then expand. The data are synthetic training data.</a:t>
+            </a:r>
+          </a:p>
+          <a:p xmlns:a="http://schemas.openxmlformats.org/drawingml/2006/main">
+            <a:r>
+              <a:t/>
+            </a:r>
+          </a:p>
+          <a:p xmlns:a="http://schemas.openxmlformats.org/drawingml/2006/main">
+            <a:r>
+              <a:t>KEY POINT: Say the full request in the first 30 seconds. Trial plan approval includes the measure, starting data, a fair comparison, service plans and costs. Funding has conditions. The amounts are proposed budgets and need local cost checks.</a:t>
+            </a:r>
+          </a:p>
+          <a:p xmlns:a="http://schemas.openxmlformats.org/drawingml/2006/main">
+            <a:r>
+              <a:t/>
+            </a:r>
+          </a:p>
+          <a:p xmlns:a="http://schemas.openxmlformats.org/drawingml/2006/main">
+            <a:r>
+              <a:t>SOURCES</a:t>
+            </a:r>
+          </a:p>
+          <a:p xmlns:a="http://schemas.openxmlformats.org/drawingml/2006/main">
+            <a:r>
+              <a:t>Course CSV: https://drive.google.com/file/d/1T6pweFV4EjBxZ75gge775OOYMYx2aKX0/view</a:t>
+            </a:r>
+          </a:p>
+          <a:p xmlns:a="http://schemas.openxmlformats.org/drawingml/2006/main">
+            <a:r>
+              <a:t>Data definitions: https://drive.google.com/file/d/1htqVTYconACXDD28CACXOpz8VAyz8Xm5/view</a:t>
+            </a:r>
+          </a:p>
+          <a:p xmlns:a="http://schemas.openxmlformats.org/drawingml/2006/main">
+            <a:r>
+              <a:t>Course calculation reference: https://drive.google.com/file/d/1_DAzbKnnIl4dn1JN2hffwhCueJOoqPOh/view</a:t>
             </a:r>
           </a:p>
           <a:p xmlns:a="http://schemas.openxmlformats.org/drawingml/2006/main">
             <a:r>
               <a:t>All data are synthetic.</a:t>
-            </a:r>
-          </a:p>
-          <a:p xmlns:a="http://schemas.openxmlformats.org/drawingml/2006/main">
-            <a:r>
-              <a:t>Source definitions: https://drive.google.com/file/d/1htqVTYconACXDD28CACXOpz8VAyz8Xm5/view</a:t>
-            </a:r>
-          </a:p>
-          <a:p xmlns:a="http://schemas.openxmlformats.org/drawingml/2006/main">
-            <a:r>
-              <a:t>Course calculation reference: https://drive.google.com/file/d/1_DAzbKnnIl4dn1JN2hffwhCueJOoqPOh/view</a:t>
             </a:r>
           </a:p>
         </p:txBody>
@@ -548,37 +568,57 @@
           <a:lstStyle xmlns:a="http://schemas.openxmlformats.org/drawingml/2006/main"/>
           <a:p xmlns:a="http://schemas.openxmlformats.org/drawingml/2006/main">
             <a:r>
-              <a:t>Situation. Orient the audience to monthly dates, a 0–100% axis and the 65% target. January 2022: 51.40%; December 2025: 63.33%; increase: 11.93 percentage points. No unsupported date for future target attainment.</a:t>
-            </a:r>
-          </a:p>
-          <a:p xmlns:a="http://schemas.openxmlformats.org/drawingml/2006/main">
-            <a:r>
-              <a:t>Source: https://drive.google.com/file/d/1T6pweFV4EjBxZ75gge775OOYMYx2aKX0/view</a:t>
-            </a:r>
-          </a:p>
-          <a:p xmlns:a="http://schemas.openxmlformats.org/drawingml/2006/main">
-            <a:r>
-              <a:t>Method: Arithmetic mean of digital_adoption_pct, matching supplied labs. This is a course index, not digital transactions / total transactions.</a:t>
-            </a:r>
-          </a:p>
-          <a:p xmlns:a="http://schemas.openxmlformats.org/drawingml/2006/main">
-            <a:r>
-              <a:t>Period: December 2025 unless the chart is a monthly trend.</a:t>
+              <a:t>REQUIRED QUESTION: Is Tayseer on track toward 65% nationally? What is the current result and trend?</a:t>
+            </a:r>
+          </a:p>
+          <a:p xmlns:a="http://schemas.openxmlformats.org/drawingml/2006/main">
+            <a:r>
+              <a:t/>
+            </a:r>
+          </a:p>
+          <a:p xmlns:a="http://schemas.openxmlformats.org/drawingml/2006/main">
+            <a:r>
+              <a:t>SAY: The chart shows monthly adoption from January 2022 to December 2025. The vertical scale runs from zero to one hundred percent. The orange line is the 65% target. The course average rose from 51.40% to 63.33%, an improvement of 11.93 percentage points. It is still 1.67 points below target. The data show progress but cannot tell us when the target will be reached.</a:t>
+            </a:r>
+          </a:p>
+          <a:p xmlns:a="http://schemas.openxmlformats.org/drawingml/2006/main">
+            <a:r>
+              <a:t/>
+            </a:r>
+          </a:p>
+          <a:p xmlns:a="http://schemas.openxmlformats.org/drawingml/2006/main">
+            <a:r>
+              <a:t>IF ASKED: The main measure is a simple average of the supplied adoption percentages. It does not directly count digital transactions as a share of all transactions. Giving more weight to records with more transactions changes the result to 66.12%, above target. Agree the measure before any trial release. A percentage-point change means the difference between two percentages.</a:t>
+            </a:r>
+          </a:p>
+          <a:p xmlns:a="http://schemas.openxmlformats.org/drawingml/2006/main">
+            <a:r>
+              <a:t/>
+            </a:r>
+          </a:p>
+          <a:p xmlns:a="http://schemas.openxmlformats.org/drawingml/2006/main">
+            <a:r>
+              <a:t>SOURCES</a:t>
+            </a:r>
+          </a:p>
+          <a:p xmlns:a="http://schemas.openxmlformats.org/drawingml/2006/main">
+            <a:r>
+              <a:t>Course CSV: https://drive.google.com/file/d/1T6pweFV4EjBxZ75gge775OOYMYx2aKX0/view</a:t>
+            </a:r>
+          </a:p>
+          <a:p xmlns:a="http://schemas.openxmlformats.org/drawingml/2006/main">
+            <a:r>
+              <a:t>Data definitions: https://drive.google.com/file/d/1htqVTYconACXDD28CACXOpz8VAyz8Xm5/view</a:t>
+            </a:r>
+          </a:p>
+          <a:p xmlns:a="http://schemas.openxmlformats.org/drawingml/2006/main">
+            <a:r>
+              <a:t>Course calculation reference: https://drive.google.com/file/d/1_DAzbKnnIl4dn1JN2hffwhCueJOoqPOh/view</a:t>
             </a:r>
           </a:p>
           <a:p xmlns:a="http://schemas.openxmlformats.org/drawingml/2006/main">
             <a:r>
               <a:t>All data are synthetic.</a:t>
-            </a:r>
-          </a:p>
-          <a:p xmlns:a="http://schemas.openxmlformats.org/drawingml/2006/main">
-            <a:r>
-              <a:t>Source definitions: https://drive.google.com/file/d/1htqVTYconACXDD28CACXOpz8VAyz8Xm5/view</a:t>
-            </a:r>
-          </a:p>
-          <a:p xmlns:a="http://schemas.openxmlformats.org/drawingml/2006/main">
-            <a:r>
-              <a:t>Course calculation reference: https://drive.google.com/file/d/1_DAzbKnnIl4dn1JN2hffwhCueJOoqPOh/view</a:t>
             </a:r>
           </a:p>
         </p:txBody>
@@ -648,37 +688,67 @@
           <a:lstStyle xmlns:a="http://schemas.openxmlformats.org/drawingml/2006/main"/>
           <a:p xmlns:a="http://schemas.openxmlformats.org/drawingml/2006/main">
             <a:r>
-              <a:t>Complication. Orient to horizontal region bars, 0–100% scale, December 2025 and 65% reference. Nine below and four at/above target. Najran is lowest at 58.89%. Funding requires both gap and activity, not the lowest rate alone. Orange reference is 65%.</a:t>
-            </a:r>
-          </a:p>
-          <a:p xmlns:a="http://schemas.openxmlformats.org/drawingml/2006/main">
-            <a:r>
-              <a:t>Source: https://drive.google.com/file/d/1T6pweFV4EjBxZ75gge775OOYMYx2aKX0/view</a:t>
-            </a:r>
-          </a:p>
-          <a:p xmlns:a="http://schemas.openxmlformats.org/drawingml/2006/main">
-            <a:r>
-              <a:t>Method: Arithmetic mean of digital_adoption_pct, matching supplied labs. This is a course index, not digital transactions / total transactions.</a:t>
-            </a:r>
-          </a:p>
-          <a:p xmlns:a="http://schemas.openxmlformats.org/drawingml/2006/main">
-            <a:r>
-              <a:t>Period: December 2025 unless the chart is a monthly trend.</a:t>
+              <a:t>REQUIRED QUESTION: Which regions are below 65%, and what is the gap?</a:t>
+            </a:r>
+          </a:p>
+          <a:p xmlns:a="http://schemas.openxmlformats.org/drawingml/2006/main">
+            <a:r>
+              <a:t/>
+            </a:r>
+          </a:p>
+          <a:p xmlns:a="http://schemas.openxmlformats.org/drawingml/2006/main">
+            <a:r>
+              <a:t>SAY: Each bar shows a region's December 2025 adoption. The orange line marks 65%. Nine regions are below target: Najran, Al-Baha, Jazan, Northern Borders, Tabuk, Al-Jouf, Asir, Hail and Qassim. Najran has the lowest adoption, 58.89%, with a gap of 6.11 percentage points. Dark teal marks the three regions we propose for the first trials.</a:t>
+            </a:r>
+          </a:p>
+          <a:p xmlns:a="http://schemas.openxmlformats.org/drawingml/2006/main">
+            <a:r>
+              <a:t/>
+            </a:r>
+          </a:p>
+          <a:p xmlns:a="http://schemas.openxmlformats.org/drawingml/2006/main">
+            <a:r>
+              <a:t>WHY THE COLORS: We highlight the proposed trial regions so the audience can follow the funding plan. We do not highlight every region below target.</a:t>
+            </a:r>
+          </a:p>
+          <a:p xmlns:a="http://schemas.openxmlformats.org/drawingml/2006/main">
+            <a:r>
+              <a:t/>
+            </a:r>
+          </a:p>
+          <a:p xmlns:a="http://schemas.openxmlformats.org/drawingml/2006/main">
+            <a:r>
+              <a:t>WHY AL-BAHA IS NOT DARK TEAL: It has lower adoption than Jazan, but the selection also uses transaction activity. Al-Baha ranks fourth under our priority score. Slide 4 explains the score and the very small gap between third and fourth.</a:t>
+            </a:r>
+          </a:p>
+          <a:p xmlns:a="http://schemas.openxmlformats.org/drawingml/2006/main">
+            <a:r>
+              <a:t/>
+            </a:r>
+          </a:p>
+          <a:p xmlns:a="http://schemas.openxmlformats.org/drawingml/2006/main">
+            <a:r>
+              <a:t>SOURCES</a:t>
+            </a:r>
+          </a:p>
+          <a:p xmlns:a="http://schemas.openxmlformats.org/drawingml/2006/main">
+            <a:r>
+              <a:t>Course CSV: https://drive.google.com/file/d/1T6pweFV4EjBxZ75gge775OOYMYx2aKX0/view</a:t>
+            </a:r>
+          </a:p>
+          <a:p xmlns:a="http://schemas.openxmlformats.org/drawingml/2006/main">
+            <a:r>
+              <a:t>Data definitions: https://drive.google.com/file/d/1htqVTYconACXDD28CACXOpz8VAyz8Xm5/view</a:t>
+            </a:r>
+          </a:p>
+          <a:p xmlns:a="http://schemas.openxmlformats.org/drawingml/2006/main">
+            <a:r>
+              <a:t>Course calculation reference: https://drive.google.com/file/d/1_DAzbKnnIl4dn1JN2hffwhCueJOoqPOh/view</a:t>
             </a:r>
           </a:p>
           <a:p xmlns:a="http://schemas.openxmlformats.org/drawingml/2006/main">
             <a:r>
               <a:t>All data are synthetic.</a:t>
-            </a:r>
-          </a:p>
-          <a:p xmlns:a="http://schemas.openxmlformats.org/drawingml/2006/main">
-            <a:r>
-              <a:t>Source definitions: https://drive.google.com/file/d/1htqVTYconACXDD28CACXOpz8VAyz8Xm5/view</a:t>
-            </a:r>
-          </a:p>
-          <a:p xmlns:a="http://schemas.openxmlformats.org/drawingml/2006/main">
-            <a:r>
-              <a:t>Course calculation reference: https://drive.google.com/file/d/1_DAzbKnnIl4dn1JN2hffwhCueJOoqPOh/view</a:t>
             </a:r>
           </a:p>
         </p:txBody>
@@ -748,37 +818,77 @@
           <a:lstStyle xmlns:a="http://schemas.openxmlformats.org/drawingml/2006/main"/>
           <a:p xmlns:a="http://schemas.openxmlformats.org/drawingml/2006/main">
             <a:r>
-              <a:t>Evidence. Orient to December 2025, nine region bars, the 0–600 priority index and the target-gap annotations. Index = max(65 - regional arithmetic mean, 0)/100 × latest-month transactions. Scores: Najran 570.1185, Jazan 455.0824, Northern Borders 446.2597, Al-Baha 445.6012. Third and fourth differ by only 0.6585 index units; that is not a robust separation. Combined top-three share of nine laggard priority scores: 42.6146%. Alternative transaction weighting gives national 66.1186% and ranks Najran, Northern Borders, Al-Baha. These are material sensitivities. Fix the metric and validate demand before scaling. Descriptive data do not prove causes or returns. Chart uses source CSV and the workbook field definitions; it is not a Tableau-export screenshot.</a:t>
-            </a:r>
-          </a:p>
-          <a:p xmlns:a="http://schemas.openxmlformats.org/drawingml/2006/main">
-            <a:r>
-              <a:t>Source: https://drive.google.com/file/d/1T6pweFV4EjBxZ75gge775OOYMYx2aKX0/view</a:t>
-            </a:r>
-          </a:p>
-          <a:p xmlns:a="http://schemas.openxmlformats.org/drawingml/2006/main">
-            <a:r>
-              <a:t>Method: Arithmetic mean of digital_adoption_pct, matching supplied labs. This is a course index, not digital transactions / total transactions.</a:t>
-            </a:r>
-          </a:p>
-          <a:p xmlns:a="http://schemas.openxmlformats.org/drawingml/2006/main">
-            <a:r>
-              <a:t>Period: December 2025 unless the chart is a monthly trend.</a:t>
+              <a:t>REQUIRED QUESTION: Which regions are the biggest priorities, and what evidence supports them?</a:t>
+            </a:r>
+          </a:p>
+          <a:p xmlns:a="http://schemas.openxmlformats.org/drawingml/2006/main">
+            <a:r>
+              <a:t/>
+            </a:r>
+          </a:p>
+          <a:p xmlns:a="http://schemas.openxmlformats.org/drawingml/2006/main">
+            <a:r>
+              <a:t>SAY: We rank the nine regions below target using a priority score. Multiply the positive gap to 65 by December transactions, then divide by 100. Najran ranks first at 570.12, Jazan second at 455.08 and Northern Borders third at 446.26. These three have 42.61% of the total priority score for the nine regions below target.</a:t>
+            </a:r>
+          </a:p>
+          <a:p xmlns:a="http://schemas.openxmlformats.org/drawingml/2006/main">
+            <a:r>
+              <a:t/>
+            </a:r>
+          </a:p>
+          <a:p xmlns:a="http://schemas.openxmlformats.org/drawingml/2006/main">
+            <a:r>
+              <a:t>IMPORTANT LIMIT: 42.61% is a score share. It is not a share of users, transactions or budget. The score helps rank regions. It cannot predict extra digital transactions or investment returns.</a:t>
+            </a:r>
+          </a:p>
+          <a:p xmlns:a="http://schemas.openxmlformats.org/drawingml/2006/main">
+            <a:r>
+              <a:t/>
+            </a:r>
+          </a:p>
+          <a:p xmlns:a="http://schemas.openxmlformats.org/drawingml/2006/main">
+            <a:r>
+              <a:t>WHY AL-BAHA NEEDS A CHECK: Its score is 445.60, only about 0.66 below Northern Borders. This is almost a tie. Weighting adoption by transaction activity changes the top three to Najran, Northern Borders and Al-Baha, replacing Jazan. Confirm the measure and local service demand before funding.</a:t>
+            </a:r>
+          </a:p>
+          <a:p xmlns:a="http://schemas.openxmlformats.org/drawingml/2006/main">
+            <a:r>
+              <a:t/>
+            </a:r>
+          </a:p>
+          <a:p xmlns:a="http://schemas.openxmlformats.org/drawingml/2006/main">
+            <a:r>
+              <a:t>IF ASKED ABOUT TABLEAU: This editable chart uses the supplied CSV and the workbook calculations. The original Day 2 dashboard was not supplied. The reconstructed workbook still needs actual opening and checking in Tableau.</a:t>
+            </a:r>
+          </a:p>
+          <a:p xmlns:a="http://schemas.openxmlformats.org/drawingml/2006/main">
+            <a:r>
+              <a:t/>
+            </a:r>
+          </a:p>
+          <a:p xmlns:a="http://schemas.openxmlformats.org/drawingml/2006/main">
+            <a:r>
+              <a:t>SOURCES</a:t>
+            </a:r>
+          </a:p>
+          <a:p xmlns:a="http://schemas.openxmlformats.org/drawingml/2006/main">
+            <a:r>
+              <a:t>Course CSV: https://drive.google.com/file/d/1T6pweFV4EjBxZ75gge775OOYMYx2aKX0/view</a:t>
+            </a:r>
+          </a:p>
+          <a:p xmlns:a="http://schemas.openxmlformats.org/drawingml/2006/main">
+            <a:r>
+              <a:t>Data definitions: https://drive.google.com/file/d/1htqVTYconACXDD28CACXOpz8VAyz8Xm5/view</a:t>
+            </a:r>
+          </a:p>
+          <a:p xmlns:a="http://schemas.openxmlformats.org/drawingml/2006/main">
+            <a:r>
+              <a:t>Course calculation reference: https://drive.google.com/file/d/1_DAzbKnnIl4dn1JN2hffwhCueJOoqPOh/view</a:t>
             </a:r>
           </a:p>
           <a:p xmlns:a="http://schemas.openxmlformats.org/drawingml/2006/main">
             <a:r>
               <a:t>All data are synthetic.</a:t>
-            </a:r>
-          </a:p>
-          <a:p xmlns:a="http://schemas.openxmlformats.org/drawingml/2006/main">
-            <a:r>
-              <a:t>Source definitions: https://drive.google.com/file/d/1htqVTYconACXDD28CACXOpz8VAyz8Xm5/view</a:t>
-            </a:r>
-          </a:p>
-          <a:p xmlns:a="http://schemas.openxmlformats.org/drawingml/2006/main">
-            <a:r>
-              <a:t>Course calculation reference: https://drive.google.com/file/d/1_DAzbKnnIl4dn1JN2hffwhCueJOoqPOh/view</a:t>
             </a:r>
           </a:p>
         </p:txBody>
@@ -848,37 +958,57 @@
           <a:lstStyle xmlns:a="http://schemas.openxmlformats.org/drawingml/2006/main"/>
           <a:p xmlns:a="http://schemas.openxmlformats.org/drawingml/2006/main">
             <a:r>
-              <a:t>Options. Compare equal nine-region coverage, full concentration and staged investment. Select staged because metric sensitivity and the lack of a causal response model warrant learning before the full release. Equal allocation 40/9 = 4.444M, rounded for display only.</a:t>
-            </a:r>
-          </a:p>
-          <a:p xmlns:a="http://schemas.openxmlformats.org/drawingml/2006/main">
-            <a:r>
-              <a:t>Source: https://drive.google.com/file/d/1T6pweFV4EjBxZ75gge775OOYMYx2aKX0/view</a:t>
-            </a:r>
-          </a:p>
-          <a:p xmlns:a="http://schemas.openxmlformats.org/drawingml/2006/main">
-            <a:r>
-              <a:t>Method: Arithmetic mean of digital_adoption_pct, matching supplied labs. This is a course index, not digital transactions / total transactions.</a:t>
-            </a:r>
-          </a:p>
-          <a:p xmlns:a="http://schemas.openxmlformats.org/drawingml/2006/main">
-            <a:r>
-              <a:t>Period: December 2025 unless the chart is a monthly trend.</a:t>
+              <a:t>REQUIRED QUESTION: What are the realistic choices for using SAR 40 million?</a:t>
+            </a:r>
+          </a:p>
+          <a:p xmlns:a="http://schemas.openxmlformats.org/drawingml/2006/main">
+            <a:r>
+              <a:t/>
+            </a:r>
+          </a:p>
+          <a:p xmlns:a="http://schemas.openxmlformats.org/drawingml/2006/main">
+            <a:r>
+              <a:t>SAY: We compare three choices. Equal funding gives each of the nine regions about SAR 4.44 million, but ignores their different gaps and activity. Using all the money now focuses on three regions but spends the full budget before testing. Funding in steps sets aside SAR 35 million for regions and SAR 5 million for review. We choose this option. Release the first SAR 10 million after trial plan approval and hold SAR 30 million for review.</a:t>
+            </a:r>
+          </a:p>
+          <a:p xmlns:a="http://schemas.openxmlformats.org/drawingml/2006/main">
+            <a:r>
+              <a:t/>
+            </a:r>
+          </a:p>
+          <a:p xmlns:a="http://schemas.openxmlformats.org/drawingml/2006/main">
+            <a:r>
+              <a:t>IF ASKED WHY: The region ranking can change with the measure, and the data do not show what return the money will produce. Small trials give us evidence before a larger release.</a:t>
+            </a:r>
+          </a:p>
+          <a:p xmlns:a="http://schemas.openxmlformats.org/drawingml/2006/main">
+            <a:r>
+              <a:t/>
+            </a:r>
+          </a:p>
+          <a:p xmlns:a="http://schemas.openxmlformats.org/drawingml/2006/main">
+            <a:r>
+              <a:t>SOURCES</a:t>
+            </a:r>
+          </a:p>
+          <a:p xmlns:a="http://schemas.openxmlformats.org/drawingml/2006/main">
+            <a:r>
+              <a:t>Course CSV: https://drive.google.com/file/d/1T6pweFV4EjBxZ75gge775OOYMYx2aKX0/view</a:t>
+            </a:r>
+          </a:p>
+          <a:p xmlns:a="http://schemas.openxmlformats.org/drawingml/2006/main">
+            <a:r>
+              <a:t>Data definitions: https://drive.google.com/file/d/1htqVTYconACXDD28CACXOpz8VAyz8Xm5/view</a:t>
+            </a:r>
+          </a:p>
+          <a:p xmlns:a="http://schemas.openxmlformats.org/drawingml/2006/main">
+            <a:r>
+              <a:t>Course calculation reference: https://drive.google.com/file/d/1_DAzbKnnIl4dn1JN2hffwhCueJOoqPOh/view</a:t>
             </a:r>
           </a:p>
           <a:p xmlns:a="http://schemas.openxmlformats.org/drawingml/2006/main">
             <a:r>
               <a:t>All data are synthetic.</a:t>
-            </a:r>
-          </a:p>
-          <a:p xmlns:a="http://schemas.openxmlformats.org/drawingml/2006/main">
-            <a:r>
-              <a:t>Source definitions: https://drive.google.com/file/d/1htqVTYconACXDD28CACXOpz8VAyz8Xm5/view</a:t>
-            </a:r>
-          </a:p>
-          <a:p xmlns:a="http://schemas.openxmlformats.org/drawingml/2006/main">
-            <a:r>
-              <a:t>Course calculation reference: https://drive.google.com/file/d/1_DAzbKnnIl4dn1JN2hffwhCueJOoqPOh/view</a:t>
             </a:r>
           </a:p>
         </p:txBody>
@@ -948,37 +1078,67 @@
           <a:lstStyle xmlns:a="http://schemas.openxmlformats.org/drawingml/2006/main"/>
           <a:p xmlns:a="http://schemas.openxmlformats.org/drawingml/2006/main">
             <a:r>
-              <a:t>Recommendation. SAR 35M proportional to the current top-three score, rounded using largest remainders, plus SAR 5M reserve. Intended effect: raise selected-region adoption without degrading service. Illustrative national scenario: 63.328346 + (6.11125+4.33825+4.08775)/13 = 64.44660%. This is conditional arithmetic, not a forecast or causal return. A next wave would still be needed. No observed investment-response coefficients are available.</a:t>
-            </a:r>
-          </a:p>
-          <a:p xmlns:a="http://schemas.openxmlformats.org/drawingml/2006/main">
-            <a:r>
-              <a:t>Source: https://drive.google.com/file/d/1T6pweFV4EjBxZ75gge775OOYMYx2aKX0/view</a:t>
-            </a:r>
-          </a:p>
-          <a:p xmlns:a="http://schemas.openxmlformats.org/drawingml/2006/main">
-            <a:r>
-              <a:t>Method: Arithmetic mean of digital_adoption_pct, matching supplied labs. This is a course index, not digital transactions / total transactions.</a:t>
-            </a:r>
-          </a:p>
-          <a:p xmlns:a="http://schemas.openxmlformats.org/drawingml/2006/main">
-            <a:r>
-              <a:t>Period: December 2025 unless the chart is a monthly trend.</a:t>
+              <a:t>REQUIRED QUESTION: Which option and regions do we recommend, why, and what effect can we show?</a:t>
+            </a:r>
+          </a:p>
+          <a:p xmlns:a="http://schemas.openxmlformats.org/drawingml/2006/main">
+            <a:r>
+              <a:t/>
+            </a:r>
+          </a:p>
+          <a:p xmlns:a="http://schemas.openxmlformats.org/drawingml/2006/main">
+            <a:r>
+              <a:t>SAY: We recommend funding in steps. The proposed budgets are SAR 13 million for Najran, SAR 11 million each for Jazan and Northern Borders, and SAR 5 million for review and reserve. We split the regional SAR 35 million in proportion to the priority scores and round to whole millions. These are proposed budgets, so we must check local costs.</a:t>
+            </a:r>
+          </a:p>
+          <a:p xmlns:a="http://schemas.openxmlformats.org/drawingml/2006/main">
+            <a:r>
+              <a:t/>
+            </a:r>
+          </a:p>
+          <a:p xmlns:a="http://schemas.openxmlformats.org/drawingml/2006/main">
+            <a:r>
+              <a:t>EXPLAIN 64.45%: If these three regions reach 65% and all other regions stay unchanged, the national course average becomes 64.45%. It still falls below 65%. This is an example based on those conditions. It does not predict the effect of SAR 40 million.</a:t>
+            </a:r>
+          </a:p>
+          <a:p xmlns:a="http://schemas.openxmlformats.org/drawingml/2006/main">
+            <a:r>
+              <a:t/>
+            </a:r>
+          </a:p>
+          <a:p xmlns:a="http://schemas.openxmlformats.org/drawingml/2006/main">
+            <a:r>
+              <a:t>IF ASKED: We round each regional amount down first, then give the remaining millions to the largest decimal parts. This keeps the total at 40 million. The first 10 million splits into 3.72 million for Najran and 3.14 million each for Jazan and Northern Borders. Possible trial work includes helping users sign up or removing steps that delay services. Check the actual barriers before choosing a service plan.</a:t>
+            </a:r>
+          </a:p>
+          <a:p xmlns:a="http://schemas.openxmlformats.org/drawingml/2006/main">
+            <a:r>
+              <a:t/>
+            </a:r>
+          </a:p>
+          <a:p xmlns:a="http://schemas.openxmlformats.org/drawingml/2006/main">
+            <a:r>
+              <a:t>SOURCES</a:t>
+            </a:r>
+          </a:p>
+          <a:p xmlns:a="http://schemas.openxmlformats.org/drawingml/2006/main">
+            <a:r>
+              <a:t>Course CSV: https://drive.google.com/file/d/1T6pweFV4EjBxZ75gge775OOYMYx2aKX0/view</a:t>
+            </a:r>
+          </a:p>
+          <a:p xmlns:a="http://schemas.openxmlformats.org/drawingml/2006/main">
+            <a:r>
+              <a:t>Data definitions: https://drive.google.com/file/d/1htqVTYconACXDD28CACXOpz8VAyz8Xm5/view</a:t>
+            </a:r>
+          </a:p>
+          <a:p xmlns:a="http://schemas.openxmlformats.org/drawingml/2006/main">
+            <a:r>
+              <a:t>Course calculation reference: https://drive.google.com/file/d/1_DAzbKnnIl4dn1JN2hffwhCueJOoqPOh/view</a:t>
             </a:r>
           </a:p>
           <a:p xmlns:a="http://schemas.openxmlformats.org/drawingml/2006/main">
             <a:r>
               <a:t>All data are synthetic.</a:t>
-            </a:r>
-          </a:p>
-          <a:p xmlns:a="http://schemas.openxmlformats.org/drawingml/2006/main">
-            <a:r>
-              <a:t>Source definitions: https://drive.google.com/file/d/1htqVTYconACXDD28CACXOpz8VAyz8Xm5/view</a:t>
-            </a:r>
-          </a:p>
-          <a:p xmlns:a="http://schemas.openxmlformats.org/drawingml/2006/main">
-            <a:r>
-              <a:t>Course calculation reference: https://drive.google.com/file/d/1_DAzbKnnIl4dn1JN2hffwhCueJOoqPOh/view</a:t>
             </a:r>
           </a:p>
         </p:txBody>
@@ -1048,37 +1208,67 @@
           <a:lstStyle xmlns:a="http://schemas.openxmlformats.org/drawingml/2006/main"/>
           <a:p xmlns:a="http://schemas.openxmlformats.org/drawingml/2006/main">
             <a:r>
-              <a:t>Ask and next step. Approve 40M, authorize initial 10M only after approval of metric, baseline, comparison design, service plan and cost; hold 30M. Nominate owner on approval Day 0. Validate shortlist and approve baseline before any intervention or release; launch within 30 days if ready. Day 90 is counted from envelope approval; report pilot exposure and extend review if insufficient. Suggested +2pp is a management goal, not a causal forecast. Assess matched CSAT/SLA, costs and comparison design. Rerank if metric changes.</a:t>
-            </a:r>
-          </a:p>
-          <a:p xmlns:a="http://schemas.openxmlformats.org/drawingml/2006/main">
-            <a:r>
-              <a:t>Source: https://drive.google.com/file/d/1T6pweFV4EjBxZ75gge775OOYMYx2aKX0/view</a:t>
-            </a:r>
-          </a:p>
-          <a:p xmlns:a="http://schemas.openxmlformats.org/drawingml/2006/main">
-            <a:r>
-              <a:t>Method: Arithmetic mean of digital_adoption_pct, matching supplied labs. This is a course index, not digital transactions / total transactions.</a:t>
-            </a:r>
-          </a:p>
-          <a:p xmlns:a="http://schemas.openxmlformats.org/drawingml/2006/main">
-            <a:r>
-              <a:t>Period: December 2025 unless the chart is a monthly trend.</a:t>
+              <a:t>REQUIRED QUESTION: What exactly should the decision-maker approve and do next?</a:t>
+            </a:r>
+          </a:p>
+          <a:p xmlns:a="http://schemas.openxmlformats.org/drawingml/2006/main">
+            <a:r>
+              <a:t/>
+            </a:r>
+          </a:p>
+          <a:p xmlns:a="http://schemas.openxmlformats.org/drawingml/2006/main">
+            <a:r>
+              <a:t>SAY: Please approve the SAR 40 million plan. Release the first SAR 10 million only after trial plan approval, and hold SAR 30 million. At budget approval, choose a lead. Before any release or service change, agree the adoption measure, collect starting data, choose a fair comparison, check the region selection and approve service plans and costs. Start within thirty days only if ready.</a:t>
+            </a:r>
+          </a:p>
+          <a:p xmlns:a="http://schemas.openxmlformats.org/drawingml/2006/main">
+            <a:r>
+              <a:t/>
+            </a:r>
+          </a:p>
+          <a:p xmlns:a="http://schemas.openxmlformats.org/drawingml/2006/main">
+            <a:r>
+              <a:t>CHECKPOINT: Review results and costs at day ninety from budget approval. Record how long the trials actually ran. Extend the review if that time is too short. A gain of two percentage points, with steady customer satisfaction and service quality, is a proposed goal. It is not a promised result. Pause later releases if evidence is weak.</a:t>
+            </a:r>
+          </a:p>
+          <a:p xmlns:a="http://schemas.openxmlformats.org/drawingml/2006/main">
+            <a:r>
+              <a:t/>
+            </a:r>
+          </a:p>
+          <a:p xmlns:a="http://schemas.openxmlformats.org/drawingml/2006/main">
+            <a:r>
+              <a:t>SIMPLE TERMS: Starting data means the values before the trial. A fair comparison helps check whether a change came from the trial or from other factors.</a:t>
+            </a:r>
+          </a:p>
+          <a:p xmlns:a="http://schemas.openxmlformats.org/drawingml/2006/main">
+            <a:r>
+              <a:t/>
+            </a:r>
+          </a:p>
+          <a:p xmlns:a="http://schemas.openxmlformats.org/drawingml/2006/main">
+            <a:r>
+              <a:t>SOURCES</a:t>
+            </a:r>
+          </a:p>
+          <a:p xmlns:a="http://schemas.openxmlformats.org/drawingml/2006/main">
+            <a:r>
+              <a:t>Course CSV: https://drive.google.com/file/d/1T6pweFV4EjBxZ75gge775OOYMYx2aKX0/view</a:t>
+            </a:r>
+          </a:p>
+          <a:p xmlns:a="http://schemas.openxmlformats.org/drawingml/2006/main">
+            <a:r>
+              <a:t>Data definitions: https://drive.google.com/file/d/1htqVTYconACXDD28CACXOpz8VAyz8Xm5/view</a:t>
+            </a:r>
+          </a:p>
+          <a:p xmlns:a="http://schemas.openxmlformats.org/drawingml/2006/main">
+            <a:r>
+              <a:t>Course calculation reference: https://drive.google.com/file/d/1_DAzbKnnIl4dn1JN2hffwhCueJOoqPOh/view</a:t>
             </a:r>
           </a:p>
           <a:p xmlns:a="http://schemas.openxmlformats.org/drawingml/2006/main">
             <a:r>
               <a:t>All data are synthetic.</a:t>
-            </a:r>
-          </a:p>
-          <a:p xmlns:a="http://schemas.openxmlformats.org/drawingml/2006/main">
-            <a:r>
-              <a:t>Source definitions: https://drive.google.com/file/d/1htqVTYconACXDD28CACXOpz8VAyz8Xm5/view</a:t>
-            </a:r>
-          </a:p>
-          <a:p xmlns:a="http://schemas.openxmlformats.org/drawingml/2006/main">
-            <a:r>
-              <a:t>Course calculation reference: https://drive.google.com/file/d/1_DAzbKnnIl4dn1JN2hffwhCueJOoqPOh/view</a:t>
             </a:r>
           </a:p>
         </p:txBody>
@@ -1146,7 +1336,7 @@
   </p:cSld>
   <p:clrMap bg1="lt1" tx1="dk1" bg2="lt2" tx2="dk2" accent1="accent1" accent2="accent2" accent3="accent3" accent4="accent4" accent5="accent5" accent6="accent6" hlink="hlink" folHlink="folHlink"/>
   <p:sldLayoutIdLst>
-    <p:sldLayoutId xmlns:r="http://schemas.openxmlformats.org/officeDocument/2006/relationships" id="2147483649" r:id="R52908d3b4f6d4b17"/>
+    <p:sldLayoutId xmlns:r="http://schemas.openxmlformats.org/officeDocument/2006/relationships" id="2147483649" r:id="Rd60fa1391170443b"/>
   </p:sldLayoutIdLst>
   <p:txStyles>
     <p:titleStyle>
@@ -4290,6 +4480,7 @@
           <a:lstStyle xmlns:a="http://schemas.openxmlformats.org/drawingml/2006/main"/>
           <a:p xmlns:a="http://schemas.openxmlformats.org/drawingml/2006/main">
             <a:pPr algn="l">
+              <a:buNone/>
               <a:defRPr sz="3225" b="1">
                 <a:solidFill>
                   <a:srgbClr val="15363D"/>
@@ -4308,7 +4499,7 @@
                 <a:ea typeface="Arial"/>
                 <a:cs typeface="Arial"/>
               </a:rPr>
-              <a:t>Phase funding for Najran, Jazan and Northern Borders</a:t>
+              <a:t>Trial funding focuses on three regions</a:t>
             </a:r>
           </a:p>
         </p:txBody>
@@ -4347,6 +4538,7 @@
           <a:lstStyle xmlns:a="http://schemas.openxmlformats.org/drawingml/2006/main"/>
           <a:p xmlns:a="http://schemas.openxmlformats.org/drawingml/2006/main">
             <a:pPr algn="l">
+              <a:buNone/>
               <a:defRPr sz="1275" b="0">
                 <a:solidFill>
                   <a:srgbClr val="56666B"/>
@@ -4404,6 +4596,7 @@
           <a:lstStyle xmlns:a="http://schemas.openxmlformats.org/drawingml/2006/main"/>
           <a:p xmlns:a="http://schemas.openxmlformats.org/drawingml/2006/main">
             <a:pPr algn="l">
+              <a:buNone/>
               <a:defRPr sz="6225" b="1">
                 <a:solidFill>
                   <a:srgbClr val="087D82"/>
@@ -4461,6 +4654,7 @@
           <a:lstStyle xmlns:a="http://schemas.openxmlformats.org/drawingml/2006/main"/>
           <a:p xmlns:a="http://schemas.openxmlformats.org/drawingml/2006/main">
             <a:pPr algn="l">
+              <a:buNone/>
               <a:defRPr sz="2325" b="0">
                 <a:solidFill>
                   <a:srgbClr val="15363D"/>
@@ -4479,7 +4673,7 @@
                 <a:ea typeface="Arial"/>
                 <a:cs typeface="Arial"/>
               </a:rPr>
-              <a:t>Requested funding envelope</a:t>
+              <a:t>Najran, Jazan and Northern Borders</a:t>
             </a:r>
           </a:p>
         </p:txBody>
@@ -4518,6 +4712,7 @@
           <a:lstStyle xmlns:a="http://schemas.openxmlformats.org/drawingml/2006/main"/>
           <a:p xmlns:a="http://schemas.openxmlformats.org/drawingml/2006/main">
             <a:pPr algn="l">
+              <a:buNone/>
               <a:defRPr sz="2625" b="1">
                 <a:solidFill>
                   <a:srgbClr val="15363D"/>
@@ -4536,7 +4731,8 @@
                 <a:ea typeface="Arial"/>
                 <a:cs typeface="Arial"/>
               </a:rPr>
-              <a:t>Release SAR 10M after baseline approval; hold SAR 30M</a:t>
+              <a:t>First SAR 10M after trial plan approval.
+Hold SAR 30M for review.</a:t>
             </a:r>
           </a:p>
         </p:txBody>
@@ -4575,6 +4771,7 @@
           <a:lstStyle xmlns:a="http://schemas.openxmlformats.org/drawingml/2006/main"/>
           <a:p xmlns:a="http://schemas.openxmlformats.org/drawingml/2006/main">
             <a:pPr algn="l">
+              <a:buNone/>
               <a:defRPr sz="2100" b="0">
                 <a:solidFill>
                   <a:srgbClr val="15363D"/>
@@ -4593,7 +4790,7 @@
                 <a:ea typeface="Arial"/>
                 <a:cs typeface="Arial"/>
               </a:rPr>
-              <a:t>Move lagging regions toward the 65% adoption target</a:t>
+              <a:t>Target 65%. Fund large gaps and test before expanding.</a:t>
             </a:r>
           </a:p>
         </p:txBody>
@@ -4632,6 +4829,7 @@
           <a:lstStyle xmlns:a="http://schemas.openxmlformats.org/drawingml/2006/main"/>
           <a:p xmlns:a="http://schemas.openxmlformats.org/drawingml/2006/main">
             <a:pPr algn="l">
+              <a:buNone/>
               <a:defRPr sz="1350" b="0">
                 <a:solidFill>
                   <a:srgbClr val="56666B"/>
@@ -4650,7 +4848,7 @@
                 <a:ea typeface="Arial"/>
                 <a:cs typeface="Arial"/>
               </a:rPr>
-              <a:t>SDAIA Academy SDA-DSC-112 · Synthetic training data</a:t>
+              <a:t>SDAIA Academy SDA-DSC-112. Synthetic training data.</a:t>
             </a:r>
           </a:p>
         </p:txBody>
@@ -4718,6 +4916,7 @@
           <a:lstStyle xmlns:a="http://schemas.openxmlformats.org/drawingml/2006/main"/>
           <a:p xmlns:a="http://schemas.openxmlformats.org/drawingml/2006/main">
             <a:pPr algn="l">
+              <a:buNone/>
               <a:defRPr sz="3225" b="1">
                 <a:solidFill>
                   <a:srgbClr val="15363D"/>
@@ -4736,7 +4935,7 @@
                 <a:ea typeface="Arial"/>
                 <a:cs typeface="Arial"/>
               </a:rPr>
-              <a:t>National course adoption remains below 65%</a:t>
+              <a:t>Adoption improved but is still below 65%</a:t>
             </a:r>
           </a:p>
         </p:txBody>
@@ -4775,6 +4974,7 @@
           <a:lstStyle xmlns:a="http://schemas.openxmlformats.org/drawingml/2006/main"/>
           <a:p xmlns:a="http://schemas.openxmlformats.org/drawingml/2006/main">
             <a:pPr algn="l">
+              <a:buNone/>
               <a:defRPr sz="1275" b="0">
                 <a:solidFill>
                   <a:srgbClr val="56666B"/>
@@ -4832,6 +5032,7 @@
           <a:lstStyle xmlns:a="http://schemas.openxmlformats.org/drawingml/2006/main"/>
           <a:p xmlns:a="http://schemas.openxmlformats.org/drawingml/2006/main">
             <a:pPr algn="l">
+              <a:buNone/>
               <a:defRPr sz="4875" b="1">
                 <a:solidFill>
                   <a:srgbClr val="087D82"/>
@@ -4889,6 +5090,7 @@
           <a:lstStyle xmlns:a="http://schemas.openxmlformats.org/drawingml/2006/main"/>
           <a:p xmlns:a="http://schemas.openxmlformats.org/drawingml/2006/main">
             <a:pPr algn="l">
+              <a:buNone/>
               <a:defRPr sz="2175" b="0">
                 <a:solidFill>
                   <a:srgbClr val="15363D"/>
@@ -4907,27 +5109,11 @@
                 <a:ea typeface="Arial"/>
                 <a:cs typeface="Arial"/>
               </a:rPr>
-              <a:t>December 2025: a 1.67 percentage point gap</a:t>
+              <a:t>December 2025. Gap: 1.67 percentage points</a:t>
             </a:r>
           </a:p>
         </p:txBody>
       </p:sp>
-      <p:graphicFrame>
-        <p:nvGraphicFramePr>
-          <p:cNvPr id="15" name="Chart"/>
-          <p:cNvGraphicFramePr/>
-          <p:nvPr/>
-        </p:nvGraphicFramePr>
-        <p:xfrm>
-          <a:off xmlns:a="http://schemas.openxmlformats.org/drawingml/2006/main" x="619125" y="2581275"/>
-          <a:ext xmlns:a="http://schemas.openxmlformats.org/drawingml/2006/main" cx="10953750" cy="3086100"/>
-        </p:xfrm>
-        <a:graphic xmlns:a="http://schemas.openxmlformats.org/drawingml/2006/main">
-          <a:graphicData uri="http://schemas.openxmlformats.org/drawingml/2006/chart">
-            <c:chart xmlns:r="http://schemas.openxmlformats.org/officeDocument/2006/relationships" xmlns:c="http://schemas.openxmlformats.org/drawingml/2006/chart" r:id="R8d7eaa1160c64cdb"/>
-          </a:graphicData>
-        </a:graphic>
-      </p:graphicFrame>
       <p:sp>
         <p:nvSpPr>
           <p:cNvPr id="6" name="">
@@ -4962,6 +5148,7 @@
           <a:lstStyle xmlns:a="http://schemas.openxmlformats.org/drawingml/2006/main"/>
           <a:p xmlns:a="http://schemas.openxmlformats.org/drawingml/2006/main">
             <a:pPr algn="l">
+              <a:buNone/>
               <a:defRPr sz="1425" b="0">
                 <a:solidFill>
                   <a:srgbClr val="56666B"/>
@@ -5019,6 +5206,7 @@
           <a:lstStyle xmlns:a="http://schemas.openxmlformats.org/drawingml/2006/main"/>
           <a:p xmlns:a="http://schemas.openxmlformats.org/drawingml/2006/main">
             <a:pPr algn="ctr">
+              <a:buNone/>
               <a:defRPr sz="1425" b="0">
                 <a:solidFill>
                   <a:srgbClr val="56666B"/>
@@ -5076,6 +5264,7 @@
           <a:lstStyle xmlns:a="http://schemas.openxmlformats.org/drawingml/2006/main"/>
           <a:p xmlns:a="http://schemas.openxmlformats.org/drawingml/2006/main">
             <a:pPr algn="r">
+              <a:buNone/>
               <a:defRPr sz="1425" b="0">
                 <a:solidFill>
                   <a:srgbClr val="56666B"/>
@@ -5133,6 +5322,7 @@
           <a:lstStyle xmlns:a="http://schemas.openxmlformats.org/drawingml/2006/main"/>
           <a:p xmlns:a="http://schemas.openxmlformats.org/drawingml/2006/main">
             <a:pPr algn="l">
+              <a:buNone/>
               <a:defRPr sz="1275" b="0">
                 <a:solidFill>
                   <a:srgbClr val="B45C16"/>
@@ -5151,7 +5341,7 @@
                 <a:ea typeface="Arial"/>
                 <a:cs typeface="Arial"/>
               </a:rPr>
-              <a:t>Transaction-weighted alternative: 66.12% (&gt;65%). Target status depends on the definition.</a:t>
+              <a:t>Using transaction counts as weights gives 66.12%, above 65%.</a:t>
             </a:r>
           </a:p>
         </p:txBody>
@@ -5190,6 +5380,7 @@
           <a:lstStyle xmlns:a="http://schemas.openxmlformats.org/drawingml/2006/main"/>
           <a:p xmlns:a="http://schemas.openxmlformats.org/drawingml/2006/main">
             <a:pPr algn="l">
+              <a:buNone/>
               <a:defRPr sz="1350" b="0">
                 <a:solidFill>
                   <a:srgbClr val="56666B"/>
@@ -5208,11 +5399,27 @@
                 <a:ea typeface="Arial"/>
                 <a:cs typeface="Arial"/>
               </a:rPr>
-              <a:t>Course arithmetic-mean index, not the digital transaction share. 48 months of synthetic data.</a:t>
+              <a:t>Course measure: simple average of adoption percentages. Synthetic training data.</a:t>
             </a:r>
           </a:p>
         </p:txBody>
       </p:sp>
+      <p:graphicFrame>
+        <p:nvGraphicFramePr>
+          <p:cNvPr id="22" name="Chart"/>
+          <p:cNvGraphicFramePr/>
+          <p:nvPr/>
+        </p:nvGraphicFramePr>
+        <p:xfrm>
+          <a:off xmlns:a="http://schemas.openxmlformats.org/drawingml/2006/main" x="619125" y="2581275"/>
+          <a:ext xmlns:a="http://schemas.openxmlformats.org/drawingml/2006/main" cx="10953750" cy="3086100"/>
+        </p:xfrm>
+        <a:graphic xmlns:a="http://schemas.openxmlformats.org/drawingml/2006/main">
+          <a:graphicData uri="http://schemas.openxmlformats.org/drawingml/2006/chart">
+            <c:chart xmlns:r="http://schemas.openxmlformats.org/officeDocument/2006/relationships" xmlns:c="http://schemas.openxmlformats.org/drawingml/2006/chart" r:id="R51e1efa725604f21"/>
+          </a:graphicData>
+        </a:graphic>
+      </p:graphicFrame>
     </p:spTree>
     <p:extLst>
       <p:ext uri="{BB962C8B-B14F-4D97-AF65-F5344CB8AC3E}">
@@ -5276,6 +5483,7 @@
           <a:lstStyle xmlns:a="http://schemas.openxmlformats.org/drawingml/2006/main"/>
           <a:p xmlns:a="http://schemas.openxmlformats.org/drawingml/2006/main">
             <a:pPr algn="l">
+              <a:buNone/>
               <a:defRPr sz="3225" b="1">
                 <a:solidFill>
                   <a:srgbClr val="15363D"/>
@@ -5294,7 +5502,7 @@
                 <a:ea typeface="Arial"/>
                 <a:cs typeface="Arial"/>
               </a:rPr>
-              <a:t>Nine regions remain below target in December 2025</a:t>
+              <a:t>Nine regions are below 65% in December 2025</a:t>
             </a:r>
           </a:p>
         </p:txBody>
@@ -5333,6 +5541,7 @@
           <a:lstStyle xmlns:a="http://schemas.openxmlformats.org/drawingml/2006/main"/>
           <a:p xmlns:a="http://schemas.openxmlformats.org/drawingml/2006/main">
             <a:pPr algn="l">
+              <a:buNone/>
               <a:defRPr sz="1275" b="0">
                 <a:solidFill>
                   <a:srgbClr val="56666B"/>
@@ -5352,109 +5561,6 @@
                 <a:cs typeface="Arial"/>
               </a:rPr>
               <a:t>3 / 7</a:t>
-            </a:r>
-          </a:p>
-        </p:txBody>
-      </p:sp>
-      <p:graphicFrame>
-        <p:nvGraphicFramePr>
-          <p:cNvPr id="9" name="Chart"/>
-          <p:cNvGraphicFramePr/>
-          <p:nvPr/>
-        </p:nvGraphicFramePr>
-        <p:xfrm>
-          <a:off xmlns:a="http://schemas.openxmlformats.org/drawingml/2006/main" x="609600" y="1600200"/>
-          <a:ext xmlns:a="http://schemas.openxmlformats.org/drawingml/2006/main" cx="10972800" cy="4267200"/>
-        </p:xfrm>
-        <a:graphic xmlns:a="http://schemas.openxmlformats.org/drawingml/2006/main">
-          <a:graphicData uri="http://schemas.openxmlformats.org/drawingml/2006/chart">
-            <c:chart xmlns:r="http://schemas.openxmlformats.org/officeDocument/2006/relationships" xmlns:c="http://schemas.openxmlformats.org/drawingml/2006/chart" r:id="R1d3c14d626b04ada"/>
-          </a:graphicData>
-        </a:graphic>
-      </p:graphicFrame>
-      <p:sp>
-        <p:nvSpPr>
-          <p:cNvPr id="4" name="">
-            <a:extLst xmlns:a="http://schemas.openxmlformats.org/drawingml/2006/main">
-              <a:ext uri="{FF2B5EF4-FFF2-40B4-BE49-F238E27FC236}">
-                <a16:creationId xmlns:a16="http://schemas.microsoft.com/office/drawing/2014/main" id="{A4E13E96-3B7D-4D12-9ED0-B0F661EAE42A}"/>
-              </a:ext>
-            </a:extLst>
-          </p:cNvPr>
-          <p:cNvSpPr>
-            <a:spLocks xmlns:a="http://schemas.openxmlformats.org/drawingml/2006/main" noGrp="1"/>
-          </p:cNvSpPr>
-          <p:nvPr/>
-        </p:nvSpPr>
-        <p:spPr>
-          <a:xfrm xmlns:a="http://schemas.openxmlformats.org/drawingml/2006/main">
-            <a:off x="8036243" y="1781175"/>
-            <a:ext cx="19050" cy="3657600"/>
-          </a:xfrm>
-          <a:prstGeom xmlns:a="http://schemas.openxmlformats.org/drawingml/2006/main" prst="rect">
-            <a:avLst/>
-          </a:prstGeom>
-          <a:solidFill xmlns:a="http://schemas.openxmlformats.org/drawingml/2006/main">
-            <a:srgbClr val="B45C16"/>
-          </a:solidFill>
-          <a:ln xmlns:a="http://schemas.openxmlformats.org/drawingml/2006/main" w="0">
-            <a:noFill/>
-          </a:ln>
-        </p:spPr>
-      </p:sp>
-      <p:sp>
-        <p:nvSpPr>
-          <p:cNvPr id="5" name="">
-            <a:extLst xmlns:a="http://schemas.openxmlformats.org/drawingml/2006/main">
-              <a:ext uri="{FF2B5EF4-FFF2-40B4-BE49-F238E27FC236}">
-                <a16:creationId xmlns:a16="http://schemas.microsoft.com/office/drawing/2014/main" id="{56C22908-0C65-4E08-AB46-441B2C93322E}"/>
-              </a:ext>
-            </a:extLst>
-          </p:cNvPr>
-          <p:cNvSpPr>
-            <a:spLocks xmlns:a="http://schemas.openxmlformats.org/drawingml/2006/main" noGrp="1"/>
-          </p:cNvSpPr>
-          <p:nvPr/>
-        </p:nvSpPr>
-        <p:spPr>
-          <a:xfrm xmlns:a="http://schemas.openxmlformats.org/drawingml/2006/main">
-            <a:off x="7877175" y="1524000"/>
-            <a:ext cx="1657350" cy="342900"/>
-          </a:xfrm>
-          <a:prstGeom xmlns:a="http://schemas.openxmlformats.org/drawingml/2006/main" prst="rect">
-            <a:avLst/>
-          </a:prstGeom>
-          <a:noFill xmlns:a="http://schemas.openxmlformats.org/drawingml/2006/main"/>
-          <a:ln xmlns:a="http://schemas.openxmlformats.org/drawingml/2006/main" w="0">
-            <a:noFill/>
-          </a:ln>
-        </p:spPr>
-        <p:txBody>
-          <a:bodyPr xmlns:a="http://schemas.openxmlformats.org/drawingml/2006/main">
-            <a:noAutofit/>
-          </a:bodyPr>
-          <a:lstStyle xmlns:a="http://schemas.openxmlformats.org/drawingml/2006/main"/>
-          <a:p xmlns:a="http://schemas.openxmlformats.org/drawingml/2006/main">
-            <a:pPr algn="l">
-              <a:defRPr sz="1500" b="1">
-                <a:solidFill>
-                  <a:srgbClr val="B45C16"/>
-                </a:solidFill>
-                <a:latin typeface="Arial"/>
-                <a:ea typeface="Arial"/>
-                <a:cs typeface="Arial"/>
-              </a:defRPr>
-            </a:pPr>
-            <a:r>
-              <a:rPr sz="1500" b="1">
-                <a:solidFill>
-                  <a:srgbClr val="B45C16"/>
-                </a:solidFill>
-                <a:latin typeface="Arial"/>
-                <a:ea typeface="Arial"/>
-                <a:cs typeface="Arial"/>
-              </a:rPr>
-              <a:t>65% target</a:t>
             </a:r>
           </a:p>
         </p:txBody>
@@ -5493,6 +5599,7 @@
           <a:lstStyle xmlns:a="http://schemas.openxmlformats.org/drawingml/2006/main"/>
           <a:p xmlns:a="http://schemas.openxmlformats.org/drawingml/2006/main">
             <a:pPr algn="l">
+              <a:buNone/>
               <a:defRPr sz="1350" b="0">
                 <a:solidFill>
                   <a:srgbClr val="56666B"/>
@@ -5511,7 +5618,110 @@
                 <a:ea typeface="Arial"/>
                 <a:cs typeface="Arial"/>
               </a:rPr>
-              <a:t>Latest-month mean. Teal identifies the proposed pilot regions. Synthetic training data.</a:t>
+              <a:t>Dark teal shows proposed trial regions. Orange marks the 65% target.</a:t>
+            </a:r>
+          </a:p>
+        </p:txBody>
+      </p:sp>
+      <p:graphicFrame>
+        <p:nvGraphicFramePr>
+          <p:cNvPr id="14" name="Chart"/>
+          <p:cNvGraphicFramePr/>
+          <p:nvPr/>
+        </p:nvGraphicFramePr>
+        <p:xfrm>
+          <a:off xmlns:a="http://schemas.openxmlformats.org/drawingml/2006/main" x="609600" y="1600200"/>
+          <a:ext xmlns:a="http://schemas.openxmlformats.org/drawingml/2006/main" cx="10972800" cy="4267200"/>
+        </p:xfrm>
+        <a:graphic xmlns:a="http://schemas.openxmlformats.org/drawingml/2006/main">
+          <a:graphicData uri="http://schemas.openxmlformats.org/drawingml/2006/chart">
+            <c:chart xmlns:r="http://schemas.openxmlformats.org/officeDocument/2006/relationships" xmlns:c="http://schemas.openxmlformats.org/drawingml/2006/chart" r:id="R0a7d9a121c2147e5"/>
+          </a:graphicData>
+        </a:graphic>
+      </p:graphicFrame>
+      <p:sp>
+        <p:nvSpPr>
+          <p:cNvPr id="9" name="">
+            <a:extLst xmlns:a="http://schemas.openxmlformats.org/drawingml/2006/main">
+              <a:ext uri="{FF2B5EF4-FFF2-40B4-BE49-F238E27FC236}">
+                <a16:creationId xmlns:a16="http://schemas.microsoft.com/office/drawing/2014/main" id="{9D556D53-5D07-40F9-96F0-7848D7327CB7}"/>
+              </a:ext>
+            </a:extLst>
+          </p:cNvPr>
+          <p:cNvSpPr>
+            <a:spLocks xmlns:a="http://schemas.openxmlformats.org/drawingml/2006/main" noGrp="1"/>
+          </p:cNvSpPr>
+          <p:nvPr/>
+        </p:nvSpPr>
+        <p:spPr>
+          <a:xfrm xmlns:a="http://schemas.openxmlformats.org/drawingml/2006/main">
+            <a:off x="8036243" y="1781175"/>
+            <a:ext cx="19050" cy="3657600"/>
+          </a:xfrm>
+          <a:prstGeom xmlns:a="http://schemas.openxmlformats.org/drawingml/2006/main" prst="rect">
+            <a:avLst/>
+          </a:prstGeom>
+          <a:solidFill xmlns:a="http://schemas.openxmlformats.org/drawingml/2006/main">
+            <a:srgbClr val="B45C16"/>
+          </a:solidFill>
+          <a:ln xmlns:a="http://schemas.openxmlformats.org/drawingml/2006/main" w="0">
+            <a:noFill/>
+          </a:ln>
+        </p:spPr>
+      </p:sp>
+      <p:sp>
+        <p:nvSpPr>
+          <p:cNvPr id="10" name="">
+            <a:extLst xmlns:a="http://schemas.openxmlformats.org/drawingml/2006/main">
+              <a:ext uri="{FF2B5EF4-FFF2-40B4-BE49-F238E27FC236}">
+                <a16:creationId xmlns:a16="http://schemas.microsoft.com/office/drawing/2014/main" id="{BA3BFDCF-3DE2-4A56-B4BD-0ACC636EC3BD}"/>
+              </a:ext>
+            </a:extLst>
+          </p:cNvPr>
+          <p:cNvSpPr>
+            <a:spLocks xmlns:a="http://schemas.openxmlformats.org/drawingml/2006/main" noGrp="1"/>
+          </p:cNvSpPr>
+          <p:nvPr/>
+        </p:nvSpPr>
+        <p:spPr>
+          <a:xfrm xmlns:a="http://schemas.openxmlformats.org/drawingml/2006/main">
+            <a:off x="7877175" y="1524000"/>
+            <a:ext cx="1657350" cy="342900"/>
+          </a:xfrm>
+          <a:prstGeom xmlns:a="http://schemas.openxmlformats.org/drawingml/2006/main" prst="rect">
+            <a:avLst/>
+          </a:prstGeom>
+          <a:noFill xmlns:a="http://schemas.openxmlformats.org/drawingml/2006/main"/>
+          <a:ln xmlns:a="http://schemas.openxmlformats.org/drawingml/2006/main" w="0">
+            <a:noFill/>
+          </a:ln>
+        </p:spPr>
+        <p:txBody>
+          <a:bodyPr xmlns:a="http://schemas.openxmlformats.org/drawingml/2006/main">
+            <a:noAutofit/>
+          </a:bodyPr>
+          <a:lstStyle xmlns:a="http://schemas.openxmlformats.org/drawingml/2006/main"/>
+          <a:p xmlns:a="http://schemas.openxmlformats.org/drawingml/2006/main">
+            <a:pPr algn="l">
+              <a:defRPr sz="1500" b="1">
+                <a:solidFill>
+                  <a:srgbClr val="B45C16"/>
+                </a:solidFill>
+                <a:latin typeface="Arial"/>
+                <a:ea typeface="Arial"/>
+                <a:cs typeface="Arial"/>
+              </a:defRPr>
+            </a:pPr>
+            <a:r>
+              <a:rPr sz="1500" b="1">
+                <a:solidFill>
+                  <a:srgbClr val="B45C16"/>
+                </a:solidFill>
+                <a:latin typeface="Arial"/>
+                <a:ea typeface="Arial"/>
+                <a:cs typeface="Arial"/>
+              </a:rPr>
+              <a:t>65% target</a:t>
             </a:r>
           </a:p>
         </p:txBody>
@@ -5579,6 +5789,7 @@
           <a:lstStyle xmlns:a="http://schemas.openxmlformats.org/drawingml/2006/main"/>
           <a:p xmlns:a="http://schemas.openxmlformats.org/drawingml/2006/main">
             <a:pPr algn="l">
+              <a:buNone/>
               <a:defRPr sz="3225" b="1">
                 <a:solidFill>
                   <a:srgbClr val="15363D"/>
@@ -5597,7 +5808,7 @@
                 <a:ea typeface="Arial"/>
                 <a:cs typeface="Arial"/>
               </a:rPr>
-              <a:t>Najran leads; third place needs validation</a:t>
+              <a:t>Najran ranks first. Third place is almost a tie</a:t>
             </a:r>
           </a:p>
         </p:txBody>
@@ -5636,6 +5847,7 @@
           <a:lstStyle xmlns:a="http://schemas.openxmlformats.org/drawingml/2006/main"/>
           <a:p xmlns:a="http://schemas.openxmlformats.org/drawingml/2006/main">
             <a:pPr algn="l">
+              <a:buNone/>
               <a:defRPr sz="1275" b="0">
                 <a:solidFill>
                   <a:srgbClr val="56666B"/>
@@ -5693,6 +5905,7 @@
           <a:lstStyle xmlns:a="http://schemas.openxmlformats.org/drawingml/2006/main"/>
           <a:p xmlns:a="http://schemas.openxmlformats.org/drawingml/2006/main">
             <a:pPr algn="l">
+              <a:buNone/>
               <a:defRPr sz="1500" b="0">
                 <a:solidFill>
                   <a:srgbClr val="56666B"/>
@@ -5711,27 +5924,11 @@
                 <a:ea typeface="Arial"/>
                 <a:cs typeface="Arial"/>
               </a:rPr>
-              <a:t>December 2025 · Synthetic data · Teal: proposed pilots; orange: Al-Baha alternative</a:t>
+              <a:t>December 2025. Dark teal: trial regions. Orange: Al-Baha.</a:t>
             </a:r>
           </a:p>
         </p:txBody>
       </p:sp>
-      <p:graphicFrame>
-        <p:nvGraphicFramePr>
-          <p:cNvPr id="15" name="Chart"/>
-          <p:cNvGraphicFramePr/>
-          <p:nvPr/>
-        </p:nvGraphicFramePr>
-        <p:xfrm>
-          <a:off xmlns:a="http://schemas.openxmlformats.org/drawingml/2006/main" x="609600" y="1695450"/>
-          <a:ext xmlns:a="http://schemas.openxmlformats.org/drawingml/2006/main" cx="7286625" cy="3429000"/>
-        </p:xfrm>
-        <a:graphic xmlns:a="http://schemas.openxmlformats.org/drawingml/2006/main">
-          <a:graphicData uri="http://schemas.openxmlformats.org/drawingml/2006/chart">
-            <c:chart xmlns:r="http://schemas.openxmlformats.org/officeDocument/2006/relationships" xmlns:c="http://schemas.openxmlformats.org/drawingml/2006/chart" r:id="R7a85ec0721d84117"/>
-          </a:graphicData>
-        </a:graphic>
-      </p:graphicFrame>
       <p:sp>
         <p:nvSpPr>
           <p:cNvPr id="5" name="">
@@ -5766,6 +5963,7 @@
           <a:lstStyle xmlns:a="http://schemas.openxmlformats.org/drawingml/2006/main"/>
           <a:p xmlns:a="http://schemas.openxmlformats.org/drawingml/2006/main">
             <a:pPr algn="l">
+              <a:buNone/>
               <a:defRPr sz="4500" b="1">
                 <a:solidFill>
                   <a:srgbClr val="087D82"/>
@@ -5823,6 +6021,7 @@
           <a:lstStyle xmlns:a="http://schemas.openxmlformats.org/drawingml/2006/main"/>
           <a:p xmlns:a="http://schemas.openxmlformats.org/drawingml/2006/main">
             <a:pPr algn="l">
+              <a:buNone/>
               <a:defRPr sz="1950" b="1">
                 <a:solidFill>
                   <a:srgbClr val="15363D"/>
@@ -5841,7 +6040,9 @@
                 <a:ea typeface="Arial"/>
                 <a:cs typeface="Arial"/>
               </a:rPr>
-              <a:t>Selected regions’ share of the laggards’ priority index</a:t>
+              <a:t>Trial regions' share
+of the score for all
+9 regions below 65%</a:t>
             </a:r>
           </a:p>
         </p:txBody>
@@ -5880,6 +6081,7 @@
           <a:lstStyle xmlns:a="http://schemas.openxmlformats.org/drawingml/2006/main"/>
           <a:p xmlns:a="http://schemas.openxmlformats.org/drawingml/2006/main">
             <a:pPr algn="l">
+              <a:buNone/>
               <a:defRPr sz="1725" b="1">
                 <a:solidFill>
                   <a:srgbClr val="15363D"/>
@@ -5898,7 +6100,7 @@
                 <a:ea typeface="Arial"/>
                 <a:cs typeface="Arial"/>
               </a:rPr>
-              <a:t>Target gaps (pp)</a:t>
+              <a:t>Gap to 65% (points)</a:t>
             </a:r>
           </a:p>
         </p:txBody>
@@ -5937,6 +6139,7 @@
           <a:lstStyle xmlns:a="http://schemas.openxmlformats.org/drawingml/2006/main"/>
           <a:p xmlns:a="http://schemas.openxmlformats.org/drawingml/2006/main">
             <a:pPr algn="l">
+              <a:buNone/>
               <a:defRPr sz="1725" b="0">
                 <a:solidFill>
                   <a:srgbClr val="15363D"/>
@@ -5960,6 +6163,7 @@
           </a:p>
           <a:p xmlns:a="http://schemas.openxmlformats.org/drawingml/2006/main">
             <a:pPr algn="l">
+              <a:buNone/>
               <a:defRPr sz="1725" b="0">
                 <a:solidFill>
                   <a:srgbClr val="15363D"/>
@@ -5983,6 +6187,7 @@
           </a:p>
           <a:p xmlns:a="http://schemas.openxmlformats.org/drawingml/2006/main">
             <a:pPr algn="l">
+              <a:buNone/>
               <a:defRPr sz="1725" b="0">
                 <a:solidFill>
                   <a:srgbClr val="15363D"/>
@@ -6040,6 +6245,7 @@
           <a:lstStyle xmlns:a="http://schemas.openxmlformats.org/drawingml/2006/main"/>
           <a:p xmlns:a="http://schemas.openxmlformats.org/drawingml/2006/main">
             <a:pPr algn="l">
+              <a:buNone/>
               <a:defRPr sz="1725" b="0">
                 <a:solidFill>
                   <a:srgbClr val="56666B"/>
@@ -6058,7 +6264,7 @@
                 <a:ea typeface="Arial"/>
                 <a:cs typeface="Arial"/>
               </a:rPr>
-              <a:t>Priority proxy = positive gap / 100 × December transactions; not a conversion count</a:t>
+              <a:t>Priority score = target gap / 100 × December transactions (ranking only)</a:t>
             </a:r>
           </a:p>
         </p:txBody>
@@ -6097,6 +6303,7 @@
           <a:lstStyle xmlns:a="http://schemas.openxmlformats.org/drawingml/2006/main"/>
           <a:p xmlns:a="http://schemas.openxmlformats.org/drawingml/2006/main">
             <a:pPr algn="l">
+              <a:buNone/>
               <a:defRPr sz="2025" b="1">
                 <a:solidFill>
                   <a:srgbClr val="B45C16"/>
@@ -6115,7 +6322,7 @@
                 <a:ea typeface="Arial"/>
                 <a:cs typeface="Arial"/>
               </a:rPr>
-              <a:t>Near tie: Northern Borders 446.26 vs Al-Baha 445.60</a:t>
+              <a:t>Almost a tie: Northern Borders 446.26 and Al-Baha 445.60</a:t>
             </a:r>
           </a:p>
         </p:txBody>
@@ -6154,6 +6361,7 @@
           <a:lstStyle xmlns:a="http://schemas.openxmlformats.org/drawingml/2006/main"/>
           <a:p xmlns:a="http://schemas.openxmlformats.org/drawingml/2006/main">
             <a:pPr algn="l">
+              <a:buNone/>
               <a:defRPr sz="1350" b="0">
                 <a:solidFill>
                   <a:srgbClr val="56666B"/>
@@ -6172,11 +6380,27 @@
                 <a:ea typeface="Arial"/>
                 <a:cs typeface="Arial"/>
               </a:rPr>
-              <a:t>Metric sensitivity: transaction weighting selects Al-Baha instead of Jazan. Agree the definition before release.</a:t>
+              <a:t>Transaction weighting puts Al-Baha ahead of Jazan. Confirm the measure before funding.</a:t>
             </a:r>
           </a:p>
         </p:txBody>
       </p:sp>
+      <p:graphicFrame>
+        <p:nvGraphicFramePr>
+          <p:cNvPr id="24" name="Chart"/>
+          <p:cNvGraphicFramePr/>
+          <p:nvPr/>
+        </p:nvGraphicFramePr>
+        <p:xfrm>
+          <a:off xmlns:a="http://schemas.openxmlformats.org/drawingml/2006/main" x="609600" y="1695450"/>
+          <a:ext xmlns:a="http://schemas.openxmlformats.org/drawingml/2006/main" cx="7286625" cy="3429000"/>
+        </p:xfrm>
+        <a:graphic xmlns:a="http://schemas.openxmlformats.org/drawingml/2006/main">
+          <a:graphicData uri="http://schemas.openxmlformats.org/drawingml/2006/chart">
+            <c:chart xmlns:r="http://schemas.openxmlformats.org/officeDocument/2006/relationships" xmlns:c="http://schemas.openxmlformats.org/drawingml/2006/chart" r:id="R8a59a4b53cdd4d58"/>
+          </a:graphicData>
+        </a:graphic>
+      </p:graphicFrame>
     </p:spTree>
     <p:extLst>
       <p:ext uri="{BB962C8B-B14F-4D97-AF65-F5344CB8AC3E}">
@@ -6240,6 +6464,7 @@
           <a:lstStyle xmlns:a="http://schemas.openxmlformats.org/drawingml/2006/main"/>
           <a:p xmlns:a="http://schemas.openxmlformats.org/drawingml/2006/main">
             <a:pPr algn="l">
+              <a:buNone/>
               <a:defRPr sz="3225" b="1">
                 <a:solidFill>
                   <a:srgbClr val="15363D"/>
@@ -6258,7 +6483,7 @@
                 <a:ea typeface="Arial"/>
                 <a:cs typeface="Arial"/>
               </a:rPr>
-              <a:t>Staged funding allows adjustment after the pilot</a:t>
+              <a:t>Funding in steps lets us test before spending more</a:t>
             </a:r>
           </a:p>
         </p:txBody>
@@ -6297,6 +6522,7 @@
           <a:lstStyle xmlns:a="http://schemas.openxmlformats.org/drawingml/2006/main"/>
           <a:p xmlns:a="http://schemas.openxmlformats.org/drawingml/2006/main">
             <a:pPr algn="l">
+              <a:buNone/>
               <a:defRPr sz="1275" b="0">
                 <a:solidFill>
                   <a:srgbClr val="56666B"/>
@@ -6322,7 +6548,7 @@
       </p:sp>
       <p:graphicFrame>
         <p:nvGraphicFramePr>
-          <p:cNvPr id="8" name=""/>
+          <p:cNvPr id="10" name=""/>
           <p:cNvGraphicFramePr/>
           <p:nvPr/>
         </p:nvGraphicFramePr>
@@ -6379,7 +6605,7 @@
                           <a:ea typeface="Arial"/>
                           <a:cs typeface="Arial"/>
                         </a:rPr>
-                        <a:t>SAR 40M allocation</a:t>
+                        <a:t>Use of SAR 40M</a:t>
                       </a:r>
                     </a:p>
                   </a:txBody>
@@ -6403,7 +6629,7 @@
                           <a:ea typeface="Arial"/>
                           <a:cs typeface="Arial"/>
                         </a:rPr>
-                        <a:t>Benefit</a:t>
+                        <a:t>Main benefit</a:t>
                       </a:r>
                     </a:p>
                   </a:txBody>
@@ -6427,7 +6653,7 @@
                           <a:ea typeface="Arial"/>
                           <a:cs typeface="Arial"/>
                         </a:rPr>
-                        <a:t>Tradeoff</a:t>
+                        <a:t>Main risk</a:t>
                       </a:r>
                     </a:p>
                   </a:txBody>
@@ -6444,7 +6670,9 @@
                     <a:bodyPr/>
                     <a:lstStyle/>
                     <a:p>
-                      <a:pPr algn="l"/>
+                      <a:pPr algn="l">
+                        <a:buNone/>
+                      </a:pPr>
                       <a:r>
                         <a:rPr sz="1800">
                           <a:solidFill>
@@ -6454,7 +6682,7 @@
                           <a:ea typeface="Arial"/>
                           <a:cs typeface="Arial"/>
                         </a:rPr>
-                        <a:t>Equal allocation</a:t>
+                        <a:t>Equal funding</a:t>
                       </a:r>
                     </a:p>
                   </a:txBody>
@@ -6469,7 +6697,9 @@
                     <a:bodyPr/>
                     <a:lstStyle/>
                     <a:p>
-                      <a:pPr algn="l"/>
+                      <a:pPr algn="l">
+                        <a:buNone/>
+                      </a:pPr>
                       <a:r>
                         <a:rPr sz="1800">
                           <a:solidFill>
@@ -6479,7 +6709,7 @@
                           <a:ea typeface="Arial"/>
                           <a:cs typeface="Arial"/>
                         </a:rPr>
-                        <a:t>SAR 40M ÷ 9 (about 4.44M each)</a:t>
+                        <a:t>About SAR 4.44M for each of the 9 regions</a:t>
                       </a:r>
                     </a:p>
                   </a:txBody>
@@ -6494,7 +6724,9 @@
                     <a:bodyPr/>
                     <a:lstStyle/>
                     <a:p>
-                      <a:pPr algn="l"/>
+                      <a:pPr algn="l">
+                        <a:buNone/>
+                      </a:pPr>
                       <a:r>
                         <a:rPr sz="1800">
                           <a:solidFill>
@@ -6504,7 +6736,7 @@
                           <a:ea typeface="Arial"/>
                           <a:cs typeface="Arial"/>
                         </a:rPr>
-                        <a:t>Covers all nine laggards</a:t>
+                        <a:t>Covers all 9 regions below target</a:t>
                       </a:r>
                     </a:p>
                   </a:txBody>
@@ -6519,7 +6751,9 @@
                     <a:bodyPr/>
                     <a:lstStyle/>
                     <a:p>
-                      <a:pPr algn="l"/>
+                      <a:pPr algn="l">
+                        <a:buNone/>
+                      </a:pPr>
                       <a:r>
                         <a:rPr sz="1800">
                           <a:solidFill>
@@ -6529,7 +6763,7 @@
                           <a:ea typeface="Arial"/>
                           <a:cs typeface="Arial"/>
                         </a:rPr>
-                        <a:t>Ignores differences in gap and activity</a:t>
+                        <a:t>Ignores different gaps and transaction volumes</a:t>
                       </a:r>
                     </a:p>
                   </a:txBody>
@@ -6546,7 +6780,9 @@
                     <a:bodyPr/>
                     <a:lstStyle/>
                     <a:p>
-                      <a:pPr algn="l"/>
+                      <a:pPr algn="l">
+                        <a:buNone/>
+                      </a:pPr>
                       <a:r>
                         <a:rPr sz="1800">
                           <a:solidFill>
@@ -6556,7 +6792,7 @@
                           <a:ea typeface="Arial"/>
                           <a:cs typeface="Arial"/>
                         </a:rPr>
-                        <a:t>Full concentration</a:t>
+                        <a:t>All funding now</a:t>
                       </a:r>
                     </a:p>
                   </a:txBody>
@@ -6571,7 +6807,9 @@
                     <a:bodyPr/>
                     <a:lstStyle/>
                     <a:p>
-                      <a:pPr algn="l"/>
+                      <a:pPr algn="l">
+                        <a:buNone/>
+                      </a:pPr>
                       <a:r>
                         <a:rPr sz="1800">
                           <a:solidFill>
@@ -6581,7 +6819,7 @@
                           <a:ea typeface="Arial"/>
                           <a:cs typeface="Arial"/>
                         </a:rPr>
-                        <a:t>SAR 40M in three regions</a:t>
+                        <a:t>SAR 40M in the 3 trial regions</a:t>
                       </a:r>
                     </a:p>
                   </a:txBody>
@@ -6596,7 +6834,9 @@
                     <a:bodyPr/>
                     <a:lstStyle/>
                     <a:p>
-                      <a:pPr algn="l"/>
+                      <a:pPr algn="l">
+                        <a:buNone/>
+                      </a:pPr>
                       <a:r>
                         <a:rPr sz="1800">
                           <a:solidFill>
@@ -6621,7 +6861,9 @@
                     <a:bodyPr/>
                     <a:lstStyle/>
                     <a:p>
-                      <a:pPr algn="l"/>
+                      <a:pPr algn="l">
+                        <a:buNone/>
+                      </a:pPr>
                       <a:r>
                         <a:rPr sz="1800">
                           <a:solidFill>
@@ -6631,7 +6873,7 @@
                           <a:ea typeface="Arial"/>
                           <a:cs typeface="Arial"/>
                         </a:rPr>
-                        <a:t>Commits all funding before testing</a:t>
+                        <a:t>Spends all funding before testing</a:t>
                       </a:r>
                     </a:p>
                   </a:txBody>
@@ -6648,7 +6890,9 @@
                     <a:bodyPr/>
                     <a:lstStyle/>
                     <a:p>
-                      <a:pPr algn="l"/>
+                      <a:pPr algn="l">
+                        <a:buNone/>
+                      </a:pPr>
                       <a:r>
                         <a:rPr sz="1800">
                           <a:solidFill>
@@ -6658,7 +6902,7 @@
                           <a:ea typeface="Arial"/>
                           <a:cs typeface="Arial"/>
                         </a:rPr>
-                        <a:t>Staged funding</a:t>
+                        <a:t>Funding in steps</a:t>
                       </a:r>
                     </a:p>
                   </a:txBody>
@@ -6673,7 +6917,9 @@
                     <a:bodyPr/>
                     <a:lstStyle/>
                     <a:p>
-                      <a:pPr algn="l"/>
+                      <a:pPr algn="l">
+                        <a:buNone/>
+                      </a:pPr>
                       <a:r>
                         <a:rPr sz="1800">
                           <a:solidFill>
@@ -6683,7 +6929,7 @@
                           <a:ea typeface="Arial"/>
                           <a:cs typeface="Arial"/>
                         </a:rPr>
-                        <a:t>SAR 35M regional + SAR 5M reserve</a:t>
+                        <a:t>SAR 35M for regions and SAR 5M for review</a:t>
                       </a:r>
                     </a:p>
                   </a:txBody>
@@ -6698,7 +6944,9 @@
                     <a:bodyPr/>
                     <a:lstStyle/>
                     <a:p>
-                      <a:pPr algn="l"/>
+                      <a:pPr algn="l">
+                        <a:buNone/>
+                      </a:pPr>
                       <a:r>
                         <a:rPr sz="1800">
                           <a:solidFill>
@@ -6708,7 +6956,7 @@
                           <a:ea typeface="Arial"/>
                           <a:cs typeface="Arial"/>
                         </a:rPr>
-                        <a:t>Focus with a review before scaling</a:t>
+                        <a:t>Tests before full budget release</a:t>
                       </a:r>
                     </a:p>
                   </a:txBody>
@@ -6723,7 +6971,9 @@
                     <a:bodyPr/>
                     <a:lstStyle/>
                     <a:p>
-                      <a:pPr algn="l"/>
+                      <a:pPr algn="l">
+                        <a:buNone/>
+                      </a:pPr>
                       <a:r>
                         <a:rPr sz="1800">
                           <a:solidFill>
@@ -6733,7 +6983,7 @@
                           <a:ea typeface="Arial"/>
                           <a:cs typeface="Arial"/>
                         </a:rPr>
-                        <a:t>Requires agreed metrics and evaluation</a:t>
+                        <a:t>Needs agreed measures and review</a:t>
                       </a:r>
                     </a:p>
                   </a:txBody>
@@ -6782,6 +7032,7 @@
           <a:lstStyle xmlns:a="http://schemas.openxmlformats.org/drawingml/2006/main"/>
           <a:p xmlns:a="http://schemas.openxmlformats.org/drawingml/2006/main">
             <a:pPr algn="l">
+              <a:buNone/>
               <a:defRPr sz="2100" b="1">
                 <a:solidFill>
                   <a:srgbClr val="087D82"/>
@@ -6800,7 +7051,7 @@
                 <a:ea typeface="Arial"/>
                 <a:cs typeface="Arial"/>
               </a:rPr>
-              <a:t>Selected: SAR 10M after baseline approval; hold SAR 30M for review</a:t>
+              <a:t>First SAR 10M after trial plan approval. Hold SAR 30M.</a:t>
             </a:r>
           </a:p>
         </p:txBody>
@@ -6839,6 +7090,7 @@
           <a:lstStyle xmlns:a="http://schemas.openxmlformats.org/drawingml/2006/main"/>
           <a:p xmlns:a="http://schemas.openxmlformats.org/drawingml/2006/main">
             <a:pPr algn="l">
+              <a:buNone/>
               <a:defRPr sz="1350" b="0">
                 <a:solidFill>
                   <a:srgbClr val="56666B"/>
@@ -6857,7 +7109,7 @@
                 <a:ea typeface="Arial"/>
                 <a:cs typeface="Arial"/>
               </a:rPr>
-              <a:t>These are allocation policies. The data do not estimate causal returns for each option.</a:t>
+              <a:t>The data cannot show which option gives the highest return.</a:t>
             </a:r>
           </a:p>
         </p:txBody>
@@ -6925,6 +7177,7 @@
           <a:lstStyle xmlns:a="http://schemas.openxmlformats.org/drawingml/2006/main"/>
           <a:p xmlns:a="http://schemas.openxmlformats.org/drawingml/2006/main">
             <a:pPr algn="l">
+              <a:buNone/>
               <a:defRPr sz="3225" b="1">
                 <a:solidFill>
                   <a:srgbClr val="15363D"/>
@@ -6943,7 +7196,7 @@
                 <a:ea typeface="Arial"/>
                 <a:cs typeface="Arial"/>
               </a:rPr>
-              <a:t>SAR 35M targets the regions; SAR 5M supports reassessment</a:t>
+              <a:t>SAR 35M for regions and SAR 5M for review</a:t>
             </a:r>
           </a:p>
         </p:txBody>
@@ -6982,6 +7235,7 @@
           <a:lstStyle xmlns:a="http://schemas.openxmlformats.org/drawingml/2006/main"/>
           <a:p xmlns:a="http://schemas.openxmlformats.org/drawingml/2006/main">
             <a:pPr algn="l">
+              <a:buNone/>
               <a:defRPr sz="1275" b="0">
                 <a:solidFill>
                   <a:srgbClr val="56666B"/>
@@ -7007,7 +7261,7 @@
       </p:sp>
       <p:graphicFrame>
         <p:nvGraphicFramePr>
-          <p:cNvPr id="10" name=""/>
+          <p:cNvPr id="12" name=""/>
           <p:cNvGraphicFramePr/>
           <p:nvPr/>
         </p:nvGraphicFramePr>
@@ -7038,7 +7292,7 @@
                           <a:ea typeface="Arial"/>
                           <a:cs typeface="Arial"/>
                         </a:rPr>
-                        <a:t>Allocation</a:t>
+                        <a:t>Budget area</a:t>
                       </a:r>
                     </a:p>
                   </a:txBody>
@@ -7079,7 +7333,9 @@
                     <a:bodyPr/>
                     <a:lstStyle/>
                     <a:p>
-                      <a:pPr algn="l"/>
+                      <a:pPr algn="l">
+                        <a:buNone/>
+                      </a:pPr>
                       <a:r>
                         <a:rPr sz="1800">
                           <a:solidFill>
@@ -7104,7 +7360,9 @@
                     <a:bodyPr/>
                     <a:lstStyle/>
                     <a:p>
-                      <a:pPr algn="l"/>
+                      <a:pPr algn="l">
+                        <a:buNone/>
+                      </a:pPr>
                       <a:r>
                         <a:rPr sz="1800">
                           <a:solidFill>
@@ -7131,7 +7389,9 @@
                     <a:bodyPr/>
                     <a:lstStyle/>
                     <a:p>
-                      <a:pPr algn="l"/>
+                      <a:pPr algn="l">
+                        <a:buNone/>
+                      </a:pPr>
                       <a:r>
                         <a:rPr sz="1800">
                           <a:solidFill>
@@ -7156,7 +7416,9 @@
                     <a:bodyPr/>
                     <a:lstStyle/>
                     <a:p>
-                      <a:pPr algn="l"/>
+                      <a:pPr algn="l">
+                        <a:buNone/>
+                      </a:pPr>
                       <a:r>
                         <a:rPr sz="1800">
                           <a:solidFill>
@@ -7183,7 +7445,9 @@
                     <a:bodyPr/>
                     <a:lstStyle/>
                     <a:p>
-                      <a:pPr algn="l"/>
+                      <a:pPr algn="l">
+                        <a:buNone/>
+                      </a:pPr>
                       <a:r>
                         <a:rPr sz="1800">
                           <a:solidFill>
@@ -7208,7 +7472,9 @@
                     <a:bodyPr/>
                     <a:lstStyle/>
                     <a:p>
-                      <a:pPr algn="l"/>
+                      <a:pPr algn="l">
+                        <a:buNone/>
+                      </a:pPr>
                       <a:r>
                         <a:rPr sz="1800">
                           <a:solidFill>
@@ -7235,7 +7501,9 @@
                     <a:bodyPr/>
                     <a:lstStyle/>
                     <a:p>
-                      <a:pPr algn="l"/>
+                      <a:pPr algn="l">
+                        <a:buNone/>
+                      </a:pPr>
                       <a:r>
                         <a:rPr sz="1800">
                           <a:solidFill>
@@ -7245,7 +7513,7 @@
                           <a:ea typeface="Arial"/>
                           <a:cs typeface="Arial"/>
                         </a:rPr>
-                        <a:t>Evaluation reserve</a:t>
+                        <a:t>Review and reserve</a:t>
                       </a:r>
                     </a:p>
                   </a:txBody>
@@ -7260,7 +7528,9 @@
                     <a:bodyPr/>
                     <a:lstStyle/>
                     <a:p>
-                      <a:pPr algn="l"/>
+                      <a:pPr algn="l">
+                        <a:buNone/>
+                      </a:pPr>
                       <a:r>
                         <a:rPr sz="1800">
                           <a:solidFill>
@@ -7287,7 +7557,9 @@
                     <a:bodyPr/>
                     <a:lstStyle/>
                     <a:p>
-                      <a:pPr algn="l"/>
+                      <a:pPr algn="l">
+                        <a:buNone/>
+                      </a:pPr>
                       <a:r>
                         <a:rPr sz="1800">
                           <a:solidFill>
@@ -7312,7 +7584,9 @@
                     <a:bodyPr/>
                     <a:lstStyle/>
                     <a:p>
-                      <a:pPr algn="l"/>
+                      <a:pPr algn="l">
+                        <a:buNone/>
+                      </a:pPr>
                       <a:r>
                         <a:rPr sz="1800">
                           <a:solidFill>
@@ -7371,6 +7645,7 @@
           <a:lstStyle xmlns:a="http://schemas.openxmlformats.org/drawingml/2006/main"/>
           <a:p xmlns:a="http://schemas.openxmlformats.org/drawingml/2006/main">
             <a:pPr algn="l">
+              <a:buNone/>
               <a:defRPr sz="5025" b="1">
                 <a:solidFill>
                   <a:srgbClr val="087D82"/>
@@ -7428,6 +7703,7 @@
           <a:lstStyle xmlns:a="http://schemas.openxmlformats.org/drawingml/2006/main"/>
           <a:p xmlns:a="http://schemas.openxmlformats.org/drawingml/2006/main">
             <a:pPr algn="l">
+              <a:buNone/>
               <a:defRPr sz="2250" b="1">
                 <a:solidFill>
                   <a:srgbClr val="15363D"/>
@@ -7446,7 +7722,7 @@
                 <a:ea typeface="Arial"/>
                 <a:cs typeface="Arial"/>
               </a:rPr>
-              <a:t>National index if all three reach 65% and every other region stays unchanged</a:t>
+              <a:t>National average if the 3 regions reach 65% and the other regions stay unchanged</a:t>
             </a:r>
           </a:p>
         </p:txBody>
@@ -7485,6 +7761,7 @@
           <a:lstStyle xmlns:a="http://schemas.openxmlformats.org/drawingml/2006/main"/>
           <a:p xmlns:a="http://schemas.openxmlformats.org/drawingml/2006/main">
             <a:pPr algn="l">
+              <a:buNone/>
               <a:defRPr sz="1950" b="0">
                 <a:solidFill>
                   <a:srgbClr val="B45C16"/>
@@ -7503,7 +7780,8 @@
                 <a:ea typeface="Arial"/>
                 <a:cs typeface="Arial"/>
               </a:rPr>
-              <a:t>Conditional arithmetic, not an investment forecast</a:t>
+              <a:t>An example only.
+The budget effect is unknown.</a:t>
             </a:r>
           </a:p>
         </p:txBody>
@@ -7542,6 +7820,7 @@
           <a:lstStyle xmlns:a="http://schemas.openxmlformats.org/drawingml/2006/main"/>
           <a:p xmlns:a="http://schemas.openxmlformats.org/drawingml/2006/main">
             <a:pPr algn="l">
+              <a:buNone/>
               <a:defRPr sz="1350" b="0">
                 <a:solidFill>
                   <a:srgbClr val="56666B"/>
@@ -7560,7 +7839,7 @@
                 <a:ea typeface="Arial"/>
                 <a:cs typeface="Arial"/>
               </a:rPr>
-              <a:t>Proposed envelopes, not cost estimates. Closing these three gaps alone does not meet the national target.</a:t>
+              <a:t>Budget amounts need local cost checks. This example still falls below 65%.</a:t>
             </a:r>
           </a:p>
         </p:txBody>
@@ -7628,6 +7907,7 @@
           <a:lstStyle xmlns:a="http://schemas.openxmlformats.org/drawingml/2006/main"/>
           <a:p xmlns:a="http://schemas.openxmlformats.org/drawingml/2006/main">
             <a:pPr algn="l">
+              <a:buNone/>
               <a:defRPr sz="3225" b="1">
                 <a:solidFill>
                   <a:srgbClr val="15363D"/>
@@ -7646,7 +7926,7 @@
                 <a:ea typeface="Arial"/>
                 <a:cs typeface="Arial"/>
               </a:rPr>
-              <a:t>Approve SAR 40M; review pilots at day 90</a:t>
+              <a:t>The 40M proposal starts with 10M in trials</a:t>
             </a:r>
           </a:p>
         </p:txBody>
@@ -7685,6 +7965,7 @@
           <a:lstStyle xmlns:a="http://schemas.openxmlformats.org/drawingml/2006/main"/>
           <a:p xmlns:a="http://schemas.openxmlformats.org/drawingml/2006/main">
             <a:pPr algn="l">
+              <a:buNone/>
               <a:defRPr sz="1275" b="0">
                 <a:solidFill>
                   <a:srgbClr val="56666B"/>
@@ -7742,6 +8023,7 @@
           <a:lstStyle xmlns:a="http://schemas.openxmlformats.org/drawingml/2006/main"/>
           <a:p xmlns:a="http://schemas.openxmlformats.org/drawingml/2006/main">
             <a:pPr algn="l">
+              <a:buNone/>
               <a:defRPr sz="2925" b="1">
                 <a:solidFill>
                   <a:srgbClr val="087D82"/>
@@ -7760,14 +8042,14 @@
                 <a:ea typeface="Arial"/>
                 <a:cs typeface="Arial"/>
               </a:rPr>
-              <a:t>Approve SAR 40M; pilot SAR 10M after baseline approval</a:t>
+              <a:t>First 10M after trial plan approval. Hold 30M.</a:t>
             </a:r>
           </a:p>
         </p:txBody>
       </p:sp>
       <p:graphicFrame>
         <p:nvGraphicFramePr>
-          <p:cNvPr id="10" name=""/>
+          <p:cNvPr id="12" name=""/>
           <p:cNvGraphicFramePr/>
           <p:nvPr/>
         </p:nvGraphicFramePr>
@@ -7798,7 +8080,7 @@
                           <a:ea typeface="Arial"/>
                           <a:cs typeface="Arial"/>
                         </a:rPr>
-                        <a:t>After approval</a:t>
+                        <a:t>After budget approval</a:t>
                       </a:r>
                     </a:p>
                   </a:txBody>
@@ -7822,7 +8104,7 @@
                           <a:ea typeface="Arial"/>
                           <a:cs typeface="Arial"/>
                         </a:rPr>
-                        <a:t>Action and decision</a:t>
+                        <a:t>Next step</a:t>
                       </a:r>
                     </a:p>
                   </a:txBody>
@@ -7839,7 +8121,9 @@
                     <a:bodyPr/>
                     <a:lstStyle/>
                     <a:p>
-                      <a:pPr algn="l"/>
+                      <a:pPr algn="l">
+                        <a:buNone/>
+                      </a:pPr>
                       <a:r>
                         <a:rPr sz="1800">
                           <a:solidFill>
@@ -7864,7 +8148,9 @@
                     <a:bodyPr/>
                     <a:lstStyle/>
                     <a:p>
-                      <a:pPr algn="l"/>
+                      <a:pPr algn="l">
+                        <a:buNone/>
+                      </a:pPr>
                       <a:r>
                         <a:rPr sz="1800">
                           <a:solidFill>
@@ -7874,7 +8160,7 @@
                           <a:ea typeface="Arial"/>
                           <a:cs typeface="Arial"/>
                         </a:rPr>
-                        <a:t>Approve the envelope and name an accountable owner</a:t>
+                        <a:t>Approve the 40M budget and choose a lead</a:t>
                       </a:r>
                     </a:p>
                   </a:txBody>
@@ -7891,7 +8177,9 @@
                     <a:bodyPr/>
                     <a:lstStyle/>
                     <a:p>
-                      <a:pPr algn="l"/>
+                      <a:pPr algn="l">
+                        <a:buNone/>
+                      </a:pPr>
                       <a:r>
                         <a:rPr sz="1800">
                           <a:solidFill>
@@ -7916,7 +8204,9 @@
                     <a:bodyPr/>
                     <a:lstStyle/>
                     <a:p>
-                      <a:pPr algn="l"/>
+                      <a:pPr algn="l">
+                        <a:buNone/>
+                      </a:pPr>
                       <a:r>
                         <a:rPr sz="1800">
                           <a:solidFill>
@@ -7926,7 +8216,7 @@
                           <a:ea typeface="Arial"/>
                           <a:cs typeface="Arial"/>
                         </a:rPr>
-                        <a:t>Approve metric, baseline, comparison and cost; then launch pilots</a:t>
+                        <a:t>Approve the trial plan. Start when ready.</a:t>
                       </a:r>
                     </a:p>
                   </a:txBody>
@@ -7943,7 +8233,9 @@
                     <a:bodyPr/>
                     <a:lstStyle/>
                     <a:p>
-                      <a:pPr algn="l"/>
+                      <a:pPr algn="l">
+                        <a:buNone/>
+                      </a:pPr>
                       <a:r>
                         <a:rPr sz="1800">
                           <a:solidFill>
@@ -7968,7 +8260,9 @@
                     <a:bodyPr/>
                     <a:lstStyle/>
                     <a:p>
-                      <a:pPr algn="l"/>
+                      <a:pPr algn="l">
+                        <a:buNone/>
+                      </a:pPr>
                       <a:r>
                         <a:rPr sz="1800">
                           <a:solidFill>
@@ -7978,7 +8272,7 @@
                           <a:ea typeface="Arial"/>
                           <a:cs typeface="Arial"/>
                         </a:rPr>
-                        <a:t>Review impact and cost before releasing further funding</a:t>
+                        <a:t>Review results and costs before any later release</a:t>
                       </a:r>
                     </a:p>
                   </a:txBody>
@@ -8027,6 +8321,7 @@
           <a:lstStyle xmlns:a="http://schemas.openxmlformats.org/drawingml/2006/main"/>
           <a:p xmlns:a="http://schemas.openxmlformats.org/drawingml/2006/main">
             <a:pPr algn="l">
+              <a:buNone/>
               <a:defRPr sz="2100" b="1">
                 <a:solidFill>
                   <a:srgbClr val="15363D"/>
@@ -8045,7 +8340,7 @@
                 <a:ea typeface="Arial"/>
                 <a:cs typeface="Arial"/>
               </a:rPr>
-              <a:t>Proposed continuation goal: +2pp with stable satisfaction and service performance</a:t>
+              <a:t>Trial goal: +2 percentage points and steady service quality</a:t>
             </a:r>
           </a:p>
         </p:txBody>
@@ -8084,6 +8379,7 @@
           <a:lstStyle xmlns:a="http://schemas.openxmlformats.org/drawingml/2006/main"/>
           <a:p xmlns:a="http://schemas.openxmlformats.org/drawingml/2006/main">
             <a:pPr algn="l">
+              <a:buNone/>
               <a:defRPr sz="1350" b="0">
                 <a:solidFill>
                   <a:srgbClr val="56666B"/>
@@ -8102,7 +8398,7 @@
                 <a:ea typeface="Arial"/>
                 <a:cs typeface="Arial"/>
               </a:rPr>
-              <a:t>A management goal, not a prediction. Check comparison groups and service mix before attributing improvement.</a:t>
+              <a:t>Goal only. Day 90 starts at budget approval. Extend the review if needed.</a:t>
             </a:r>
           </a:p>
         </p:txBody>

</xml_diff>

<commit_message>
Translate presenter notes into Arabic and preserve English slides
</commit_message>
<xml_diff>
--- a/deliverables/Tayseer_Executive_Story_Final.pptx
+++ b/deliverables/Tayseer_Executive_Story_Final.pptx
@@ -2,19 +2,19 @@
 <file path=ppt/presentation.xml><?xml version="1.0" encoding="utf-8"?>
 <p:presentation xmlns:p="http://schemas.openxmlformats.org/presentationml/2006/main">
   <p:sldMasterIdLst>
-    <p:sldMasterId xmlns:r="http://schemas.openxmlformats.org/officeDocument/2006/relationships" id="2147483648" r:id="Rcfcfe6300f8645fa"/>
+    <p:sldMasterId xmlns:r="http://schemas.openxmlformats.org/officeDocument/2006/relationships" id="2147483648" r:id="Rc6559b8bf6714290"/>
   </p:sldMasterIdLst>
   <p:notesMasterIdLst>
-    <p:notesMasterId xmlns:r="http://schemas.openxmlformats.org/officeDocument/2006/relationships" r:id="Rddbd0501d71d4b72"/>
+    <p:notesMasterId xmlns:r="http://schemas.openxmlformats.org/officeDocument/2006/relationships" r:id="R05fd968ea72e4c42"/>
   </p:notesMasterIdLst>
   <p:sldIdLst>
-    <p:sldId xmlns:r="http://schemas.openxmlformats.org/officeDocument/2006/relationships" id="256" r:id="Rad8f7e020653436e"/>
-    <p:sldId xmlns:r="http://schemas.openxmlformats.org/officeDocument/2006/relationships" id="257" r:id="R7be30f1de9f34d0b"/>
-    <p:sldId xmlns:r="http://schemas.openxmlformats.org/officeDocument/2006/relationships" id="258" r:id="R9413290337294d12"/>
-    <p:sldId xmlns:r="http://schemas.openxmlformats.org/officeDocument/2006/relationships" id="259" r:id="Rc43debd6ce5e45e8"/>
-    <p:sldId xmlns:r="http://schemas.openxmlformats.org/officeDocument/2006/relationships" id="260" r:id="Rdce23e26ca6d4c56"/>
-    <p:sldId xmlns:r="http://schemas.openxmlformats.org/officeDocument/2006/relationships" id="261" r:id="Re2d64cec87794f65"/>
-    <p:sldId xmlns:r="http://schemas.openxmlformats.org/officeDocument/2006/relationships" id="262" r:id="Rb817c53ee05b48d7"/>
+    <p:sldId xmlns:r="http://schemas.openxmlformats.org/officeDocument/2006/relationships" id="256" r:id="R0d4a19c1d09e4a8d"/>
+    <p:sldId xmlns:r="http://schemas.openxmlformats.org/officeDocument/2006/relationships" id="257" r:id="Rc061c8539ef94aea"/>
+    <p:sldId xmlns:r="http://schemas.openxmlformats.org/officeDocument/2006/relationships" id="258" r:id="Rf824cac35a9b40fb"/>
+    <p:sldId xmlns:r="http://schemas.openxmlformats.org/officeDocument/2006/relationships" id="259" r:id="R4610b5d925ba414e"/>
+    <p:sldId xmlns:r="http://schemas.openxmlformats.org/officeDocument/2006/relationships" id="260" r:id="Rd9a19c916fbc498c"/>
+    <p:sldId xmlns:r="http://schemas.openxmlformats.org/officeDocument/2006/relationships" id="261" r:id="R23bee0df897240a2"/>
+    <p:sldId xmlns:r="http://schemas.openxmlformats.org/officeDocument/2006/relationships" id="262" r:id="Rf98a8dab33924865"/>
   </p:sldIdLst>
   <p:sldSz cx="12192000" cy="6858000"/>
   <p:notesSz cx="6858000" cy="9144000"/>
@@ -448,7 +448,7 @@
           <a:lstStyle xmlns:a="http://schemas.openxmlformats.org/drawingml/2006/main"/>
           <a:p xmlns:a="http://schemas.openxmlformats.org/drawingml/2006/main">
             <a:r>
-              <a:t>REQUIRED QUESTION: Which regions should get priority, and what decision do we ask for?</a:t>
+              <a:t>السؤال المطلوب: ما المناطق ذات الأولوية؟ وما القرار الذي نطلبه؟</a:t>
             </a:r>
           </a:p>
           <a:p xmlns:a="http://schemas.openxmlformats.org/drawingml/2006/main">
@@ -458,7 +458,12 @@
           </a:p>
           <a:p xmlns:a="http://schemas.openxmlformats.org/drawingml/2006/main">
             <a:r>
-              <a:t>SAY: Please approve SAR 40 million for a plan focused on Najran, Jazan and Northern Borders. Release the first SAR 10 million only after we approve the trial plan. Hold SAR 30 million for review. We want to improve adoption where the gap and transaction activity are large, test the results, then expand. The data are synthetic training data.</a:t>
+              <a:t>قل أثناء العرض:</a:t>
+            </a:r>
+          </a:p>
+          <a:p xmlns:a="http://schemas.openxmlformats.org/drawingml/2006/main">
+            <a:r>
+              <a:t>نطلب اعتماد 40 مليون ريال لخطة تركز على نجران وجازان والحدود الشمالية، بهدف رفع التبني الرقمي نحو 65%. نصرف أول 10 ملايين بعد اعتماد خطة التجربة، ونحتفظ بـ30 مليون للمراجعة. نركز على المناطق ذات الفجوة والنشاط المرتفعين، ونختبر النتائج قبل التوسع. البيانات تدريبية اصطناعية.</a:t>
             </a:r>
           </a:p>
           <a:p xmlns:a="http://schemas.openxmlformats.org/drawingml/2006/main">
@@ -468,7 +473,12 @@
           </a:p>
           <a:p xmlns:a="http://schemas.openxmlformats.org/drawingml/2006/main">
             <a:r>
-              <a:t>KEY POINT: Say the full request in the first 30 seconds. Trial plan approval includes the measure, starting data, a fair comparison, service plans and costs. Funding has conditions. The amounts are proposed budgets and need local cost checks.</a:t>
+              <a:t>عند السؤال:</a:t>
+            </a:r>
+          </a:p>
+          <a:p xmlns:a="http://schemas.openxmlformats.org/drawingml/2006/main">
+            <a:r>
+              <a:t>اعتماد خطة التجربة يعني الاتفاق على مقياس التبني، وبيانات البداية، ومقارنة عادلة، والتحقق من اختيار المناطق، وخطط الخدمات وتكاليفها. المبالغ مقترحة وتحتاج تحققًا من التكاليف المحلية.</a:t>
             </a:r>
           </a:p>
           <a:p xmlns:a="http://schemas.openxmlformats.org/drawingml/2006/main">
@@ -478,27 +488,37 @@
           </a:p>
           <a:p xmlns:a="http://schemas.openxmlformats.org/drawingml/2006/main">
             <a:r>
-              <a:t>SOURCES</a:t>
-            </a:r>
-          </a:p>
-          <a:p xmlns:a="http://schemas.openxmlformats.org/drawingml/2006/main">
-            <a:r>
-              <a:t>Course CSV: https://drive.google.com/file/d/1T6pweFV4EjBxZ75gge775OOYMYx2aKX0/view</a:t>
-            </a:r>
-          </a:p>
-          <a:p xmlns:a="http://schemas.openxmlformats.org/drawingml/2006/main">
-            <a:r>
-              <a:t>Data definitions: https://drive.google.com/file/d/1htqVTYconACXDD28CACXOpz8VAyz8Xm5/view</a:t>
-            </a:r>
-          </a:p>
-          <a:p xmlns:a="http://schemas.openxmlformats.org/drawingml/2006/main">
-            <a:r>
-              <a:t>Course calculation reference: https://drive.google.com/file/d/1_DAzbKnnIl4dn1JN2hffwhCueJOoqPOh/view</a:t>
-            </a:r>
-          </a:p>
-          <a:p xmlns:a="http://schemas.openxmlformats.org/drawingml/2006/main">
-            <a:r>
-              <a:t>All data are synthetic.</a:t>
+              <a:t>تذكير: اذكر الطلب كاملًا خلال أول 30 ثانية.</a:t>
+            </a:r>
+          </a:p>
+          <a:p xmlns:a="http://schemas.openxmlformats.org/drawingml/2006/main">
+            <a:r>
+              <a:t/>
+            </a:r>
+          </a:p>
+          <a:p xmlns:a="http://schemas.openxmlformats.org/drawingml/2006/main">
+            <a:r>
+              <a:t>المصادر:</a:t>
+            </a:r>
+          </a:p>
+          <a:p xmlns:a="http://schemas.openxmlformats.org/drawingml/2006/main">
+            <a:r>
+              <a:t>بيانات الدورة: https://drive.google.com/file/d/1T6pweFV4EjBxZ75gge775OOYMYx2aKX0/view</a:t>
+            </a:r>
+          </a:p>
+          <a:p xmlns:a="http://schemas.openxmlformats.org/drawingml/2006/main">
+            <a:r>
+              <a:t>تعريفات البيانات: https://drive.google.com/file/d/1htqVTYconACXDD28CACXOpz8VAyz8Xm5/view</a:t>
+            </a:r>
+          </a:p>
+          <a:p xmlns:a="http://schemas.openxmlformats.org/drawingml/2006/main">
+            <a:r>
+              <a:t>مرجع حسابات الدورة: https://drive.google.com/file/d/1_DAzbKnnIl4dn1JN2hffwhCueJOoqPOh/view</a:t>
+            </a:r>
+          </a:p>
+          <a:p xmlns:a="http://schemas.openxmlformats.org/drawingml/2006/main">
+            <a:r>
+              <a:t>جميع البيانات تدريبية اصطناعية.</a:t>
             </a:r>
           </a:p>
         </p:txBody>
@@ -568,7 +588,7 @@
           <a:lstStyle xmlns:a="http://schemas.openxmlformats.org/drawingml/2006/main"/>
           <a:p xmlns:a="http://schemas.openxmlformats.org/drawingml/2006/main">
             <a:r>
-              <a:t>REQUIRED QUESTION: Is Tayseer on track toward 65% nationally? What is the current result and trend?</a:t>
+              <a:t>السؤال المطلوب: هل تيسير على المسار نحو 65%؟ وما الوضع الحالي والاتجاه؟</a:t>
             </a:r>
           </a:p>
           <a:p xmlns:a="http://schemas.openxmlformats.org/drawingml/2006/main">
@@ -578,7 +598,12 @@
           </a:p>
           <a:p xmlns:a="http://schemas.openxmlformats.org/drawingml/2006/main">
             <a:r>
-              <a:t>SAY: The chart shows monthly adoption from January 2022 to December 2025. The vertical scale runs from zero to one hundred percent. The orange line is the 65% target. The course average rose from 51.40% to 63.33%, an improvement of 11.93 percentage points. It is still 1.67 points below target. The data show progress but cannot tell us when the target will be reached.</a:t>
+              <a:t>قل أثناء العرض:</a:t>
+            </a:r>
+          </a:p>
+          <a:p xmlns:a="http://schemas.openxmlformats.org/drawingml/2006/main">
+            <a:r>
+              <a:t>ارتفع متوسط التبني من 51.40% في يناير 2022 إلى 63.33% في ديسمبر 2025؛ أي تحسن 11.93 نقطة مئوية. ما زلنا أقل من الهدف بـ1.67 نقطة. الخط البرتقالي يمثل هدف 65%، والمحور يبدأ من صفر. الاتجاه يتحسن، لكن البيانات لا تحدد متى سنصل للهدف.</a:t>
             </a:r>
           </a:p>
           <a:p xmlns:a="http://schemas.openxmlformats.org/drawingml/2006/main">
@@ -588,7 +613,12 @@
           </a:p>
           <a:p xmlns:a="http://schemas.openxmlformats.org/drawingml/2006/main">
             <a:r>
-              <a:t>IF ASKED: The main measure is a simple average of the supplied adoption percentages. It does not directly count digital transactions as a share of all transactions. Giving more weight to records with more transactions changes the result to 66.12%, above target. Agree the measure before any trial release. A percentage-point change means the difference between two percentages.</a:t>
+              <a:t>عند السؤال:</a:t>
+            </a:r>
+          </a:p>
+          <a:p xmlns:a="http://schemas.openxmlformats.org/drawingml/2006/main">
+            <a:r>
+              <a:t>المقياس الأساسي هو المتوسط البسيط لنسب التبني الموجودة في البيانات، وليس نسبة المعاملات الرقمية من جميع المعاملات. إذا أعطينا وزنًا أكبر للسجلات ذات المعاملات الأكثر، تصبح النتيجة 66.12%، فوق الهدف. لذلك يجب الاتفاق على المقياس قبل الصرف. النقطة المئوية هي الفرق بين نسبتين.</a:t>
             </a:r>
           </a:p>
           <a:p xmlns:a="http://schemas.openxmlformats.org/drawingml/2006/main">
@@ -598,27 +628,27 @@
           </a:p>
           <a:p xmlns:a="http://schemas.openxmlformats.org/drawingml/2006/main">
             <a:r>
-              <a:t>SOURCES</a:t>
-            </a:r>
-          </a:p>
-          <a:p xmlns:a="http://schemas.openxmlformats.org/drawingml/2006/main">
-            <a:r>
-              <a:t>Course CSV: https://drive.google.com/file/d/1T6pweFV4EjBxZ75gge775OOYMYx2aKX0/view</a:t>
-            </a:r>
-          </a:p>
-          <a:p xmlns:a="http://schemas.openxmlformats.org/drawingml/2006/main">
-            <a:r>
-              <a:t>Data definitions: https://drive.google.com/file/d/1htqVTYconACXDD28CACXOpz8VAyz8Xm5/view</a:t>
-            </a:r>
-          </a:p>
-          <a:p xmlns:a="http://schemas.openxmlformats.org/drawingml/2006/main">
-            <a:r>
-              <a:t>Course calculation reference: https://drive.google.com/file/d/1_DAzbKnnIl4dn1JN2hffwhCueJOoqPOh/view</a:t>
-            </a:r>
-          </a:p>
-          <a:p xmlns:a="http://schemas.openxmlformats.org/drawingml/2006/main">
-            <a:r>
-              <a:t>All data are synthetic.</a:t>
+              <a:t>المصادر:</a:t>
+            </a:r>
+          </a:p>
+          <a:p xmlns:a="http://schemas.openxmlformats.org/drawingml/2006/main">
+            <a:r>
+              <a:t>بيانات الدورة: https://drive.google.com/file/d/1T6pweFV4EjBxZ75gge775OOYMYx2aKX0/view</a:t>
+            </a:r>
+          </a:p>
+          <a:p xmlns:a="http://schemas.openxmlformats.org/drawingml/2006/main">
+            <a:r>
+              <a:t>تعريفات البيانات: https://drive.google.com/file/d/1htqVTYconACXDD28CACXOpz8VAyz8Xm5/view</a:t>
+            </a:r>
+          </a:p>
+          <a:p xmlns:a="http://schemas.openxmlformats.org/drawingml/2006/main">
+            <a:r>
+              <a:t>مرجع حسابات الدورة: https://drive.google.com/file/d/1_DAzbKnnIl4dn1JN2hffwhCueJOoqPOh/view</a:t>
+            </a:r>
+          </a:p>
+          <a:p xmlns:a="http://schemas.openxmlformats.org/drawingml/2006/main">
+            <a:r>
+              <a:t>جميع البيانات تدريبية اصطناعية.</a:t>
             </a:r>
           </a:p>
         </p:txBody>
@@ -688,7 +718,7 @@
           <a:lstStyle xmlns:a="http://schemas.openxmlformats.org/drawingml/2006/main"/>
           <a:p xmlns:a="http://schemas.openxmlformats.org/drawingml/2006/main">
             <a:r>
-              <a:t>REQUIRED QUESTION: Which regions are below 65%, and what is the gap?</a:t>
+              <a:t>السؤال المطلوب: ما المناطق الأقل من 65%؟ وما حجم الفجوة؟</a:t>
             </a:r>
           </a:p>
           <a:p xmlns:a="http://schemas.openxmlformats.org/drawingml/2006/main">
@@ -698,7 +728,12 @@
           </a:p>
           <a:p xmlns:a="http://schemas.openxmlformats.org/drawingml/2006/main">
             <a:r>
-              <a:t>SAY: Each bar shows a region's December 2025 adoption. The orange line marks 65%. Nine regions are below target: Najran, Al-Baha, Jazan, Northern Borders, Tabuk, Al-Jouf, Asir, Hail and Qassim. Najran has the lowest adoption, 58.89%, with a gap of 6.11 percentage points. Dark teal marks the three regions we propose for the first trials.</a:t>
+              <a:t>قل أثناء العرض:</a:t>
+            </a:r>
+          </a:p>
+          <a:p xmlns:a="http://schemas.openxmlformats.org/drawingml/2006/main">
+            <a:r>
+              <a:t>تسع مناطق أقل من الهدف: نجران، الباحة، جازان، الحدود الشمالية، تبوك، الجوف، عسير، حائل والقصيم. نجران الأقل عند 58.89%، بفجوة 6.11 نقطة. الخط البرتقالي هو هدف 65%. اللون الداكن يوضح المناطق الثلاث المقترحة للتجربة.</a:t>
             </a:r>
           </a:p>
           <a:p xmlns:a="http://schemas.openxmlformats.org/drawingml/2006/main">
@@ -708,7 +743,12 @@
           </a:p>
           <a:p xmlns:a="http://schemas.openxmlformats.org/drawingml/2006/main">
             <a:r>
-              <a:t>WHY THE COLORS: We highlight the proposed trial regions so the audience can follow the funding plan. We do not highlight every region below target.</a:t>
+              <a:t>عند السؤال عن التظليل:</a:t>
+            </a:r>
+          </a:p>
+          <a:p xmlns:a="http://schemas.openxmlformats.org/drawingml/2006/main">
+            <a:r>
+              <a:t>نظلل مناطق التجربة لتوضيح خطة التمويل؛ التظليل لا يعني جميع المناطق الأقل من الهدف.</a:t>
             </a:r>
           </a:p>
           <a:p xmlns:a="http://schemas.openxmlformats.org/drawingml/2006/main">
@@ -718,7 +758,12 @@
           </a:p>
           <a:p xmlns:a="http://schemas.openxmlformats.org/drawingml/2006/main">
             <a:r>
-              <a:t>WHY AL-BAHA IS NOT DARK TEAL: It has lower adoption than Jazan, but the selection also uses transaction activity. Al-Baha ranks fourth under our priority score. Slide 4 explains the score and the very small gap between third and fourth.</a:t>
+              <a:t>لماذا الباحة ليست مظللة؟</a:t>
+            </a:r>
+          </a:p>
+          <a:p xmlns:a="http://schemas.openxmlformats.org/drawingml/2006/main">
+            <a:r>
+              <a:t>الاختيار يجمع فجوة التبني وعدد المعاملات، وليس انخفاض التبني وحده. الباحة رابعة في درجة الأولوية، رغم أن تبنيها أقل من جازان. السلايد التالي يوضح الحساب والفارق البسيط بينها وبين الحدود الشمالية.</a:t>
             </a:r>
           </a:p>
           <a:p xmlns:a="http://schemas.openxmlformats.org/drawingml/2006/main">
@@ -728,27 +773,27 @@
           </a:p>
           <a:p xmlns:a="http://schemas.openxmlformats.org/drawingml/2006/main">
             <a:r>
-              <a:t>SOURCES</a:t>
-            </a:r>
-          </a:p>
-          <a:p xmlns:a="http://schemas.openxmlformats.org/drawingml/2006/main">
-            <a:r>
-              <a:t>Course CSV: https://drive.google.com/file/d/1T6pweFV4EjBxZ75gge775OOYMYx2aKX0/view</a:t>
-            </a:r>
-          </a:p>
-          <a:p xmlns:a="http://schemas.openxmlformats.org/drawingml/2006/main">
-            <a:r>
-              <a:t>Data definitions: https://drive.google.com/file/d/1htqVTYconACXDD28CACXOpz8VAyz8Xm5/view</a:t>
-            </a:r>
-          </a:p>
-          <a:p xmlns:a="http://schemas.openxmlformats.org/drawingml/2006/main">
-            <a:r>
-              <a:t>Course calculation reference: https://drive.google.com/file/d/1_DAzbKnnIl4dn1JN2hffwhCueJOoqPOh/view</a:t>
-            </a:r>
-          </a:p>
-          <a:p xmlns:a="http://schemas.openxmlformats.org/drawingml/2006/main">
-            <a:r>
-              <a:t>All data are synthetic.</a:t>
+              <a:t>المصادر:</a:t>
+            </a:r>
+          </a:p>
+          <a:p xmlns:a="http://schemas.openxmlformats.org/drawingml/2006/main">
+            <a:r>
+              <a:t>بيانات الدورة: https://drive.google.com/file/d/1T6pweFV4EjBxZ75gge775OOYMYx2aKX0/view</a:t>
+            </a:r>
+          </a:p>
+          <a:p xmlns:a="http://schemas.openxmlformats.org/drawingml/2006/main">
+            <a:r>
+              <a:t>تعريفات البيانات: https://drive.google.com/file/d/1htqVTYconACXDD28CACXOpz8VAyz8Xm5/view</a:t>
+            </a:r>
+          </a:p>
+          <a:p xmlns:a="http://schemas.openxmlformats.org/drawingml/2006/main">
+            <a:r>
+              <a:t>مرجع حسابات الدورة: https://drive.google.com/file/d/1_DAzbKnnIl4dn1JN2hffwhCueJOoqPOh/view</a:t>
+            </a:r>
+          </a:p>
+          <a:p xmlns:a="http://schemas.openxmlformats.org/drawingml/2006/main">
+            <a:r>
+              <a:t>جميع البيانات تدريبية اصطناعية.</a:t>
             </a:r>
           </a:p>
         </p:txBody>
@@ -818,7 +863,7 @@
           <a:lstStyle xmlns:a="http://schemas.openxmlformats.org/drawingml/2006/main"/>
           <a:p xmlns:a="http://schemas.openxmlformats.org/drawingml/2006/main">
             <a:r>
-              <a:t>REQUIRED QUESTION: Which regions are the biggest priorities, and what evidence supports them?</a:t>
+              <a:t>السؤال المطلوب: ما أكبر الأولويات؟ وما الدليل على الاختيار؟</a:t>
             </a:r>
           </a:p>
           <a:p xmlns:a="http://schemas.openxmlformats.org/drawingml/2006/main">
@@ -828,7 +873,12 @@
           </a:p>
           <a:p xmlns:a="http://schemas.openxmlformats.org/drawingml/2006/main">
             <a:r>
-              <a:t>SAY: We rank the nine regions below target using a priority score. Multiply the positive gap to 65 by December transactions, then divide by 100. Najran ranks first at 570.12, Jazan second at 455.08 and Northern Borders third at 446.26. These three have 42.61% of the total priority score for the nine regions below target.</a:t>
+              <a:t>قل أثناء العرض:</a:t>
+            </a:r>
+          </a:p>
+          <a:p xmlns:a="http://schemas.openxmlformats.org/drawingml/2006/main">
+            <a:r>
+              <a:t>درجة الأولوية تساوي الفجوة إلى 65% مقسومة على 100، ثم مضروبة في عدد معاملات ديسمبر. نجران أولًا بدرجة 570.12، ثم جازان 455.08، ثم الحدود الشمالية 446.26. هذه المناطق تمثل 42.61% من مجموع درجات المناطق التسع الأقل من الهدف. الداكن للمناطق المختارة، والبرتقالي للباحة كبديل قريب.</a:t>
             </a:r>
           </a:p>
           <a:p xmlns:a="http://schemas.openxmlformats.org/drawingml/2006/main">
@@ -838,7 +888,12 @@
           </a:p>
           <a:p xmlns:a="http://schemas.openxmlformats.org/drawingml/2006/main">
             <a:r>
-              <a:t>IMPORTANT LIMIT: 42.61% is a score share. It is not a share of users, transactions or budget. The score helps rank regions. It cannot predict extra digital transactions or investment returns.</a:t>
+              <a:t>عند السؤال:</a:t>
+            </a:r>
+          </a:p>
+          <a:p xmlns:a="http://schemas.openxmlformats.org/drawingml/2006/main">
+            <a:r>
+              <a:t>42.61% حصة من درجة الأولوية، وليست حصة من المستخدمين أو المعاملات أو الميزانية. الدرجة للترتيب فقط، ولا تتنبأ بعائد الاستثمار أو بمعاملات رقمية إضافية.</a:t>
             </a:r>
           </a:p>
           <a:p xmlns:a="http://schemas.openxmlformats.org/drawingml/2006/main">
@@ -848,7 +903,12 @@
           </a:p>
           <a:p xmlns:a="http://schemas.openxmlformats.org/drawingml/2006/main">
             <a:r>
-              <a:t>WHY AL-BAHA NEEDS A CHECK: Its score is 445.60, only about 0.66 below Northern Borders. This is almost a tie. Weighting adoption by transaction activity changes the top three to Najran, Northern Borders and Al-Baha, replacing Jazan. Confirm the measure and local service demand before funding.</a:t>
+              <a:t>لماذا نراجع الباحة؟</a:t>
+            </a:r>
+          </a:p>
+          <a:p xmlns:a="http://schemas.openxmlformats.org/drawingml/2006/main">
+            <a:r>
+              <a:t>درجتها 445.60؛ أقل من الحدود الشمالية بحوالي 0.66 فقط، أي شبه تعادل. عند وزن نسب التبني بالمعاملات، تحل الباحة بدل جازان. نتحقق من المقياس والطلب المحلي قبل التمويل.</a:t>
             </a:r>
           </a:p>
           <a:p xmlns:a="http://schemas.openxmlformats.org/drawingml/2006/main">
@@ -858,7 +918,12 @@
           </a:p>
           <a:p xmlns:a="http://schemas.openxmlformats.org/drawingml/2006/main">
             <a:r>
-              <a:t>IF ASKED ABOUT TABLEAU: This editable chart uses the supplied CSV and the workbook calculations. The original Day 2 dashboard was not supplied. The reconstructed workbook still needs actual opening and checking in Tableau.</a:t>
+              <a:t>عند السؤال عن تابلو:</a:t>
+            </a:r>
+          </a:p>
+          <a:p xmlns:a="http://schemas.openxmlformats.org/drawingml/2006/main">
+            <a:r>
+              <a:t>الرسم من ملف بيانات الدورة وحساباتنا. لوحة اليوم الثاني الأصلية لم تُرسل لنا؛ اللوحة المعاد بناؤها تحتاج فتحًا وفحصًا فعليًا في تابلو.</a:t>
             </a:r>
           </a:p>
           <a:p xmlns:a="http://schemas.openxmlformats.org/drawingml/2006/main">
@@ -868,27 +933,27 @@
           </a:p>
           <a:p xmlns:a="http://schemas.openxmlformats.org/drawingml/2006/main">
             <a:r>
-              <a:t>SOURCES</a:t>
-            </a:r>
-          </a:p>
-          <a:p xmlns:a="http://schemas.openxmlformats.org/drawingml/2006/main">
-            <a:r>
-              <a:t>Course CSV: https://drive.google.com/file/d/1T6pweFV4EjBxZ75gge775OOYMYx2aKX0/view</a:t>
-            </a:r>
-          </a:p>
-          <a:p xmlns:a="http://schemas.openxmlformats.org/drawingml/2006/main">
-            <a:r>
-              <a:t>Data definitions: https://drive.google.com/file/d/1htqVTYconACXDD28CACXOpz8VAyz8Xm5/view</a:t>
-            </a:r>
-          </a:p>
-          <a:p xmlns:a="http://schemas.openxmlformats.org/drawingml/2006/main">
-            <a:r>
-              <a:t>Course calculation reference: https://drive.google.com/file/d/1_DAzbKnnIl4dn1JN2hffwhCueJOoqPOh/view</a:t>
-            </a:r>
-          </a:p>
-          <a:p xmlns:a="http://schemas.openxmlformats.org/drawingml/2006/main">
-            <a:r>
-              <a:t>All data are synthetic.</a:t>
+              <a:t>المصادر:</a:t>
+            </a:r>
+          </a:p>
+          <a:p xmlns:a="http://schemas.openxmlformats.org/drawingml/2006/main">
+            <a:r>
+              <a:t>بيانات الدورة: https://drive.google.com/file/d/1T6pweFV4EjBxZ75gge775OOYMYx2aKX0/view</a:t>
+            </a:r>
+          </a:p>
+          <a:p xmlns:a="http://schemas.openxmlformats.org/drawingml/2006/main">
+            <a:r>
+              <a:t>تعريفات البيانات: https://drive.google.com/file/d/1htqVTYconACXDD28CACXOpz8VAyz8Xm5/view</a:t>
+            </a:r>
+          </a:p>
+          <a:p xmlns:a="http://schemas.openxmlformats.org/drawingml/2006/main">
+            <a:r>
+              <a:t>مرجع حسابات الدورة: https://drive.google.com/file/d/1_DAzbKnnIl4dn1JN2hffwhCueJOoqPOh/view</a:t>
+            </a:r>
+          </a:p>
+          <a:p xmlns:a="http://schemas.openxmlformats.org/drawingml/2006/main">
+            <a:r>
+              <a:t>جميع البيانات تدريبية اصطناعية.</a:t>
             </a:r>
           </a:p>
         </p:txBody>
@@ -958,7 +1023,7 @@
           <a:lstStyle xmlns:a="http://schemas.openxmlformats.org/drawingml/2006/main"/>
           <a:p xmlns:a="http://schemas.openxmlformats.org/drawingml/2006/main">
             <a:r>
-              <a:t>REQUIRED QUESTION: What are the realistic choices for using SAR 40 million?</a:t>
+              <a:t>السؤال المطلوب: ما الخيارات الواقعية لتوزيع 40 مليون ريال؟</a:t>
             </a:r>
           </a:p>
           <a:p xmlns:a="http://schemas.openxmlformats.org/drawingml/2006/main">
@@ -968,7 +1033,12 @@
           </a:p>
           <a:p xmlns:a="http://schemas.openxmlformats.org/drawingml/2006/main">
             <a:r>
-              <a:t>SAY: We compare three choices. Equal funding gives each of the nine regions about SAR 4.44 million, but ignores their different gaps and activity. Using all the money now focuses on three regions but spends the full budget before testing. Funding in steps sets aside SAR 35 million for regions and SAR 5 million for review. We choose this option. Release the first SAR 10 million after trial plan approval and hold SAR 30 million for review.</a:t>
+              <a:t>قل أثناء العرض:</a:t>
+            </a:r>
+          </a:p>
+          <a:p xmlns:a="http://schemas.openxmlformats.org/drawingml/2006/main">
+            <a:r>
+              <a:t>لدينا ثلاثة خيارات: توزيع متساوٍ، حوالي 4.44 مليون لكل منطقة من التسع؛ لكنه يتجاهل اختلاف الفجوات والنشاط. أو صرف الأربعين مليون كلها في المناطق الثلاث مباشرة؛ لكنه يصرف قبل الاختبار. نوصي بالصرف على مراحل: 35 مليون للمناطق و5 ملايين للمراجعة والاحتياط. نبدأ بعشرة ملايين بعد اعتماد خطة التجربة، ونحتفظ بثلاثين مليون.</a:t>
             </a:r>
           </a:p>
           <a:p xmlns:a="http://schemas.openxmlformats.org/drawingml/2006/main">
@@ -978,7 +1048,12 @@
           </a:p>
           <a:p xmlns:a="http://schemas.openxmlformats.org/drawingml/2006/main">
             <a:r>
-              <a:t>IF ASKED WHY: The region ranking can change with the measure, and the data do not show what return the money will produce. Small trials give us evidence before a larger release.</a:t>
+              <a:t>عند السؤال لماذا هذا الخيار:</a:t>
+            </a:r>
+          </a:p>
+          <a:p xmlns:a="http://schemas.openxmlformats.org/drawingml/2006/main">
+            <a:r>
+              <a:t>الترتيب قد يتغير حسب المقياس، ولا نعرف عائد التمويل من هذه البيانات. التجربة تعطينا دليلًا قبل صرف المزيد.</a:t>
             </a:r>
           </a:p>
           <a:p xmlns:a="http://schemas.openxmlformats.org/drawingml/2006/main">
@@ -988,27 +1063,27 @@
           </a:p>
           <a:p xmlns:a="http://schemas.openxmlformats.org/drawingml/2006/main">
             <a:r>
-              <a:t>SOURCES</a:t>
-            </a:r>
-          </a:p>
-          <a:p xmlns:a="http://schemas.openxmlformats.org/drawingml/2006/main">
-            <a:r>
-              <a:t>Course CSV: https://drive.google.com/file/d/1T6pweFV4EjBxZ75gge775OOYMYx2aKX0/view</a:t>
-            </a:r>
-          </a:p>
-          <a:p xmlns:a="http://schemas.openxmlformats.org/drawingml/2006/main">
-            <a:r>
-              <a:t>Data definitions: https://drive.google.com/file/d/1htqVTYconACXDD28CACXOpz8VAyz8Xm5/view</a:t>
-            </a:r>
-          </a:p>
-          <a:p xmlns:a="http://schemas.openxmlformats.org/drawingml/2006/main">
-            <a:r>
-              <a:t>Course calculation reference: https://drive.google.com/file/d/1_DAzbKnnIl4dn1JN2hffwhCueJOoqPOh/view</a:t>
-            </a:r>
-          </a:p>
-          <a:p xmlns:a="http://schemas.openxmlformats.org/drawingml/2006/main">
-            <a:r>
-              <a:t>All data are synthetic.</a:t>
+              <a:t>المصادر:</a:t>
+            </a:r>
+          </a:p>
+          <a:p xmlns:a="http://schemas.openxmlformats.org/drawingml/2006/main">
+            <a:r>
+              <a:t>بيانات الدورة: https://drive.google.com/file/d/1T6pweFV4EjBxZ75gge775OOYMYx2aKX0/view</a:t>
+            </a:r>
+          </a:p>
+          <a:p xmlns:a="http://schemas.openxmlformats.org/drawingml/2006/main">
+            <a:r>
+              <a:t>تعريفات البيانات: https://drive.google.com/file/d/1htqVTYconACXDD28CACXOpz8VAyz8Xm5/view</a:t>
+            </a:r>
+          </a:p>
+          <a:p xmlns:a="http://schemas.openxmlformats.org/drawingml/2006/main">
+            <a:r>
+              <a:t>مرجع حسابات الدورة: https://drive.google.com/file/d/1_DAzbKnnIl4dn1JN2hffwhCueJOoqPOh/view</a:t>
+            </a:r>
+          </a:p>
+          <a:p xmlns:a="http://schemas.openxmlformats.org/drawingml/2006/main">
+            <a:r>
+              <a:t>جميع البيانات تدريبية اصطناعية.</a:t>
             </a:r>
           </a:p>
         </p:txBody>
@@ -1078,7 +1153,7 @@
           <a:lstStyle xmlns:a="http://schemas.openxmlformats.org/drawingml/2006/main"/>
           <a:p xmlns:a="http://schemas.openxmlformats.org/drawingml/2006/main">
             <a:r>
-              <a:t>REQUIRED QUESTION: Which option and regions do we recommend, why, and what effect can we show?</a:t>
+              <a:t>السؤال المطلوب: ما التوصية؟ ولماذا؟ وما الأثر الذي نستطيع توضيحه؟</a:t>
             </a:r>
           </a:p>
           <a:p xmlns:a="http://schemas.openxmlformats.org/drawingml/2006/main">
@@ -1088,7 +1163,12 @@
           </a:p>
           <a:p xmlns:a="http://schemas.openxmlformats.org/drawingml/2006/main">
             <a:r>
-              <a:t>SAY: We recommend funding in steps. The proposed budgets are SAR 13 million for Najran, SAR 11 million each for Jazan and Northern Borders, and SAR 5 million for review and reserve. We split the regional SAR 35 million in proportion to the priority scores and round to whole millions. These are proposed budgets, so we must check local costs.</a:t>
+              <a:t>قل أثناء العرض:</a:t>
+            </a:r>
+          </a:p>
+          <a:p xmlns:a="http://schemas.openxmlformats.org/drawingml/2006/main">
+            <a:r>
+              <a:t>نوصي بالصرف على مراحل: 13 مليون لنجران، و11 مليون لجازان، و11 مليون للحدود الشمالية، و5 ملايين للمراجعة والاحتياط. وزعنا ميزانية المناطق بحسب درجات الأولوية وقربناها لملايين كاملة. المبالغ مقترحة وتحتاج تحققًا من التكاليف.</a:t>
             </a:r>
           </a:p>
           <a:p xmlns:a="http://schemas.openxmlformats.org/drawingml/2006/main">
@@ -1098,7 +1178,12 @@
           </a:p>
           <a:p xmlns:a="http://schemas.openxmlformats.org/drawingml/2006/main">
             <a:r>
-              <a:t>EXPLAIN 64.45%: If these three regions reach 65% and all other regions stay unchanged, the national course average becomes 64.45%. It still falls below 65%. This is an example based on those conditions. It does not predict the effect of SAR 40 million.</a:t>
+              <a:t>كيف أشرح 64.45%؟</a:t>
+            </a:r>
+          </a:p>
+          <a:p xmlns:a="http://schemas.openxmlformats.org/drawingml/2006/main">
+            <a:r>
+              <a:t>إذا وصلت المناطق الثلاث إلى 65% وبقيت بقية المناطق كما هي، يصبح المتوسط الوطني 64.45%؛ ويظل أقل من الهدف. هذا مثال حسابي مشروط، وليس توقعًا لنتيجة صرف الميزانية.</a:t>
             </a:r>
           </a:p>
           <a:p xmlns:a="http://schemas.openxmlformats.org/drawingml/2006/main">
@@ -1108,7 +1193,12 @@
           </a:p>
           <a:p xmlns:a="http://schemas.openxmlformats.org/drawingml/2006/main">
             <a:r>
-              <a:t>IF ASKED: We round each regional amount down first, then give the remaining millions to the largest decimal parts. This keeps the total at 40 million. The first 10 million splits into 3.72 million for Najran and 3.14 million each for Jazan and Northern Borders. Possible trial work includes helping users sign up or removing steps that delay services. Check the actual barriers before choosing a service plan.</a:t>
+              <a:t>عند السؤال عن التقريب:</a:t>
+            </a:r>
+          </a:p>
+          <a:p xmlns:a="http://schemas.openxmlformats.org/drawingml/2006/main">
+            <a:r>
+              <a:t>نقرب مبالغ المناطق للأسفل أولًا، ثم نعطي الملايين المتبقية لأكبر الأجزاء العشرية؛ ليظل الإجمالي 40 مليونًا.</a:t>
             </a:r>
           </a:p>
           <a:p xmlns:a="http://schemas.openxmlformats.org/drawingml/2006/main">
@@ -1118,27 +1208,42 @@
           </a:p>
           <a:p xmlns:a="http://schemas.openxmlformats.org/drawingml/2006/main">
             <a:r>
-              <a:t>SOURCES</a:t>
-            </a:r>
-          </a:p>
-          <a:p xmlns:a="http://schemas.openxmlformats.org/drawingml/2006/main">
-            <a:r>
-              <a:t>Course CSV: https://drive.google.com/file/d/1T6pweFV4EjBxZ75gge775OOYMYx2aKX0/view</a:t>
-            </a:r>
-          </a:p>
-          <a:p xmlns:a="http://schemas.openxmlformats.org/drawingml/2006/main">
-            <a:r>
-              <a:t>Data definitions: https://drive.google.com/file/d/1htqVTYconACXDD28CACXOpz8VAyz8Xm5/view</a:t>
-            </a:r>
-          </a:p>
-          <a:p xmlns:a="http://schemas.openxmlformats.org/drawingml/2006/main">
-            <a:r>
-              <a:t>Course calculation reference: https://drive.google.com/file/d/1_DAzbKnnIl4dn1JN2hffwhCueJOoqPOh/view</a:t>
-            </a:r>
-          </a:p>
-          <a:p xmlns:a="http://schemas.openxmlformats.org/drawingml/2006/main">
-            <a:r>
-              <a:t>All data are synthetic.</a:t>
+              <a:t>عند السؤال عن أول عشرة ملايين:</a:t>
+            </a:r>
+          </a:p>
+          <a:p xmlns:a="http://schemas.openxmlformats.org/drawingml/2006/main">
+            <a:r>
+              <a:t>3.72 مليون لنجران، و3.14 مليون لكل من جازان والحدود الشمالية. يمكن اختبار مساعدة المستخدمين في التسجيل أو تقليل خطوات الخدمة، بعد التأكد من العوائق الفعلية.</a:t>
+            </a:r>
+          </a:p>
+          <a:p xmlns:a="http://schemas.openxmlformats.org/drawingml/2006/main">
+            <a:r>
+              <a:t/>
+            </a:r>
+          </a:p>
+          <a:p xmlns:a="http://schemas.openxmlformats.org/drawingml/2006/main">
+            <a:r>
+              <a:t>المصادر:</a:t>
+            </a:r>
+          </a:p>
+          <a:p xmlns:a="http://schemas.openxmlformats.org/drawingml/2006/main">
+            <a:r>
+              <a:t>بيانات الدورة: https://drive.google.com/file/d/1T6pweFV4EjBxZ75gge775OOYMYx2aKX0/view</a:t>
+            </a:r>
+          </a:p>
+          <a:p xmlns:a="http://schemas.openxmlformats.org/drawingml/2006/main">
+            <a:r>
+              <a:t>تعريفات البيانات: https://drive.google.com/file/d/1htqVTYconACXDD28CACXOpz8VAyz8Xm5/view</a:t>
+            </a:r>
+          </a:p>
+          <a:p xmlns:a="http://schemas.openxmlformats.org/drawingml/2006/main">
+            <a:r>
+              <a:t>مرجع حسابات الدورة: https://drive.google.com/file/d/1_DAzbKnnIl4dn1JN2hffwhCueJOoqPOh/view</a:t>
+            </a:r>
+          </a:p>
+          <a:p xmlns:a="http://schemas.openxmlformats.org/drawingml/2006/main">
+            <a:r>
+              <a:t>جميع البيانات تدريبية اصطناعية.</a:t>
             </a:r>
           </a:p>
         </p:txBody>
@@ -1208,7 +1313,7 @@
           <a:lstStyle xmlns:a="http://schemas.openxmlformats.org/drawingml/2006/main"/>
           <a:p xmlns:a="http://schemas.openxmlformats.org/drawingml/2006/main">
             <a:r>
-              <a:t>REQUIRED QUESTION: What exactly should the decision-maker approve and do next?</a:t>
+              <a:t>السؤال المطلوب: ما الموافقة المطلوبة بالضبط؟ وما الخطوة التالية؟</a:t>
             </a:r>
           </a:p>
           <a:p xmlns:a="http://schemas.openxmlformats.org/drawingml/2006/main">
@@ -1218,7 +1323,12 @@
           </a:p>
           <a:p xmlns:a="http://schemas.openxmlformats.org/drawingml/2006/main">
             <a:r>
-              <a:t>SAY: Please approve the SAR 40 million plan. Release the first SAR 10 million only after trial plan approval, and hold SAR 30 million. At budget approval, choose a lead. Before any release or service change, agree the adoption measure, collect starting data, choose a fair comparison, check the region selection and approve service plans and costs. Start within thirty days only if ready.</a:t>
+              <a:t>قل أثناء العرض:</a:t>
+            </a:r>
+          </a:p>
+          <a:p xmlns:a="http://schemas.openxmlformats.org/drawingml/2006/main">
+            <a:r>
+              <a:t>نطلب اعتماد خطة الأربعين مليون. نصرف أول عشرة ملايين بعد اعتماد خطة التجربة، ونحتفظ بثلاثين مليون. عند اعتماد الميزانية نحدد المسؤول. قبل الصرف أو تغيير الخدمات نتفق على المقياس، ونجمع بيانات البداية، ونضع مقارنة عادلة، ونتحقق من المناطق والخطط والتكاليف. نبدأ خلال 30 يومًا إذا اكتملت الجاهزية.</a:t>
             </a:r>
           </a:p>
           <a:p xmlns:a="http://schemas.openxmlformats.org/drawingml/2006/main">
@@ -1228,7 +1338,12 @@
           </a:p>
           <a:p xmlns:a="http://schemas.openxmlformats.org/drawingml/2006/main">
             <a:r>
-              <a:t>CHECKPOINT: Review results and costs at day ninety from budget approval. Record how long the trials actually ran. Extend the review if that time is too short. A gain of two percentage points, with steady customer satisfaction and service quality, is a proposed goal. It is not a promised result. Pause later releases if evidence is weak.</a:t>
+              <a:t>المراجعة:</a:t>
+            </a:r>
+          </a:p>
+          <a:p xmlns:a="http://schemas.openxmlformats.org/drawingml/2006/main">
+            <a:r>
+              <a:t>في اليوم 90 من اعتماد الميزانية نراجع النتائج والتكاليف قبل أي صرف لاحق. نسجل مدة تشغيل التجربة فعليًا، ونمدد المراجعة إذا كانت المدة قصيرة. هدف التحسن نقطتان مئويتان مع ثبات رضا العملاء وجودة الخدمة؛ هذا هدف مقترح وليس وعدًا. نوقف الصرف اللاحق إذا كان الدليل ضعيفًا.</a:t>
             </a:r>
           </a:p>
           <a:p xmlns:a="http://schemas.openxmlformats.org/drawingml/2006/main">
@@ -1238,7 +1353,12 @@
           </a:p>
           <a:p xmlns:a="http://schemas.openxmlformats.org/drawingml/2006/main">
             <a:r>
-              <a:t>SIMPLE TERMS: Starting data means the values before the trial. A fair comparison helps check whether a change came from the trial or from other factors.</a:t>
+              <a:t>عند السؤال:</a:t>
+            </a:r>
+          </a:p>
+          <a:p xmlns:a="http://schemas.openxmlformats.org/drawingml/2006/main">
+            <a:r>
+              <a:t>بيانات البداية هي القيم قبل التجربة. المقارنة العادلة تساعدنا على التمييز بين أثر التجربة وأثر عوامل أخرى.</a:t>
             </a:r>
           </a:p>
           <a:p xmlns:a="http://schemas.openxmlformats.org/drawingml/2006/main">
@@ -1248,27 +1368,27 @@
           </a:p>
           <a:p xmlns:a="http://schemas.openxmlformats.org/drawingml/2006/main">
             <a:r>
-              <a:t>SOURCES</a:t>
-            </a:r>
-          </a:p>
-          <a:p xmlns:a="http://schemas.openxmlformats.org/drawingml/2006/main">
-            <a:r>
-              <a:t>Course CSV: https://drive.google.com/file/d/1T6pweFV4EjBxZ75gge775OOYMYx2aKX0/view</a:t>
-            </a:r>
-          </a:p>
-          <a:p xmlns:a="http://schemas.openxmlformats.org/drawingml/2006/main">
-            <a:r>
-              <a:t>Data definitions: https://drive.google.com/file/d/1htqVTYconACXDD28CACXOpz8VAyz8Xm5/view</a:t>
-            </a:r>
-          </a:p>
-          <a:p xmlns:a="http://schemas.openxmlformats.org/drawingml/2006/main">
-            <a:r>
-              <a:t>Course calculation reference: https://drive.google.com/file/d/1_DAzbKnnIl4dn1JN2hffwhCueJOoqPOh/view</a:t>
-            </a:r>
-          </a:p>
-          <a:p xmlns:a="http://schemas.openxmlformats.org/drawingml/2006/main">
-            <a:r>
-              <a:t>All data are synthetic.</a:t>
+              <a:t>المصادر:</a:t>
+            </a:r>
+          </a:p>
+          <a:p xmlns:a="http://schemas.openxmlformats.org/drawingml/2006/main">
+            <a:r>
+              <a:t>بيانات الدورة: https://drive.google.com/file/d/1T6pweFV4EjBxZ75gge775OOYMYx2aKX0/view</a:t>
+            </a:r>
+          </a:p>
+          <a:p xmlns:a="http://schemas.openxmlformats.org/drawingml/2006/main">
+            <a:r>
+              <a:t>تعريفات البيانات: https://drive.google.com/file/d/1htqVTYconACXDD28CACXOpz8VAyz8Xm5/view</a:t>
+            </a:r>
+          </a:p>
+          <a:p xmlns:a="http://schemas.openxmlformats.org/drawingml/2006/main">
+            <a:r>
+              <a:t>مرجع حسابات الدورة: https://drive.google.com/file/d/1_DAzbKnnIl4dn1JN2hffwhCueJOoqPOh/view</a:t>
+            </a:r>
+          </a:p>
+          <a:p xmlns:a="http://schemas.openxmlformats.org/drawingml/2006/main">
+            <a:r>
+              <a:t>جميع البيانات تدريبية اصطناعية.</a:t>
             </a:r>
           </a:p>
         </p:txBody>
@@ -1336,7 +1456,7 @@
   </p:cSld>
   <p:clrMap bg1="lt1" tx1="dk1" bg2="lt2" tx2="dk2" accent1="accent1" accent2="accent2" accent3="accent3" accent4="accent4" accent5="accent5" accent6="accent6" hlink="hlink" folHlink="folHlink"/>
   <p:sldLayoutIdLst>
-    <p:sldLayoutId xmlns:r="http://schemas.openxmlformats.org/officeDocument/2006/relationships" id="2147483649" r:id="Rd60fa1391170443b"/>
+    <p:sldLayoutId xmlns:r="http://schemas.openxmlformats.org/officeDocument/2006/relationships" id="2147483649" r:id="Rfde2dd1793e34614"/>
   </p:sldLayoutIdLst>
   <p:txStyles>
     <p:titleStyle>
@@ -5416,7 +5536,7 @@
         </p:xfrm>
         <a:graphic xmlns:a="http://schemas.openxmlformats.org/drawingml/2006/main">
           <a:graphicData uri="http://schemas.openxmlformats.org/drawingml/2006/chart">
-            <c:chart xmlns:r="http://schemas.openxmlformats.org/officeDocument/2006/relationships" xmlns:c="http://schemas.openxmlformats.org/drawingml/2006/chart" r:id="R51e1efa725604f21"/>
+            <c:chart xmlns:r="http://schemas.openxmlformats.org/officeDocument/2006/relationships" xmlns:c="http://schemas.openxmlformats.org/drawingml/2006/chart" r:id="R207862d0300849b7"/>
           </a:graphicData>
         </a:graphic>
       </p:graphicFrame>
@@ -5625,7 +5745,7 @@
       </p:sp>
       <p:graphicFrame>
         <p:nvGraphicFramePr>
-          <p:cNvPr id="14" name="Chart"/>
+          <p:cNvPr id="17" name="Chart"/>
           <p:cNvGraphicFramePr/>
           <p:nvPr/>
         </p:nvGraphicFramePr>
@@ -5635,16 +5755,16 @@
         </p:xfrm>
         <a:graphic xmlns:a="http://schemas.openxmlformats.org/drawingml/2006/main">
           <a:graphicData uri="http://schemas.openxmlformats.org/drawingml/2006/chart">
-            <c:chart xmlns:r="http://schemas.openxmlformats.org/officeDocument/2006/relationships" xmlns:c="http://schemas.openxmlformats.org/drawingml/2006/chart" r:id="R0a7d9a121c2147e5"/>
+            <c:chart xmlns:r="http://schemas.openxmlformats.org/officeDocument/2006/relationships" xmlns:c="http://schemas.openxmlformats.org/drawingml/2006/chart" r:id="R0ce5e154f6e04a59"/>
           </a:graphicData>
         </a:graphic>
       </p:graphicFrame>
       <p:sp>
         <p:nvSpPr>
-          <p:cNvPr id="9" name="">
+          <p:cNvPr id="12" name="">
             <a:extLst xmlns:a="http://schemas.openxmlformats.org/drawingml/2006/main">
               <a:ext uri="{FF2B5EF4-FFF2-40B4-BE49-F238E27FC236}">
-                <a16:creationId xmlns:a16="http://schemas.microsoft.com/office/drawing/2014/main" id="{9D556D53-5D07-40F9-96F0-7848D7327CB7}"/>
+                <a16:creationId xmlns:a16="http://schemas.microsoft.com/office/drawing/2014/main" id="{404714D3-3E63-4B56-8B9F-68FD39ABE57D}"/>
               </a:ext>
             </a:extLst>
           </p:cNvPr>
@@ -5671,10 +5791,10 @@
       </p:sp>
       <p:sp>
         <p:nvSpPr>
-          <p:cNvPr id="10" name="">
+          <p:cNvPr id="13" name="">
             <a:extLst xmlns:a="http://schemas.openxmlformats.org/drawingml/2006/main">
               <a:ext uri="{FF2B5EF4-FFF2-40B4-BE49-F238E27FC236}">
-                <a16:creationId xmlns:a16="http://schemas.microsoft.com/office/drawing/2014/main" id="{BA3BFDCF-3DE2-4A56-B4BD-0ACC636EC3BD}"/>
+                <a16:creationId xmlns:a16="http://schemas.microsoft.com/office/drawing/2014/main" id="{224EB86B-7286-46A1-95EF-B3BE41F197BD}"/>
               </a:ext>
             </a:extLst>
           </p:cNvPr>
@@ -6397,7 +6517,7 @@
         </p:xfrm>
         <a:graphic xmlns:a="http://schemas.openxmlformats.org/drawingml/2006/main">
           <a:graphicData uri="http://schemas.openxmlformats.org/drawingml/2006/chart">
-            <c:chart xmlns:r="http://schemas.openxmlformats.org/officeDocument/2006/relationships" xmlns:c="http://schemas.openxmlformats.org/drawingml/2006/chart" r:id="R8a59a4b53cdd4d58"/>
+            <c:chart xmlns:r="http://schemas.openxmlformats.org/officeDocument/2006/relationships" xmlns:c="http://schemas.openxmlformats.org/drawingml/2006/chart" r:id="R7f7e502dc10f4f8f"/>
           </a:graphicData>
         </a:graphic>
       </p:graphicFrame>

</xml_diff>